<commit_message>
docs: update observability portal executive deck and remove outdated version
</commit_message>
<xml_diff>
--- a/docs/ui-ux-design/diagrams/observability-portal-exec-deck.pptx
+++ b/docs/ui-ux-design/diagrams/observability-portal-exec-deck.pptx
@@ -10,6 +10,7 @@
     <p:sldId id="258" r:id="rId9"/>
     <p:sldId id="259" r:id="rId10"/>
     <p:sldId id="260" r:id="rId11"/>
+    <p:sldId id="261" r:id="rId12"/>
   </p:sldIdLst>
   <p:sldSz cx="12191695" cy="6858000" type="screen4x3"/>
   <p:notesSz cx="6858000" cy="9144000"/>
@@ -6504,7 +6505,7 @@
         <p:spPr>
           <a:xfrm>
             <a:off x="548640" y="640080"/>
-            <a:ext cx="11064240" cy="548640"/>
+            <a:ext cx="11064240" cy="502920"/>
           </a:xfrm>
           <a:prstGeom prst="rect">
             <a:avLst/>
@@ -6523,7 +6524,7 @@
               </a:spcAft>
             </a:pPr>
             <a:r>
-              <a:rPr sz="2600" b="1">
+              <a:rPr sz="2400" b="1">
                 <a:solidFill>
                   <a:srgbClr val="1B2A41"/>
                 </a:solidFill>
@@ -6542,7 +6543,7 @@
         </p:nvSpPr>
         <p:spPr>
           <a:xfrm>
-            <a:off x="566928" y="1261872"/>
+            <a:off x="566928" y="1207008"/>
             <a:ext cx="914400" cy="32004"/>
           </a:xfrm>
           <a:prstGeom prst="rect">
@@ -6586,8 +6587,8 @@
         </p:nvSpPr>
         <p:spPr>
           <a:xfrm>
-            <a:off x="548640" y="1371600"/>
-            <a:ext cx="11064240" cy="365760"/>
+            <a:off x="548640" y="1316736"/>
+            <a:ext cx="11064240" cy="292608"/>
           </a:xfrm>
           <a:prstGeom prst="rect">
             <a:avLst/>
@@ -6612,7 +6613,7 @@
                 </a:solidFill>
                 <a:latin typeface="Segoe UI"/>
               </a:rPr>
-              <a:t>One pipeline from request to activation — one config repo per tool, one neutral request format, per-tool translators. Nothing reaches a platform service that is not in git first.</a:t>
+              <a:t>One governed pipeline, two feedback loops, one oracle — nothing reaches a platform service that is not in git first.</a:t>
             </a:r>
           </a:p>
         </p:txBody>
@@ -6625,8 +6626,8 @@
         </p:nvSpPr>
         <p:spPr>
           <a:xfrm>
-            <a:off x="548640" y="2743200"/>
-            <a:ext cx="1097280" cy="960120"/>
+            <a:off x="548640" y="2331720"/>
+            <a:ext cx="822960" cy="868680"/>
           </a:xfrm>
           <a:prstGeom prst="rect">
             <a:avLst/>
@@ -6669,27 +6670,27 @@
         </p:nvSpPr>
         <p:spPr>
           <a:xfrm>
-            <a:off x="640080" y="2926080"/>
-            <a:ext cx="914400" cy="640080"/>
-          </a:xfrm>
-          <a:prstGeom prst="rect">
-            <a:avLst/>
-          </a:prstGeom>
-          <a:noFill/>
-        </p:spPr>
-        <p:txBody>
-          <a:bodyPr wrap="square" anchor="t" lIns="0" rIns="0" tIns="0" bIns="0">
-            <a:spAutoFit/>
-          </a:bodyPr>
-          <a:lstStyle/>
-          <a:p>
-            <a:pPr algn="l">
-              <a:spcAft>
-                <a:spcPts val="100"/>
-              </a:spcAft>
-            </a:pPr>
-            <a:r>
-              <a:rPr sz="1150" b="1">
+            <a:off x="621792" y="2505456"/>
+            <a:ext cx="676656" cy="548640"/>
+          </a:xfrm>
+          <a:prstGeom prst="rect">
+            <a:avLst/>
+          </a:prstGeom>
+          <a:noFill/>
+        </p:spPr>
+        <p:txBody>
+          <a:bodyPr wrap="square" anchor="t" lIns="0" rIns="0" tIns="0" bIns="0">
+            <a:spAutoFit/>
+          </a:bodyPr>
+          <a:lstStyle/>
+          <a:p>
+            <a:pPr algn="l">
+              <a:spcAft>
+                <a:spcPts val="0"/>
+              </a:spcAft>
+            </a:pPr>
+            <a:r>
+              <a:rPr sz="1050" b="1">
                 <a:solidFill>
                   <a:srgbClr val="FFFFFF"/>
                 </a:solidFill>
@@ -6701,11 +6702,11 @@
           <a:p>
             <a:pPr algn="l">
               <a:spcAft>
-                <a:spcPts val="100"/>
-              </a:spcAft>
-            </a:pPr>
-            <a:r>
-              <a:rPr sz="850" b="0">
+                <a:spcPts val="0"/>
+              </a:spcAft>
+            </a:pPr>
+            <a:r>
+              <a:rPr sz="750" b="0">
                 <a:solidFill>
                   <a:srgbClr val="C9D2DD"/>
                 </a:solidFill>
@@ -6724,8 +6725,8 @@
         </p:nvSpPr>
         <p:spPr>
           <a:xfrm>
-            <a:off x="1682496" y="3108960"/>
-            <a:ext cx="274320" cy="219456"/>
+            <a:off x="1408176" y="2651760"/>
+            <a:ext cx="237744" cy="201168"/>
           </a:xfrm>
           <a:prstGeom prst="rightArrow">
             <a:avLst/>
@@ -6768,91 +6769,8 @@
         </p:nvSpPr>
         <p:spPr>
           <a:xfrm>
-            <a:off x="1993392" y="1874519"/>
-            <a:ext cx="2468880" cy="2697480"/>
-          </a:xfrm>
-          <a:prstGeom prst="rect">
-            <a:avLst/>
-          </a:prstGeom>
-          <a:solidFill>
-            <a:srgbClr val="F4F6F8"/>
-          </a:solidFill>
-          <a:ln>
-            <a:noFill/>
-          </a:ln>
-          <a:effectLst/>
-        </p:spPr>
-        <p:style>
-          <a:lnRef idx="1">
-            <a:schemeClr val="accent1"/>
-          </a:lnRef>
-          <a:fillRef idx="3">
-            <a:schemeClr val="accent1"/>
-          </a:fillRef>
-          <a:effectRef idx="2">
-            <a:schemeClr val="accent1"/>
-          </a:effectRef>
-          <a:fontRef idx="minor">
-            <a:schemeClr val="lt1"/>
-          </a:fontRef>
-        </p:style>
-        <p:txBody>
-          <a:bodyPr rtlCol="0" anchor="ctr"/>
-          <a:lstStyle/>
-          <a:p>
-            <a:pPr algn="ctr"/>
-          </a:p>
-        </p:txBody>
-      </p:sp>
-      <p:sp>
-        <p:nvSpPr>
-          <p:cNvPr id="10" name="TextBox 9"/>
-          <p:cNvSpPr txBox="1"/>
-          <p:nvPr/>
-        </p:nvSpPr>
-        <p:spPr>
-          <a:xfrm>
-            <a:off x="2112264" y="1965960"/>
-            <a:ext cx="2231136" cy="237744"/>
-          </a:xfrm>
-          <a:prstGeom prst="rect">
-            <a:avLst/>
-          </a:prstGeom>
-          <a:noFill/>
-        </p:spPr>
-        <p:txBody>
-          <a:bodyPr wrap="square" anchor="t" lIns="0" rIns="0" tIns="0" bIns="0">
-            <a:spAutoFit/>
-          </a:bodyPr>
-          <a:lstStyle/>
-          <a:p>
-            <a:pPr algn="l">
-              <a:spcAft>
-                <a:spcPts val="400"/>
-              </a:spcAft>
-            </a:pPr>
-            <a:r>
-              <a:rPr sz="900" b="1">
-                <a:solidFill>
-                  <a:srgbClr val="7A808A"/>
-                </a:solidFill>
-                <a:latin typeface="Segoe UI"/>
-              </a:rPr>
-              <a:t>BACKSTAGE — USER LAYER</a:t>
-            </a:r>
-          </a:p>
-        </p:txBody>
-      </p:sp>
-      <p:sp>
-        <p:nvSpPr>
-          <p:cNvPr id="11" name="Rectangle 10"/>
-          <p:cNvSpPr/>
-          <p:nvPr/>
-        </p:nvSpPr>
-        <p:spPr>
-          <a:xfrm>
-            <a:off x="2112264" y="2231136"/>
-            <a:ext cx="2231136" cy="1051560"/>
+            <a:off x="1682496" y="1828800"/>
+            <a:ext cx="2788920" cy="1874519"/>
           </a:xfrm>
           <a:prstGeom prst="rect">
             <a:avLst/>
@@ -6891,78 +6809,315 @@
       </p:sp>
       <p:sp>
         <p:nvSpPr>
+          <p:cNvPr id="10" name="Rectangle 9"/>
+          <p:cNvSpPr/>
+          <p:nvPr/>
+        </p:nvSpPr>
+        <p:spPr>
+          <a:xfrm>
+            <a:off x="1682496" y="1828800"/>
+            <a:ext cx="2788920" cy="45720"/>
+          </a:xfrm>
+          <a:prstGeom prst="rect">
+            <a:avLst/>
+          </a:prstGeom>
+          <a:solidFill>
+            <a:srgbClr val="36BAA2"/>
+          </a:solidFill>
+          <a:ln>
+            <a:noFill/>
+          </a:ln>
+          <a:effectLst/>
+        </p:spPr>
+        <p:style>
+          <a:lnRef idx="1">
+            <a:schemeClr val="accent1"/>
+          </a:lnRef>
+          <a:fillRef idx="3">
+            <a:schemeClr val="accent1"/>
+          </a:fillRef>
+          <a:effectRef idx="2">
+            <a:schemeClr val="accent1"/>
+          </a:effectRef>
+          <a:fontRef idx="minor">
+            <a:schemeClr val="lt1"/>
+          </a:fontRef>
+        </p:style>
+        <p:txBody>
+          <a:bodyPr rtlCol="0" anchor="ctr"/>
+          <a:lstStyle/>
+          <a:p>
+            <a:pPr algn="ctr"/>
+          </a:p>
+        </p:txBody>
+      </p:sp>
+      <p:sp>
+        <p:nvSpPr>
+          <p:cNvPr id="11" name="Rounded Rectangle 10"/>
+          <p:cNvSpPr/>
+          <p:nvPr/>
+        </p:nvSpPr>
+        <p:spPr>
+          <a:xfrm>
+            <a:off x="1810512" y="1975104"/>
+            <a:ext cx="237744" cy="237744"/>
+          </a:xfrm>
+          <a:prstGeom prst="roundRect">
+            <a:avLst>
+              <a:gd name="adj" fmla="val 25000"/>
+            </a:avLst>
+          </a:prstGeom>
+          <a:solidFill>
+            <a:srgbClr val="36BAA2"/>
+          </a:solidFill>
+          <a:ln>
+            <a:noFill/>
+          </a:ln>
+          <a:effectLst/>
+        </p:spPr>
+        <p:style>
+          <a:lnRef idx="1">
+            <a:schemeClr val="accent1"/>
+          </a:lnRef>
+          <a:fillRef idx="3">
+            <a:schemeClr val="accent1"/>
+          </a:fillRef>
+          <a:effectRef idx="2">
+            <a:schemeClr val="accent1"/>
+          </a:effectRef>
+          <a:fontRef idx="minor">
+            <a:schemeClr val="lt1"/>
+          </a:fontRef>
+        </p:style>
+        <p:txBody>
+          <a:bodyPr rtlCol="0" anchor="ctr" lIns="0" rIns="0" tIns="0" bIns="0"/>
+          <a:lstStyle/>
+          <a:p>
+            <a:pPr algn="ctr"/>
+            <a:r>
+              <a:rPr sz="800" b="1">
+                <a:solidFill>
+                  <a:srgbClr val="FFFFFF"/>
+                </a:solidFill>
+                <a:latin typeface="Segoe UI"/>
+              </a:rPr>
+              <a:t>B</a:t>
+            </a:r>
+          </a:p>
+        </p:txBody>
+      </p:sp>
+      <p:sp>
+        <p:nvSpPr>
           <p:cNvPr id="12" name="TextBox 11"/>
           <p:cNvSpPr txBox="1"/>
           <p:nvPr/>
         </p:nvSpPr>
         <p:spPr>
           <a:xfrm>
-            <a:off x="2231136" y="2322576"/>
-            <a:ext cx="1993391" cy="886968"/>
-          </a:xfrm>
-          <a:prstGeom prst="rect">
-            <a:avLst/>
-          </a:prstGeom>
-          <a:noFill/>
-        </p:spPr>
-        <p:txBody>
-          <a:bodyPr wrap="square" anchor="t" lIns="0" rIns="0" tIns="0" bIns="0">
-            <a:spAutoFit/>
-          </a:bodyPr>
-          <a:lstStyle/>
-          <a:p>
-            <a:pPr algn="l">
-              <a:spcAft>
-                <a:spcPts val="100"/>
+            <a:off x="2157984" y="1956816"/>
+            <a:ext cx="2221991" cy="274320"/>
+          </a:xfrm>
+          <a:prstGeom prst="rect">
+            <a:avLst/>
+          </a:prstGeom>
+          <a:noFill/>
+        </p:spPr>
+        <p:txBody>
+          <a:bodyPr wrap="square" anchor="t" lIns="0" rIns="0" tIns="0" bIns="0">
+            <a:spAutoFit/>
+          </a:bodyPr>
+          <a:lstStyle/>
+          <a:p>
+            <a:pPr algn="l">
+              <a:spcAft>
+                <a:spcPts val="0"/>
+              </a:spcAft>
+            </a:pPr>
+            <a:r>
+              <a:rPr sz="1000" b="1">
+                <a:solidFill>
+                  <a:srgbClr val="2E74B5"/>
+                </a:solidFill>
+                <a:latin typeface="Segoe UI"/>
+              </a:rPr>
+              <a:t>1 · </a:t>
+            </a:r>
+            <a:r>
+              <a:rPr sz="900" b="1">
+                <a:solidFill>
+                  <a:srgbClr val="7A808A"/>
+                </a:solidFill>
+                <a:latin typeface="Segoe UI"/>
+              </a:rPr>
+              <a:t>BACKSTAGE · YELLOW PAGES</a:t>
+            </a:r>
+          </a:p>
+        </p:txBody>
+      </p:sp>
+      <p:sp>
+        <p:nvSpPr>
+          <p:cNvPr id="13" name="TextBox 12"/>
+          <p:cNvSpPr txBox="1"/>
+          <p:nvPr/>
+        </p:nvSpPr>
+        <p:spPr>
+          <a:xfrm>
+            <a:off x="1828800" y="2304288"/>
+            <a:ext cx="2496312" cy="292608"/>
+          </a:xfrm>
+          <a:prstGeom prst="rect">
+            <a:avLst/>
+          </a:prstGeom>
+          <a:noFill/>
+        </p:spPr>
+        <p:txBody>
+          <a:bodyPr wrap="square" anchor="t" lIns="0" rIns="0" tIns="0" bIns="0">
+            <a:spAutoFit/>
+          </a:bodyPr>
+          <a:lstStyle/>
+          <a:p>
+            <a:pPr algn="l">
+              <a:spcAft>
+                <a:spcPts val="0"/>
               </a:spcAft>
             </a:pPr>
             <a:r>
               <a:rPr sz="1050" b="1">
                 <a:solidFill>
-                  <a:srgbClr val="2E74B5"/>
-                </a:solidFill>
-                <a:latin typeface="Segoe UI"/>
-              </a:rPr>
-              <a:t>1 · </a:t>
-            </a:r>
-            <a:r>
-              <a:rPr sz="1050" b="1">
-                <a:solidFill>
                   <a:srgbClr val="1B2A41"/>
                 </a:solidFill>
                 <a:latin typeface="Segoe UI"/>
               </a:rPr>
-              <a:t>Portal wizard</a:t>
-            </a:r>
-          </a:p>
-          <a:p>
-            <a:pPr algn="l">
-              <a:spcAft>
-                <a:spcPts val="100"/>
-              </a:spcAft>
-            </a:pPr>
-            <a:r>
-              <a:rPr sz="900" b="0">
-                <a:solidFill>
-                  <a:srgbClr val="40444B"/>
-                </a:solidFill>
-                <a:latin typeface="Segoe UI"/>
-              </a:rPr>
-              <a:t>The request is described in a form — not a ticket, not a chat.</a:t>
-            </a:r>
-          </a:p>
-        </p:txBody>
-      </p:sp>
-      <p:sp>
-        <p:nvSpPr>
-          <p:cNvPr id="13" name="Rectangle 12"/>
+              <a:t>Wizard → git; approval in-portal</a:t>
+            </a:r>
+          </a:p>
+        </p:txBody>
+      </p:sp>
+      <p:sp>
+        <p:nvSpPr>
+          <p:cNvPr id="14" name="TextBox 13"/>
+          <p:cNvSpPr txBox="1"/>
+          <p:nvPr/>
+        </p:nvSpPr>
+        <p:spPr>
+          <a:xfrm>
+            <a:off x="1828800" y="2651760"/>
+            <a:ext cx="2496312" cy="1005840"/>
+          </a:xfrm>
+          <a:prstGeom prst="rect">
+            <a:avLst/>
+          </a:prstGeom>
+          <a:noFill/>
+        </p:spPr>
+        <p:txBody>
+          <a:bodyPr wrap="square" anchor="t" lIns="0" rIns="0" tIns="0" bIns="0">
+            <a:spAutoFit/>
+          </a:bodyPr>
+          <a:lstStyle/>
+          <a:p>
+            <a:pPr algn="l">
+              <a:spcAft>
+                <a:spcPts val="300"/>
+              </a:spcAft>
+            </a:pPr>
+            <a:r>
+              <a:rPr sz="750" b="0">
+                <a:solidFill>
+                  <a:srgbClr val="3E4C63"/>
+                </a:solidFill>
+                <a:latin typeface="Consolas"/>
+              </a:rPr>
+              <a:t>scaffolder → domain-model JSON</a:t>
+            </a:r>
+          </a:p>
+          <a:p>
+            <a:pPr algn="l">
+              <a:spcAft>
+                <a:spcPts val="300"/>
+              </a:spcAft>
+            </a:pPr>
+            <a:r>
+              <a:rPr sz="750" b="0">
+                <a:solidFill>
+                  <a:srgbClr val="3E4C63"/>
+                </a:solidFill>
+                <a:latin typeface="Consolas"/>
+              </a:rPr>
+              <a:t>publish:bitbucketServer</a:t>
+            </a:r>
+          </a:p>
+          <a:p>
+            <a:pPr algn="l">
+              <a:spcAft>
+                <a:spcPts val="300"/>
+              </a:spcAft>
+            </a:pPr>
+            <a:r>
+              <a:rPr sz="750" b="0">
+                <a:solidFill>
+                  <a:srgbClr val="3E4C63"/>
+                </a:solidFill>
+                <a:latin typeface="Consolas"/>
+              </a:rPr>
+              <a:t>staging/&lt;env&gt;-&lt;asset&gt; · maker-checker</a:t>
+            </a:r>
+          </a:p>
+        </p:txBody>
+      </p:sp>
+      <p:sp>
+        <p:nvSpPr>
+          <p:cNvPr id="15" name="Right Arrow 14"/>
           <p:cNvSpPr/>
           <p:nvPr/>
         </p:nvSpPr>
         <p:spPr>
           <a:xfrm>
-            <a:off x="2112264" y="3401568"/>
-            <a:ext cx="2231136" cy="1051560"/>
+            <a:off x="4507992" y="2651760"/>
+            <a:ext cx="237744" cy="201168"/>
+          </a:xfrm>
+          <a:prstGeom prst="rightArrow">
+            <a:avLst/>
+          </a:prstGeom>
+          <a:solidFill>
+            <a:srgbClr val="2E74B5"/>
+          </a:solidFill>
+          <a:ln>
+            <a:noFill/>
+          </a:ln>
+          <a:effectLst/>
+        </p:spPr>
+        <p:style>
+          <a:lnRef idx="1">
+            <a:schemeClr val="accent1"/>
+          </a:lnRef>
+          <a:fillRef idx="3">
+            <a:schemeClr val="accent1"/>
+          </a:fillRef>
+          <a:effectRef idx="2">
+            <a:schemeClr val="accent1"/>
+          </a:effectRef>
+          <a:fontRef idx="minor">
+            <a:schemeClr val="lt1"/>
+          </a:fontRef>
+        </p:style>
+        <p:txBody>
+          <a:bodyPr rtlCol="0" anchor="ctr"/>
+          <a:lstStyle/>
+          <a:p>
+            <a:pPr algn="ctr"/>
+          </a:p>
+        </p:txBody>
+      </p:sp>
+      <p:sp>
+        <p:nvSpPr>
+          <p:cNvPr id="16" name="Rectangle 15"/>
+          <p:cNvSpPr/>
+          <p:nvPr/>
+        </p:nvSpPr>
+        <p:spPr>
+          <a:xfrm>
+            <a:off x="4782312" y="1828800"/>
+            <a:ext cx="2651760" cy="1874519"/>
           </a:xfrm>
           <a:prstGeom prst="rect">
             <a:avLst/>
@@ -7001,78 +7156,271 @@
       </p:sp>
       <p:sp>
         <p:nvSpPr>
-          <p:cNvPr id="14" name="TextBox 13"/>
-          <p:cNvSpPr txBox="1"/>
-          <p:nvPr/>
-        </p:nvSpPr>
-        <p:spPr>
-          <a:xfrm>
-            <a:off x="2231136" y="3493008"/>
-            <a:ext cx="1993391" cy="886968"/>
-          </a:xfrm>
-          <a:prstGeom prst="rect">
-            <a:avLst/>
-          </a:prstGeom>
-          <a:noFill/>
-        </p:spPr>
-        <p:txBody>
-          <a:bodyPr wrap="square" anchor="t" lIns="0" rIns="0" tIns="0" bIns="0">
-            <a:spAutoFit/>
-          </a:bodyPr>
-          <a:lstStyle/>
-          <a:p>
-            <a:pPr algn="l">
-              <a:spcAft>
-                <a:spcPts val="100"/>
+          <p:cNvPr id="17" name="Rectangle 16"/>
+          <p:cNvSpPr/>
+          <p:nvPr/>
+        </p:nvSpPr>
+        <p:spPr>
+          <a:xfrm>
+            <a:off x="4782312" y="1828800"/>
+            <a:ext cx="2651760" cy="45720"/>
+          </a:xfrm>
+          <a:prstGeom prst="rect">
+            <a:avLst/>
+          </a:prstGeom>
+          <a:solidFill>
+            <a:srgbClr val="0052CC"/>
+          </a:solidFill>
+          <a:ln>
+            <a:noFill/>
+          </a:ln>
+          <a:effectLst/>
+        </p:spPr>
+        <p:style>
+          <a:lnRef idx="1">
+            <a:schemeClr val="accent1"/>
+          </a:lnRef>
+          <a:fillRef idx="3">
+            <a:schemeClr val="accent1"/>
+          </a:fillRef>
+          <a:effectRef idx="2">
+            <a:schemeClr val="accent1"/>
+          </a:effectRef>
+          <a:fontRef idx="minor">
+            <a:schemeClr val="lt1"/>
+          </a:fontRef>
+        </p:style>
+        <p:txBody>
+          <a:bodyPr rtlCol="0" anchor="ctr"/>
+          <a:lstStyle/>
+          <a:p>
+            <a:pPr algn="ctr"/>
+          </a:p>
+        </p:txBody>
+      </p:sp>
+      <p:sp>
+        <p:nvSpPr>
+          <p:cNvPr id="18" name="Rounded Rectangle 17"/>
+          <p:cNvSpPr/>
+          <p:nvPr/>
+        </p:nvSpPr>
+        <p:spPr>
+          <a:xfrm>
+            <a:off x="4910328" y="1975104"/>
+            <a:ext cx="237744" cy="237744"/>
+          </a:xfrm>
+          <a:prstGeom prst="roundRect">
+            <a:avLst>
+              <a:gd name="adj" fmla="val 25000"/>
+            </a:avLst>
+          </a:prstGeom>
+          <a:solidFill>
+            <a:srgbClr val="0052CC"/>
+          </a:solidFill>
+          <a:ln>
+            <a:noFill/>
+          </a:ln>
+          <a:effectLst/>
+        </p:spPr>
+        <p:style>
+          <a:lnRef idx="1">
+            <a:schemeClr val="accent1"/>
+          </a:lnRef>
+          <a:fillRef idx="3">
+            <a:schemeClr val="accent1"/>
+          </a:fillRef>
+          <a:effectRef idx="2">
+            <a:schemeClr val="accent1"/>
+          </a:effectRef>
+          <a:fontRef idx="minor">
+            <a:schemeClr val="lt1"/>
+          </a:fontRef>
+        </p:style>
+        <p:txBody>
+          <a:bodyPr rtlCol="0" anchor="ctr" lIns="0" rIns="0" tIns="0" bIns="0"/>
+          <a:lstStyle/>
+          <a:p>
+            <a:pPr algn="ctr"/>
+            <a:r>
+              <a:rPr sz="800" b="1">
+                <a:solidFill>
+                  <a:srgbClr val="FFFFFF"/>
+                </a:solidFill>
+                <a:latin typeface="Segoe UI"/>
+              </a:rPr>
+              <a:t>Bb</a:t>
+            </a:r>
+          </a:p>
+        </p:txBody>
+      </p:sp>
+      <p:sp>
+        <p:nvSpPr>
+          <p:cNvPr id="19" name="TextBox 18"/>
+          <p:cNvSpPr txBox="1"/>
+          <p:nvPr/>
+        </p:nvSpPr>
+        <p:spPr>
+          <a:xfrm>
+            <a:off x="5257800" y="1956816"/>
+            <a:ext cx="2084831" cy="274320"/>
+          </a:xfrm>
+          <a:prstGeom prst="rect">
+            <a:avLst/>
+          </a:prstGeom>
+          <a:noFill/>
+        </p:spPr>
+        <p:txBody>
+          <a:bodyPr wrap="square" anchor="t" lIns="0" rIns="0" tIns="0" bIns="0">
+            <a:spAutoFit/>
+          </a:bodyPr>
+          <a:lstStyle/>
+          <a:p>
+            <a:pPr algn="l">
+              <a:spcAft>
+                <a:spcPts val="0"/>
+              </a:spcAft>
+            </a:pPr>
+            <a:r>
+              <a:rPr sz="1000" b="1">
+                <a:solidFill>
+                  <a:srgbClr val="2E74B5"/>
+                </a:solidFill>
+                <a:latin typeface="Segoe UI"/>
+              </a:rPr>
+              <a:t>2 · </a:t>
+            </a:r>
+            <a:r>
+              <a:rPr sz="900" b="1">
+                <a:solidFill>
+                  <a:srgbClr val="7A808A"/>
+                </a:solidFill>
+                <a:latin typeface="Segoe UI"/>
+              </a:rPr>
+              <a:t>BITBUCKET · TRUTH</a:t>
+            </a:r>
+          </a:p>
+        </p:txBody>
+      </p:sp>
+      <p:sp>
+        <p:nvSpPr>
+          <p:cNvPr id="20" name="TextBox 19"/>
+          <p:cNvSpPr txBox="1"/>
+          <p:nvPr/>
+        </p:nvSpPr>
+        <p:spPr>
+          <a:xfrm>
+            <a:off x="4928616" y="2304288"/>
+            <a:ext cx="2359152" cy="292608"/>
+          </a:xfrm>
+          <a:prstGeom prst="rect">
+            <a:avLst/>
+          </a:prstGeom>
+          <a:noFill/>
+        </p:spPr>
+        <p:txBody>
+          <a:bodyPr wrap="square" anchor="t" lIns="0" rIns="0" tIns="0" bIns="0">
+            <a:spAutoFit/>
+          </a:bodyPr>
+          <a:lstStyle/>
+          <a:p>
+            <a:pPr algn="l">
+              <a:spcAft>
+                <a:spcPts val="0"/>
               </a:spcAft>
             </a:pPr>
             <a:r>
               <a:rPr sz="1050" b="1">
                 <a:solidFill>
-                  <a:srgbClr val="2E74B5"/>
-                </a:solidFill>
-                <a:latin typeface="Segoe UI"/>
-              </a:rPr>
-              <a:t>2 · </a:t>
-            </a:r>
-            <a:r>
-              <a:rPr sz="1050" b="1">
-                <a:solidFill>
                   <a:srgbClr val="1B2A41"/>
                 </a:solidFill>
                 <a:latin typeface="Segoe UI"/>
               </a:rPr>
-              <a:t>Approval workflow</a:t>
-            </a:r>
-          </a:p>
-          <a:p>
-            <a:pPr algn="l">
-              <a:spcAft>
-                <a:spcPts val="100"/>
-              </a:spcAft>
-            </a:pPr>
-            <a:r>
-              <a:rPr sz="900" b="0">
-                <a:solidFill>
-                  <a:srgbClr val="40444B"/>
-                </a:solidFill>
-                <a:latin typeface="Segoe UI"/>
-              </a:rPr>
-              <a:t>Maker–checker; approver reviews a readable change.</a:t>
-            </a:r>
-          </a:p>
-        </p:txBody>
-      </p:sp>
-      <p:sp>
-        <p:nvSpPr>
-          <p:cNvPr id="15" name="Right Arrow 14"/>
+              <a:t>main = production; merge = approval</a:t>
+            </a:r>
+          </a:p>
+        </p:txBody>
+      </p:sp>
+      <p:sp>
+        <p:nvSpPr>
+          <p:cNvPr id="21" name="TextBox 20"/>
+          <p:cNvSpPr txBox="1"/>
+          <p:nvPr/>
+        </p:nvSpPr>
+        <p:spPr>
+          <a:xfrm>
+            <a:off x="4928616" y="2651760"/>
+            <a:ext cx="2359152" cy="1005840"/>
+          </a:xfrm>
+          <a:prstGeom prst="rect">
+            <a:avLst/>
+          </a:prstGeom>
+          <a:noFill/>
+        </p:spPr>
+        <p:txBody>
+          <a:bodyPr wrap="square" anchor="t" lIns="0" rIns="0" tIns="0" bIns="0">
+            <a:spAutoFit/>
+          </a:bodyPr>
+          <a:lstStyle/>
+          <a:p>
+            <a:pPr algn="l">
+              <a:spcAft>
+                <a:spcPts val="300"/>
+              </a:spcAft>
+            </a:pPr>
+            <a:r>
+              <a:rPr sz="750" b="0">
+                <a:solidFill>
+                  <a:srgbClr val="3E4C63"/>
+                </a:solidFill>
+                <a:latin typeface="Consolas"/>
+              </a:rPr>
+              <a:t>git = audit (who / what / when)</a:t>
+            </a:r>
+          </a:p>
+          <a:p>
+            <a:pPr algn="l">
+              <a:spcAft>
+                <a:spcPts val="300"/>
+              </a:spcAft>
+            </a:pPr>
+            <a:r>
+              <a:rPr sz="750" b="0">
+                <a:solidFill>
+                  <a:srgbClr val="3E4C63"/>
+                </a:solidFill>
+                <a:latin typeface="Consolas"/>
+              </a:rPr>
+              <a:t>repo:refs_changed -&gt; from/toHash</a:t>
+            </a:r>
+          </a:p>
+          <a:p>
+            <a:pPr algn="l">
+              <a:spcAft>
+                <a:spcPts val="300"/>
+              </a:spcAft>
+            </a:pPr>
+            <a:r>
+              <a:rPr sz="750" b="0">
+                <a:solidFill>
+                  <a:srgbClr val="3E4C63"/>
+                </a:solidFill>
+                <a:latin typeface="Consolas"/>
+              </a:rPr>
+              <a:t>one config repo per tool</a:t>
+            </a:r>
+          </a:p>
+        </p:txBody>
+      </p:sp>
+      <p:sp>
+        <p:nvSpPr>
+          <p:cNvPr id="22" name="Right Arrow 21"/>
           <p:cNvSpPr/>
           <p:nvPr/>
         </p:nvSpPr>
         <p:spPr>
           <a:xfrm>
-            <a:off x="4498848" y="3108960"/>
-            <a:ext cx="274320" cy="219456"/>
+            <a:off x="7470648" y="2651760"/>
+            <a:ext cx="237744" cy="201168"/>
           </a:xfrm>
           <a:prstGeom prst="rightArrow">
             <a:avLst/>
@@ -7109,97 +7457,14 @@
       </p:sp>
       <p:sp>
         <p:nvSpPr>
-          <p:cNvPr id="16" name="Rectangle 15"/>
+          <p:cNvPr id="23" name="Rectangle 22"/>
           <p:cNvSpPr/>
           <p:nvPr/>
         </p:nvSpPr>
         <p:spPr>
           <a:xfrm>
-            <a:off x="4809744" y="1874519"/>
-            <a:ext cx="2697480" cy="2697480"/>
-          </a:xfrm>
-          <a:prstGeom prst="rect">
-            <a:avLst/>
-          </a:prstGeom>
-          <a:solidFill>
-            <a:srgbClr val="F4F6F8"/>
-          </a:solidFill>
-          <a:ln>
-            <a:noFill/>
-          </a:ln>
-          <a:effectLst/>
-        </p:spPr>
-        <p:style>
-          <a:lnRef idx="1">
-            <a:schemeClr val="accent1"/>
-          </a:lnRef>
-          <a:fillRef idx="3">
-            <a:schemeClr val="accent1"/>
-          </a:fillRef>
-          <a:effectRef idx="2">
-            <a:schemeClr val="accent1"/>
-          </a:effectRef>
-          <a:fontRef idx="minor">
-            <a:schemeClr val="lt1"/>
-          </a:fontRef>
-        </p:style>
-        <p:txBody>
-          <a:bodyPr rtlCol="0" anchor="ctr"/>
-          <a:lstStyle/>
-          <a:p>
-            <a:pPr algn="ctr"/>
-          </a:p>
-        </p:txBody>
-      </p:sp>
-      <p:sp>
-        <p:nvSpPr>
-          <p:cNvPr id="17" name="TextBox 16"/>
-          <p:cNvSpPr txBox="1"/>
-          <p:nvPr/>
-        </p:nvSpPr>
-        <p:spPr>
-          <a:xfrm>
-            <a:off x="4928616" y="1965960"/>
-            <a:ext cx="2459736" cy="237744"/>
-          </a:xfrm>
-          <a:prstGeom prst="rect">
-            <a:avLst/>
-          </a:prstGeom>
-          <a:noFill/>
-        </p:spPr>
-        <p:txBody>
-          <a:bodyPr wrap="square" anchor="t" lIns="0" rIns="0" tIns="0" bIns="0">
-            <a:spAutoFit/>
-          </a:bodyPr>
-          <a:lstStyle/>
-          <a:p>
-            <a:pPr algn="l">
-              <a:spcAft>
-                <a:spcPts val="400"/>
-              </a:spcAft>
-            </a:pPr>
-            <a:r>
-              <a:rPr sz="900" b="1">
-                <a:solidFill>
-                  <a:srgbClr val="7A808A"/>
-                </a:solidFill>
-                <a:latin typeface="Segoe UI"/>
-              </a:rPr>
-              <a:t>BITBUCKET — SYSTEM OF RECORD</a:t>
-            </a:r>
-          </a:p>
-        </p:txBody>
-      </p:sp>
-      <p:sp>
-        <p:nvSpPr>
-          <p:cNvPr id="18" name="Rectangle 17"/>
-          <p:cNvSpPr/>
-          <p:nvPr/>
-        </p:nvSpPr>
-        <p:spPr>
-          <a:xfrm>
-            <a:off x="4928616" y="2231136"/>
-            <a:ext cx="2459736" cy="1051560"/>
+            <a:off x="7744968" y="1828800"/>
+            <a:ext cx="2514600" cy="1874519"/>
           </a:xfrm>
           <a:prstGeom prst="rect">
             <a:avLst/>
@@ -7238,89 +7503,23 @@
       </p:sp>
       <p:sp>
         <p:nvSpPr>
-          <p:cNvPr id="19" name="TextBox 18"/>
-          <p:cNvSpPr txBox="1"/>
-          <p:nvPr/>
-        </p:nvSpPr>
-        <p:spPr>
-          <a:xfrm>
-            <a:off x="5047488" y="2322576"/>
-            <a:ext cx="2221991" cy="886968"/>
-          </a:xfrm>
-          <a:prstGeom prst="rect">
-            <a:avLst/>
-          </a:prstGeom>
-          <a:noFill/>
-        </p:spPr>
-        <p:txBody>
-          <a:bodyPr wrap="square" anchor="t" lIns="0" rIns="0" tIns="0" bIns="0">
-            <a:spAutoFit/>
-          </a:bodyPr>
-          <a:lstStyle/>
-          <a:p>
-            <a:pPr algn="l">
-              <a:spcAft>
-                <a:spcPts val="100"/>
-              </a:spcAft>
-            </a:pPr>
-            <a:r>
-              <a:rPr sz="1050" b="1">
-                <a:solidFill>
-                  <a:srgbClr val="2E74B5"/>
-                </a:solidFill>
-                <a:latin typeface="Segoe UI"/>
-              </a:rPr>
-              <a:t>3 · </a:t>
-            </a:r>
-            <a:r>
-              <a:rPr sz="1050" b="1">
-                <a:solidFill>
-                  <a:srgbClr val="1B2A41"/>
-                </a:solidFill>
-                <a:latin typeface="Segoe UI"/>
-              </a:rPr>
-              <a:t>Staging branch</a:t>
-            </a:r>
-          </a:p>
-          <a:p>
-            <a:pPr algn="l">
-              <a:spcAft>
-                <a:spcPts val="100"/>
-              </a:spcAft>
-            </a:pPr>
-            <a:r>
-              <a:rPr sz="900" b="0">
-                <a:solidFill>
-                  <a:srgbClr val="40444B"/>
-                </a:solidFill>
-                <a:latin typeface="Segoe UI"/>
-              </a:rPr>
-              <a:t>One branch per request; main is production truth.</a:t>
-            </a:r>
-          </a:p>
-        </p:txBody>
-      </p:sp>
-      <p:sp>
-        <p:nvSpPr>
-          <p:cNvPr id="20" name="Rectangle 19"/>
+          <p:cNvPr id="24" name="Rectangle 23"/>
           <p:cNvSpPr/>
           <p:nvPr/>
         </p:nvSpPr>
         <p:spPr>
           <a:xfrm>
-            <a:off x="4928616" y="3401568"/>
-            <a:ext cx="2459736" cy="1051560"/>
+            <a:off x="7744968" y="1828800"/>
+            <a:ext cx="2514600" cy="45720"/>
           </a:xfrm>
           <a:prstGeom prst="rect">
             <a:avLst/>
           </a:prstGeom>
           <a:solidFill>
-            <a:srgbClr val="FFFFFF"/>
+            <a:srgbClr val="EE0000"/>
           </a:solidFill>
-          <a:ln w="9525">
-            <a:solidFill>
-              <a:srgbClr val="D8DCE1"/>
-            </a:solidFill>
+          <a:ln>
+            <a:noFill/>
           </a:ln>
           <a:effectLst/>
         </p:spPr>
@@ -7348,78 +7547,227 @@
       </p:sp>
       <p:sp>
         <p:nvSpPr>
-          <p:cNvPr id="21" name="TextBox 20"/>
-          <p:cNvSpPr txBox="1"/>
-          <p:nvPr/>
-        </p:nvSpPr>
-        <p:spPr>
-          <a:xfrm>
-            <a:off x="5047488" y="3493008"/>
-            <a:ext cx="2221991" cy="886968"/>
-          </a:xfrm>
-          <a:prstGeom prst="rect">
-            <a:avLst/>
-          </a:prstGeom>
-          <a:noFill/>
-        </p:spPr>
-        <p:txBody>
-          <a:bodyPr wrap="square" anchor="t" lIns="0" rIns="0" tIns="0" bIns="0">
-            <a:spAutoFit/>
-          </a:bodyPr>
-          <a:lstStyle/>
-          <a:p>
-            <a:pPr algn="l">
-              <a:spcAft>
-                <a:spcPts val="100"/>
+          <p:cNvPr id="25" name="Rounded Rectangle 24"/>
+          <p:cNvSpPr/>
+          <p:nvPr/>
+        </p:nvSpPr>
+        <p:spPr>
+          <a:xfrm>
+            <a:off x="7872984" y="1975104"/>
+            <a:ext cx="237744" cy="237744"/>
+          </a:xfrm>
+          <a:prstGeom prst="roundRect">
+            <a:avLst>
+              <a:gd name="adj" fmla="val 25000"/>
+            </a:avLst>
+          </a:prstGeom>
+          <a:solidFill>
+            <a:srgbClr val="EE0000"/>
+          </a:solidFill>
+          <a:ln>
+            <a:noFill/>
+          </a:ln>
+          <a:effectLst/>
+        </p:spPr>
+        <p:style>
+          <a:lnRef idx="1">
+            <a:schemeClr val="accent1"/>
+          </a:lnRef>
+          <a:fillRef idx="3">
+            <a:schemeClr val="accent1"/>
+          </a:fillRef>
+          <a:effectRef idx="2">
+            <a:schemeClr val="accent1"/>
+          </a:effectRef>
+          <a:fontRef idx="minor">
+            <a:schemeClr val="lt1"/>
+          </a:fontRef>
+        </p:style>
+        <p:txBody>
+          <a:bodyPr rtlCol="0" anchor="ctr" lIns="0" rIns="0" tIns="0" bIns="0"/>
+          <a:lstStyle/>
+          <a:p>
+            <a:pPr algn="ctr"/>
+            <a:r>
+              <a:rPr sz="800" b="1">
+                <a:solidFill>
+                  <a:srgbClr val="FFFFFF"/>
+                </a:solidFill>
+                <a:latin typeface="Segoe UI"/>
+              </a:rPr>
+              <a:t>A</a:t>
+            </a:r>
+          </a:p>
+        </p:txBody>
+      </p:sp>
+      <p:sp>
+        <p:nvSpPr>
+          <p:cNvPr id="26" name="TextBox 25"/>
+          <p:cNvSpPr txBox="1"/>
+          <p:nvPr/>
+        </p:nvSpPr>
+        <p:spPr>
+          <a:xfrm>
+            <a:off x="8220456" y="1956816"/>
+            <a:ext cx="1947672" cy="274320"/>
+          </a:xfrm>
+          <a:prstGeom prst="rect">
+            <a:avLst/>
+          </a:prstGeom>
+          <a:noFill/>
+        </p:spPr>
+        <p:txBody>
+          <a:bodyPr wrap="square" anchor="t" lIns="0" rIns="0" tIns="0" bIns="0">
+            <a:spAutoFit/>
+          </a:bodyPr>
+          <a:lstStyle/>
+          <a:p>
+            <a:pPr algn="l">
+              <a:spcAft>
+                <a:spcPts val="0"/>
+              </a:spcAft>
+            </a:pPr>
+            <a:r>
+              <a:rPr sz="1000" b="1">
+                <a:solidFill>
+                  <a:srgbClr val="2E74B5"/>
+                </a:solidFill>
+                <a:latin typeface="Segoe UI"/>
+              </a:rPr>
+              <a:t>3 · </a:t>
+            </a:r>
+            <a:r>
+              <a:rPr sz="900" b="1">
+                <a:solidFill>
+                  <a:srgbClr val="7A808A"/>
+                </a:solidFill>
+                <a:latin typeface="Segoe UI"/>
+              </a:rPr>
+              <a:t>ANSIBLE · ACTIVATION</a:t>
+            </a:r>
+          </a:p>
+        </p:txBody>
+      </p:sp>
+      <p:sp>
+        <p:nvSpPr>
+          <p:cNvPr id="27" name="TextBox 26"/>
+          <p:cNvSpPr txBox="1"/>
+          <p:nvPr/>
+        </p:nvSpPr>
+        <p:spPr>
+          <a:xfrm>
+            <a:off x="7891272" y="2304288"/>
+            <a:ext cx="2221992" cy="292608"/>
+          </a:xfrm>
+          <a:prstGeom prst="rect">
+            <a:avLst/>
+          </a:prstGeom>
+          <a:noFill/>
+        </p:spPr>
+        <p:txBody>
+          <a:bodyPr wrap="square" anchor="t" lIns="0" rIns="0" tIns="0" bIns="0">
+            <a:spAutoFit/>
+          </a:bodyPr>
+          <a:lstStyle/>
+          <a:p>
+            <a:pPr algn="l">
+              <a:spcAft>
+                <a:spcPts val="0"/>
               </a:spcAft>
             </a:pPr>
             <a:r>
               <a:rPr sz="1050" b="1">
                 <a:solidFill>
-                  <a:srgbClr val="2E74B5"/>
-                </a:solidFill>
-                <a:latin typeface="Segoe UI"/>
-              </a:rPr>
-              <a:t>4 · </a:t>
-            </a:r>
-            <a:r>
-              <a:rPr sz="1050" b="1">
-                <a:solidFill>
                   <a:srgbClr val="1B2A41"/>
                 </a:solidFill>
                 <a:latin typeface="Segoe UI"/>
               </a:rPr>
-              <a:t>PR merged to main</a:t>
-            </a:r>
-          </a:p>
-          <a:p>
-            <a:pPr algn="l">
-              <a:spcAft>
-                <a:spcPts val="100"/>
-              </a:spcAft>
-            </a:pPr>
-            <a:r>
-              <a:rPr sz="900" b="0">
-                <a:solidFill>
-                  <a:srgbClr val="40444B"/>
-                </a:solidFill>
-                <a:latin typeface="Segoe UI"/>
-              </a:rPr>
-              <a:t>The merge IS the approval; git IS the audit trail.</a:t>
-            </a:r>
-          </a:p>
-        </p:txBody>
-      </p:sp>
-      <p:sp>
-        <p:nvSpPr>
-          <p:cNvPr id="22" name="Right Arrow 21"/>
+              <a:t>Translate → activate, stateless</a:t>
+            </a:r>
+          </a:p>
+        </p:txBody>
+      </p:sp>
+      <p:sp>
+        <p:nvSpPr>
+          <p:cNvPr id="28" name="TextBox 27"/>
+          <p:cNvSpPr txBox="1"/>
+          <p:nvPr/>
+        </p:nvSpPr>
+        <p:spPr>
+          <a:xfrm>
+            <a:off x="7891272" y="2651760"/>
+            <a:ext cx="2221992" cy="1005840"/>
+          </a:xfrm>
+          <a:prstGeom prst="rect">
+            <a:avLst/>
+          </a:prstGeom>
+          <a:noFill/>
+        </p:spPr>
+        <p:txBody>
+          <a:bodyPr wrap="square" anchor="t" lIns="0" rIns="0" tIns="0" bIns="0">
+            <a:spAutoFit/>
+          </a:bodyPr>
+          <a:lstStyle/>
+          <a:p>
+            <a:pPr algn="l">
+              <a:spcAft>
+                <a:spcPts val="300"/>
+              </a:spcAft>
+            </a:pPr>
+            <a:r>
+              <a:rPr sz="750" b="0">
+                <a:solidFill>
+                  <a:srgbClr val="3E4C63"/>
+                </a:solidFill>
+                <a:latin typeface="Consolas"/>
+              </a:rPr>
+              <a:t>REST reads only — no clone, no git writes</a:t>
+            </a:r>
+          </a:p>
+          <a:p>
+            <a:pPr algn="l">
+              <a:spcAft>
+                <a:spcPts val="300"/>
+              </a:spcAft>
+            </a:pPr>
+            <a:r>
+              <a:rPr sz="750" b="0">
+                <a:solidFill>
+                  <a:srgbClr val="3E4C63"/>
+                </a:solidFill>
+                <a:latin typeface="Consolas"/>
+              </a:rPr>
+              <a:t>neutral JSON -&gt; tool format</a:t>
+            </a:r>
+          </a:p>
+          <a:p>
+            <a:pPr algn="l">
+              <a:spcAft>
+                <a:spcPts val="300"/>
+              </a:spcAft>
+            </a:pPr>
+            <a:r>
+              <a:rPr sz="750" b="0">
+                <a:solidFill>
+                  <a:srgbClr val="3E4C63"/>
+                </a:solidFill>
+                <a:latin typeface="Consolas"/>
+              </a:rPr>
+              <a:t>idempotent PUT x3 · Vault · no_log</a:t>
+            </a:r>
+          </a:p>
+        </p:txBody>
+      </p:sp>
+      <p:sp>
+        <p:nvSpPr>
+          <p:cNvPr id="29" name="Right Arrow 28"/>
           <p:cNvSpPr/>
           <p:nvPr/>
         </p:nvSpPr>
         <p:spPr>
           <a:xfrm>
-            <a:off x="7543800" y="3108960"/>
-            <a:ext cx="274320" cy="219456"/>
+            <a:off x="10296144" y="2651760"/>
+            <a:ext cx="237744" cy="201168"/>
           </a:xfrm>
           <a:prstGeom prst="rightArrow">
             <a:avLst/>
@@ -7456,14 +7804,14 @@
       </p:sp>
       <p:sp>
         <p:nvSpPr>
-          <p:cNvPr id="23" name="Rectangle 22"/>
+          <p:cNvPr id="30" name="Rectangle 29"/>
           <p:cNvSpPr/>
           <p:nvPr/>
         </p:nvSpPr>
         <p:spPr>
           <a:xfrm>
-            <a:off x="7854696" y="1874519"/>
-            <a:ext cx="1691640" cy="2697480"/>
+            <a:off x="10570464" y="1828800"/>
+            <a:ext cx="1069848" cy="1874519"/>
           </a:xfrm>
           <a:prstGeom prst="rect">
             <a:avLst/>
@@ -7500,14 +7848,14 @@
       </p:sp>
       <p:sp>
         <p:nvSpPr>
-          <p:cNvPr id="24" name="TextBox 23"/>
-          <p:cNvSpPr txBox="1"/>
-          <p:nvPr/>
-        </p:nvSpPr>
-        <p:spPr>
-          <a:xfrm>
-            <a:off x="7973568" y="1965960"/>
-            <a:ext cx="1453896" cy="237744"/>
+          <p:cNvPr id="31" name="TextBox 30"/>
+          <p:cNvSpPr txBox="1"/>
+          <p:nvPr/>
+        </p:nvSpPr>
+        <p:spPr>
+          <a:xfrm>
+            <a:off x="10661904" y="1883664"/>
+            <a:ext cx="914400" cy="219456"/>
           </a:xfrm>
           <a:prstGeom prst="rect">
             <a:avLst/>
@@ -7526,38 +7874,38 @@
               </a:spcAft>
             </a:pPr>
             <a:r>
-              <a:rPr sz="900" b="1">
+              <a:rPr sz="800" b="1">
                 <a:solidFill>
                   <a:srgbClr val="7A808A"/>
                 </a:solidFill>
                 <a:latin typeface="Segoe UI"/>
               </a:rPr>
-              <a:t>ANSIBLE — ACTIVATION</a:t>
-            </a:r>
-          </a:p>
-        </p:txBody>
-      </p:sp>
-      <p:sp>
-        <p:nvSpPr>
-          <p:cNvPr id="25" name="Rectangle 24"/>
+              <a:t>4 · TARGETS</a:t>
+            </a:r>
+          </a:p>
+        </p:txBody>
+      </p:sp>
+      <p:sp>
+        <p:nvSpPr>
+          <p:cNvPr id="32" name="Rounded Rectangle 31"/>
           <p:cNvSpPr/>
           <p:nvPr/>
         </p:nvSpPr>
         <p:spPr>
           <a:xfrm>
-            <a:off x="7973568" y="2377440"/>
-            <a:ext cx="1453896" cy="1920240"/>
-          </a:xfrm>
-          <a:prstGeom prst="rect">
-            <a:avLst/>
+            <a:off x="10680192" y="2139696"/>
+            <a:ext cx="201168" cy="201168"/>
+          </a:xfrm>
+          <a:prstGeom prst="roundRect">
+            <a:avLst>
+              <a:gd name="adj" fmla="val 25000"/>
+            </a:avLst>
           </a:prstGeom>
           <a:solidFill>
-            <a:srgbClr val="FFFFFF"/>
+            <a:srgbClr val="CC092F"/>
           </a:solidFill>
-          <a:ln w="9525">
-            <a:solidFill>
-              <a:srgbClr val="D8DCE1"/>
-            </a:solidFill>
+          <a:ln>
+            <a:noFill/>
           </a:ln>
           <a:effectLst/>
         </p:spPr>
@@ -7576,6 +7924,428 @@
           </a:fontRef>
         </p:style>
         <p:txBody>
+          <a:bodyPr rtlCol="0" anchor="ctr" lIns="0" rIns="0" tIns="0" bIns="0"/>
+          <a:lstStyle/>
+          <a:p>
+            <a:pPr algn="ctr"/>
+            <a:r>
+              <a:rPr sz="700" b="1">
+                <a:solidFill>
+                  <a:srgbClr val="FFFFFF"/>
+                </a:solidFill>
+                <a:latin typeface="Segoe UI"/>
+              </a:rPr>
+              <a:t>DX</a:t>
+            </a:r>
+          </a:p>
+        </p:txBody>
+      </p:sp>
+      <p:sp>
+        <p:nvSpPr>
+          <p:cNvPr id="33" name="TextBox 32"/>
+          <p:cNvSpPr txBox="1"/>
+          <p:nvPr/>
+        </p:nvSpPr>
+        <p:spPr>
+          <a:xfrm>
+            <a:off x="10936224" y="2148839"/>
+            <a:ext cx="685800" cy="201168"/>
+          </a:xfrm>
+          <a:prstGeom prst="rect">
+            <a:avLst/>
+          </a:prstGeom>
+          <a:noFill/>
+        </p:spPr>
+        <p:txBody>
+          <a:bodyPr wrap="square" anchor="t" lIns="0" rIns="0" tIns="0" bIns="0">
+            <a:spAutoFit/>
+          </a:bodyPr>
+          <a:lstStyle/>
+          <a:p>
+            <a:pPr algn="l">
+              <a:spcAft>
+                <a:spcPts val="0"/>
+              </a:spcAft>
+            </a:pPr>
+            <a:r>
+              <a:rPr sz="800" b="1">
+                <a:solidFill>
+                  <a:srgbClr val="1B2A41"/>
+                </a:solidFill>
+                <a:latin typeface="Segoe UI"/>
+              </a:rPr>
+              <a:t>DX UIM</a:t>
+            </a:r>
+          </a:p>
+        </p:txBody>
+      </p:sp>
+      <p:sp>
+        <p:nvSpPr>
+          <p:cNvPr id="34" name="Rounded Rectangle 33"/>
+          <p:cNvSpPr/>
+          <p:nvPr/>
+        </p:nvSpPr>
+        <p:spPr>
+          <a:xfrm>
+            <a:off x="10680192" y="2523744"/>
+            <a:ext cx="201168" cy="201168"/>
+          </a:xfrm>
+          <a:prstGeom prst="roundRect">
+            <a:avLst>
+              <a:gd name="adj" fmla="val 25000"/>
+            </a:avLst>
+          </a:prstGeom>
+          <a:solidFill>
+            <a:srgbClr val="00BFB3"/>
+          </a:solidFill>
+          <a:ln>
+            <a:noFill/>
+          </a:ln>
+          <a:effectLst/>
+        </p:spPr>
+        <p:style>
+          <a:lnRef idx="1">
+            <a:schemeClr val="accent1"/>
+          </a:lnRef>
+          <a:fillRef idx="3">
+            <a:schemeClr val="accent1"/>
+          </a:fillRef>
+          <a:effectRef idx="2">
+            <a:schemeClr val="accent1"/>
+          </a:effectRef>
+          <a:fontRef idx="minor">
+            <a:schemeClr val="lt1"/>
+          </a:fontRef>
+        </p:style>
+        <p:txBody>
+          <a:bodyPr rtlCol="0" anchor="ctr" lIns="0" rIns="0" tIns="0" bIns="0"/>
+          <a:lstStyle/>
+          <a:p>
+            <a:pPr algn="ctr"/>
+            <a:r>
+              <a:rPr sz="700" b="1">
+                <a:solidFill>
+                  <a:srgbClr val="FFFFFF"/>
+                </a:solidFill>
+                <a:latin typeface="Segoe UI"/>
+              </a:rPr>
+              <a:t>E</a:t>
+            </a:r>
+          </a:p>
+        </p:txBody>
+      </p:sp>
+      <p:sp>
+        <p:nvSpPr>
+          <p:cNvPr id="35" name="TextBox 34"/>
+          <p:cNvSpPr txBox="1"/>
+          <p:nvPr/>
+        </p:nvSpPr>
+        <p:spPr>
+          <a:xfrm>
+            <a:off x="10936224" y="2532887"/>
+            <a:ext cx="685800" cy="201168"/>
+          </a:xfrm>
+          <a:prstGeom prst="rect">
+            <a:avLst/>
+          </a:prstGeom>
+          <a:noFill/>
+        </p:spPr>
+        <p:txBody>
+          <a:bodyPr wrap="square" anchor="t" lIns="0" rIns="0" tIns="0" bIns="0">
+            <a:spAutoFit/>
+          </a:bodyPr>
+          <a:lstStyle/>
+          <a:p>
+            <a:pPr algn="l">
+              <a:spcAft>
+                <a:spcPts val="0"/>
+              </a:spcAft>
+            </a:pPr>
+            <a:r>
+              <a:rPr sz="800" b="1">
+                <a:solidFill>
+                  <a:srgbClr val="1B2A41"/>
+                </a:solidFill>
+                <a:latin typeface="Segoe UI"/>
+              </a:rPr>
+              <a:t>ELK</a:t>
+            </a:r>
+          </a:p>
+        </p:txBody>
+      </p:sp>
+      <p:sp>
+        <p:nvSpPr>
+          <p:cNvPr id="36" name="Rounded Rectangle 35"/>
+          <p:cNvSpPr/>
+          <p:nvPr/>
+        </p:nvSpPr>
+        <p:spPr>
+          <a:xfrm>
+            <a:off x="10680192" y="2907791"/>
+            <a:ext cx="201168" cy="201168"/>
+          </a:xfrm>
+          <a:prstGeom prst="roundRect">
+            <a:avLst>
+              <a:gd name="adj" fmla="val 25000"/>
+            </a:avLst>
+          </a:prstGeom>
+          <a:solidFill>
+            <a:srgbClr val="F99D1C"/>
+          </a:solidFill>
+          <a:ln>
+            <a:noFill/>
+          </a:ln>
+          <a:effectLst/>
+        </p:spPr>
+        <p:style>
+          <a:lnRef idx="1">
+            <a:schemeClr val="accent1"/>
+          </a:lnRef>
+          <a:fillRef idx="3">
+            <a:schemeClr val="accent1"/>
+          </a:fillRef>
+          <a:effectRef idx="2">
+            <a:schemeClr val="accent1"/>
+          </a:effectRef>
+          <a:fontRef idx="minor">
+            <a:schemeClr val="lt1"/>
+          </a:fontRef>
+        </p:style>
+        <p:txBody>
+          <a:bodyPr rtlCol="0" anchor="ctr" lIns="0" rIns="0" tIns="0" bIns="0"/>
+          <a:lstStyle/>
+          <a:p>
+            <a:pPr algn="ctr"/>
+            <a:r>
+              <a:rPr sz="700" b="1">
+                <a:solidFill>
+                  <a:srgbClr val="FFFFFF"/>
+                </a:solidFill>
+                <a:latin typeface="Segoe UI"/>
+              </a:rPr>
+              <a:t>SW</a:t>
+            </a:r>
+          </a:p>
+        </p:txBody>
+      </p:sp>
+      <p:sp>
+        <p:nvSpPr>
+          <p:cNvPr id="37" name="TextBox 36"/>
+          <p:cNvSpPr txBox="1"/>
+          <p:nvPr/>
+        </p:nvSpPr>
+        <p:spPr>
+          <a:xfrm>
+            <a:off x="10936224" y="2916935"/>
+            <a:ext cx="685800" cy="201168"/>
+          </a:xfrm>
+          <a:prstGeom prst="rect">
+            <a:avLst/>
+          </a:prstGeom>
+          <a:noFill/>
+        </p:spPr>
+        <p:txBody>
+          <a:bodyPr wrap="square" anchor="t" lIns="0" rIns="0" tIns="0" bIns="0">
+            <a:spAutoFit/>
+          </a:bodyPr>
+          <a:lstStyle/>
+          <a:p>
+            <a:pPr algn="l">
+              <a:spcAft>
+                <a:spcPts val="0"/>
+              </a:spcAft>
+            </a:pPr>
+            <a:r>
+              <a:rPr sz="800" b="1">
+                <a:solidFill>
+                  <a:srgbClr val="1B2A41"/>
+                </a:solidFill>
+                <a:latin typeface="Segoe UI"/>
+              </a:rPr>
+              <a:t>SolarWinds</a:t>
+            </a:r>
+          </a:p>
+        </p:txBody>
+      </p:sp>
+      <p:sp>
+        <p:nvSpPr>
+          <p:cNvPr id="38" name="Rounded Rectangle 37"/>
+          <p:cNvSpPr/>
+          <p:nvPr/>
+        </p:nvSpPr>
+        <p:spPr>
+          <a:xfrm>
+            <a:off x="10680192" y="3291839"/>
+            <a:ext cx="201168" cy="201168"/>
+          </a:xfrm>
+          <a:prstGeom prst="roundRect">
+            <a:avLst>
+              <a:gd name="adj" fmla="val 25000"/>
+            </a:avLst>
+          </a:prstGeom>
+          <a:solidFill>
+            <a:srgbClr val="6A1B9A"/>
+          </a:solidFill>
+          <a:ln>
+            <a:noFill/>
+          </a:ln>
+          <a:effectLst/>
+        </p:spPr>
+        <p:style>
+          <a:lnRef idx="1">
+            <a:schemeClr val="accent1"/>
+          </a:lnRef>
+          <a:fillRef idx="3">
+            <a:schemeClr val="accent1"/>
+          </a:fillRef>
+          <a:effectRef idx="2">
+            <a:schemeClr val="accent1"/>
+          </a:effectRef>
+          <a:fontRef idx="minor">
+            <a:schemeClr val="lt1"/>
+          </a:fontRef>
+        </p:style>
+        <p:txBody>
+          <a:bodyPr rtlCol="0" anchor="ctr" lIns="0" rIns="0" tIns="0" bIns="0"/>
+          <a:lstStyle/>
+          <a:p>
+            <a:pPr algn="ctr"/>
+            <a:r>
+              <a:rPr sz="700" b="1">
+                <a:solidFill>
+                  <a:srgbClr val="FFFFFF"/>
+                </a:solidFill>
+                <a:latin typeface="Segoe UI"/>
+              </a:rPr>
+              <a:t>M</a:t>
+            </a:r>
+          </a:p>
+        </p:txBody>
+      </p:sp>
+      <p:sp>
+        <p:nvSpPr>
+          <p:cNvPr id="39" name="TextBox 38"/>
+          <p:cNvSpPr txBox="1"/>
+          <p:nvPr/>
+        </p:nvSpPr>
+        <p:spPr>
+          <a:xfrm>
+            <a:off x="10936224" y="3300983"/>
+            <a:ext cx="685800" cy="201168"/>
+          </a:xfrm>
+          <a:prstGeom prst="rect">
+            <a:avLst/>
+          </a:prstGeom>
+          <a:noFill/>
+        </p:spPr>
+        <p:txBody>
+          <a:bodyPr wrap="square" anchor="t" lIns="0" rIns="0" tIns="0" bIns="0">
+            <a:spAutoFit/>
+          </a:bodyPr>
+          <a:lstStyle/>
+          <a:p>
+            <a:pPr algn="l">
+              <a:spcAft>
+                <a:spcPts val="0"/>
+              </a:spcAft>
+            </a:pPr>
+            <a:r>
+              <a:rPr sz="800" b="1">
+                <a:solidFill>
+                  <a:srgbClr val="1B2A41"/>
+                </a:solidFill>
+                <a:latin typeface="Segoe UI"/>
+              </a:rPr>
+              <a:t>Moogsoft</a:t>
+            </a:r>
+          </a:p>
+        </p:txBody>
+      </p:sp>
+      <p:sp>
+        <p:nvSpPr>
+          <p:cNvPr id="40" name="TextBox 39"/>
+          <p:cNvSpPr txBox="1"/>
+          <p:nvPr/>
+        </p:nvSpPr>
+        <p:spPr>
+          <a:xfrm>
+            <a:off x="548640" y="3822191"/>
+            <a:ext cx="11064240" cy="182880"/>
+          </a:xfrm>
+          <a:prstGeom prst="rect">
+            <a:avLst/>
+          </a:prstGeom>
+          <a:noFill/>
+        </p:spPr>
+        <p:txBody>
+          <a:bodyPr wrap="square" anchor="t" lIns="0" rIns="0" tIns="0" bIns="0">
+            <a:spAutoFit/>
+          </a:bodyPr>
+          <a:lstStyle/>
+          <a:p>
+            <a:pPr algn="l">
+              <a:spcAft>
+                <a:spcPts val="0"/>
+              </a:spcAft>
+            </a:pPr>
+            <a:r>
+              <a:rPr sz="750" b="1">
+                <a:solidFill>
+                  <a:srgbClr val="7A808A"/>
+                </a:solidFill>
+                <a:latin typeface="Segoe UI"/>
+              </a:rPr>
+              <a:t>invariants: </a:t>
+            </a:r>
+            <a:r>
+              <a:rPr sz="750" b="0">
+                <a:solidFill>
+                  <a:srgbClr val="7A808A"/>
+                </a:solidFill>
+                <a:latin typeface="Consolas"/>
+              </a:rPr>
+              <a:t>data flows one way · idempotent desired-state, not diffs · empty ≠ delete</a:t>
+            </a:r>
+          </a:p>
+        </p:txBody>
+      </p:sp>
+      <p:sp>
+        <p:nvSpPr>
+          <p:cNvPr id="41" name="Rectangle 40"/>
+          <p:cNvSpPr/>
+          <p:nvPr/>
+        </p:nvSpPr>
+        <p:spPr>
+          <a:xfrm>
+            <a:off x="548640" y="4114800"/>
+            <a:ext cx="11091672" cy="603504"/>
+          </a:xfrm>
+          <a:prstGeom prst="rect">
+            <a:avLst/>
+          </a:prstGeom>
+          <a:solidFill>
+            <a:srgbClr val="F4F6F8"/>
+          </a:solidFill>
+          <a:ln>
+            <a:noFill/>
+          </a:ln>
+          <a:effectLst/>
+        </p:spPr>
+        <p:style>
+          <a:lnRef idx="1">
+            <a:schemeClr val="accent1"/>
+          </a:lnRef>
+          <a:fillRef idx="3">
+            <a:schemeClr val="accent1"/>
+          </a:fillRef>
+          <a:effectRef idx="2">
+            <a:schemeClr val="accent1"/>
+          </a:effectRef>
+          <a:fontRef idx="minor">
+            <a:schemeClr val="lt1"/>
+          </a:fontRef>
+        </p:style>
+        <p:txBody>
           <a:bodyPr rtlCol="0" anchor="ctr"/>
           <a:lstStyle/>
           <a:p>
@@ -7585,80 +8355,16 @@
       </p:sp>
       <p:sp>
         <p:nvSpPr>
-          <p:cNvPr id="26" name="TextBox 25"/>
-          <p:cNvSpPr txBox="1"/>
-          <p:nvPr/>
-        </p:nvSpPr>
-        <p:spPr>
-          <a:xfrm>
-            <a:off x="8092440" y="2468880"/>
-            <a:ext cx="1216152" cy="1755648"/>
-          </a:xfrm>
-          <a:prstGeom prst="rect">
-            <a:avLst/>
-          </a:prstGeom>
-          <a:noFill/>
-        </p:spPr>
-        <p:txBody>
-          <a:bodyPr wrap="square" anchor="t" lIns="0" rIns="0" tIns="0" bIns="0">
-            <a:spAutoFit/>
-          </a:bodyPr>
-          <a:lstStyle/>
-          <a:p>
-            <a:pPr algn="l">
-              <a:spcAft>
-                <a:spcPts val="100"/>
-              </a:spcAft>
-            </a:pPr>
-            <a:r>
-              <a:rPr sz="1050" b="1">
-                <a:solidFill>
-                  <a:srgbClr val="2E74B5"/>
-                </a:solidFill>
-                <a:latin typeface="Segoe UI"/>
-              </a:rPr>
-              <a:t>5 · </a:t>
-            </a:r>
-            <a:r>
-              <a:rPr sz="1050" b="1">
-                <a:solidFill>
-                  <a:srgbClr val="1B2A41"/>
-                </a:solidFill>
-                <a:latin typeface="Segoe UI"/>
-              </a:rPr>
-              <a:t>Webhook fires</a:t>
-            </a:r>
-          </a:p>
-          <a:p>
-            <a:pPr algn="l">
-              <a:spcAft>
-                <a:spcPts val="100"/>
-              </a:spcAft>
-            </a:pPr>
-            <a:r>
-              <a:rPr sz="900" b="0">
-                <a:solidFill>
-                  <a:srgbClr val="40444B"/>
-                </a:solidFill>
-                <a:latin typeface="Segoe UI"/>
-              </a:rPr>
-              <a:t>Commit to main triggers the sync — idempotent, stateless, reads git via API only.</a:t>
-            </a:r>
-          </a:p>
-        </p:txBody>
-      </p:sp>
-      <p:sp>
-        <p:nvSpPr>
-          <p:cNvPr id="27" name="Right Arrow 26"/>
+          <p:cNvPr id="42" name="Left Arrow 41"/>
           <p:cNvSpPr/>
           <p:nvPr/>
         </p:nvSpPr>
         <p:spPr>
           <a:xfrm>
-            <a:off x="9582912" y="3108960"/>
-            <a:ext cx="274320" cy="219456"/>
-          </a:xfrm>
-          <a:prstGeom prst="rightArrow">
+            <a:off x="676656" y="4233672"/>
+            <a:ext cx="237744" cy="182880"/>
+          </a:xfrm>
+          <a:prstGeom prst="leftArrow">
             <a:avLst/>
           </a:prstGeom>
           <a:solidFill>
@@ -7693,20 +8399,20 @@
       </p:sp>
       <p:sp>
         <p:nvSpPr>
-          <p:cNvPr id="28" name="Rectangle 27"/>
+          <p:cNvPr id="43" name="Left Arrow 42"/>
           <p:cNvSpPr/>
           <p:nvPr/>
         </p:nvSpPr>
         <p:spPr>
           <a:xfrm>
-            <a:off x="9893808" y="1874519"/>
-            <a:ext cx="1746504" cy="2697480"/>
-          </a:xfrm>
-          <a:prstGeom prst="rect">
+            <a:off x="676656" y="4462272"/>
+            <a:ext cx="237744" cy="182880"/>
+          </a:xfrm>
+          <a:prstGeom prst="leftArrow">
             <a:avLst/>
           </a:prstGeom>
           <a:solidFill>
-            <a:srgbClr val="F4F6F8"/>
+            <a:srgbClr val="F59300"/>
           </a:solidFill>
           <a:ln>
             <a:noFill/>
@@ -7737,53 +8443,89 @@
       </p:sp>
       <p:sp>
         <p:nvSpPr>
-          <p:cNvPr id="29" name="TextBox 28"/>
-          <p:cNvSpPr txBox="1"/>
-          <p:nvPr/>
-        </p:nvSpPr>
-        <p:spPr>
-          <a:xfrm>
-            <a:off x="10012680" y="1965960"/>
-            <a:ext cx="1508760" cy="237744"/>
-          </a:xfrm>
-          <a:prstGeom prst="rect">
-            <a:avLst/>
-          </a:prstGeom>
-          <a:noFill/>
-        </p:spPr>
-        <p:txBody>
-          <a:bodyPr wrap="square" anchor="t" lIns="0" rIns="0" tIns="0" bIns="0">
-            <a:spAutoFit/>
-          </a:bodyPr>
-          <a:lstStyle/>
-          <a:p>
-            <a:pPr algn="l">
-              <a:spcAft>
-                <a:spcPts val="400"/>
-              </a:spcAft>
-            </a:pPr>
-            <a:r>
-              <a:rPr sz="900" b="1">
-                <a:solidFill>
-                  <a:srgbClr val="7A808A"/>
-                </a:solidFill>
-                <a:latin typeface="Segoe UI"/>
-              </a:rPr>
-              <a:t>TARGETS</a:t>
-            </a:r>
-          </a:p>
-        </p:txBody>
-      </p:sp>
-      <p:sp>
-        <p:nvSpPr>
-          <p:cNvPr id="30" name="Rectangle 29"/>
+          <p:cNvPr id="44" name="TextBox 43"/>
+          <p:cNvSpPr txBox="1"/>
+          <p:nvPr/>
+        </p:nvSpPr>
+        <p:spPr>
+          <a:xfrm>
+            <a:off x="1042415" y="4187952"/>
+            <a:ext cx="10424160" cy="493776"/>
+          </a:xfrm>
+          <a:prstGeom prst="rect">
+            <a:avLst/>
+          </a:prstGeom>
+          <a:noFill/>
+        </p:spPr>
+        <p:txBody>
+          <a:bodyPr wrap="square" anchor="t" lIns="0" rIns="0" tIns="0" bIns="0">
+            <a:spAutoFit/>
+          </a:bodyPr>
+          <a:lstStyle/>
+          <a:p>
+            <a:pPr algn="l">
+              <a:spcAft>
+                <a:spcPts val="0"/>
+              </a:spcAft>
+            </a:pPr>
+            <a:r>
+              <a:rPr sz="950" b="1">
+                <a:solidFill>
+                  <a:srgbClr val="1B2A41"/>
+                </a:solidFill>
+                <a:latin typeface="Segoe UI"/>
+              </a:rPr>
+              <a:t>5 · Closed loop, twice. </a:t>
+            </a:r>
+            <a:r>
+              <a:rPr sz="850" b="1">
+                <a:solidFill>
+                  <a:srgbClr val="2E74B5"/>
+                </a:solidFill>
+                <a:latin typeface="Segoe UI"/>
+              </a:rPr>
+              <a:t>Per request: </a:t>
+            </a:r>
+            <a:r>
+              <a:rPr sz="800" b="0">
+                <a:solidFill>
+                  <a:srgbClr val="40444B"/>
+                </a:solidFill>
+                <a:latin typeface="Segoe UI"/>
+              </a:rPr>
+              <a:t>notify_requester → Backstage Notifications — success live, failure critical + red job. </a:t>
+            </a:r>
+            <a:r>
+              <a:rPr sz="850" b="1">
+                <a:solidFill>
+                  <a:srgbClr val="F59300"/>
+                </a:solidFill>
+                <a:latin typeface="Segoe UI"/>
+              </a:rPr>
+              <a:t>Continuous: </a:t>
+            </a:r>
+            <a:r>
+              <a:rPr sz="800" b="0">
+                <a:solidFill>
+                  <a:srgbClr val="40444B"/>
+                </a:solidFill>
+                <a:latin typeface="Segoe UI"/>
+              </a:rPr>
+              <a:t>the drift detector reads live config back from every target API, diffs it against main — mutations made on a tool surface as drift, platform owners are notified, remediation stays governed (re-sync or approved change).</a:t>
+            </a:r>
+          </a:p>
+        </p:txBody>
+      </p:sp>
+      <p:sp>
+        <p:nvSpPr>
+          <p:cNvPr id="45" name="Rectangle 44"/>
           <p:cNvSpPr/>
           <p:nvPr/>
         </p:nvSpPr>
         <p:spPr>
           <a:xfrm>
-            <a:off x="10012680" y="2231136"/>
-            <a:ext cx="1508760" cy="512064"/>
+            <a:off x="548640" y="4956048"/>
+            <a:ext cx="11091672" cy="841248"/>
           </a:xfrm>
           <a:prstGeom prst="rect">
             <a:avLst/>
@@ -7820,452 +8562,19 @@
       </p:sp>
       <p:sp>
         <p:nvSpPr>
-          <p:cNvPr id="31" name="TextBox 30"/>
-          <p:cNvSpPr txBox="1"/>
-          <p:nvPr/>
-        </p:nvSpPr>
-        <p:spPr>
-          <a:xfrm>
-            <a:off x="10085832" y="2295144"/>
-            <a:ext cx="1371600" cy="402336"/>
-          </a:xfrm>
-          <a:prstGeom prst="rect">
-            <a:avLst/>
-          </a:prstGeom>
-          <a:noFill/>
-        </p:spPr>
-        <p:txBody>
-          <a:bodyPr wrap="square" anchor="t" lIns="0" rIns="0" tIns="0" bIns="0">
-            <a:spAutoFit/>
-          </a:bodyPr>
-          <a:lstStyle/>
-          <a:p>
-            <a:pPr algn="l">
-              <a:spcAft>
-                <a:spcPts val="0"/>
-              </a:spcAft>
-            </a:pPr>
-            <a:r>
-              <a:rPr sz="950" b="1">
-                <a:solidFill>
-                  <a:srgbClr val="FFFFFF"/>
-                </a:solidFill>
-                <a:latin typeface="Segoe UI"/>
-              </a:rPr>
-              <a:t>DX UIM</a:t>
-            </a:r>
-          </a:p>
-          <a:p>
-            <a:pPr algn="l">
-              <a:spcAft>
-                <a:spcPts val="0"/>
-              </a:spcAft>
-            </a:pPr>
-            <a:r>
-              <a:rPr sz="700" b="0">
-                <a:solidFill>
-                  <a:srgbClr val="C9D2DD"/>
-                </a:solidFill>
-                <a:latin typeface="Segoe UI"/>
-              </a:rPr>
-              <a:t>built · verified</a:t>
-            </a:r>
-          </a:p>
-        </p:txBody>
-      </p:sp>
-      <p:sp>
-        <p:nvSpPr>
-          <p:cNvPr id="32" name="Rectangle 31"/>
+          <p:cNvPr id="46" name="Rounded Rectangle 45"/>
           <p:cNvSpPr/>
           <p:nvPr/>
         </p:nvSpPr>
         <p:spPr>
           <a:xfrm>
-            <a:off x="10012680" y="2816352"/>
-            <a:ext cx="1508760" cy="512064"/>
-          </a:xfrm>
-          <a:prstGeom prst="rect">
-            <a:avLst/>
-          </a:prstGeom>
-          <a:solidFill>
-            <a:srgbClr val="1B2A41"/>
-          </a:solidFill>
-          <a:ln>
-            <a:noFill/>
-          </a:ln>
-          <a:effectLst/>
-        </p:spPr>
-        <p:style>
-          <a:lnRef idx="1">
-            <a:schemeClr val="accent1"/>
-          </a:lnRef>
-          <a:fillRef idx="3">
-            <a:schemeClr val="accent1"/>
-          </a:fillRef>
-          <a:effectRef idx="2">
-            <a:schemeClr val="accent1"/>
-          </a:effectRef>
-          <a:fontRef idx="minor">
-            <a:schemeClr val="lt1"/>
-          </a:fontRef>
-        </p:style>
-        <p:txBody>
-          <a:bodyPr rtlCol="0" anchor="ctr"/>
-          <a:lstStyle/>
-          <a:p>
-            <a:pPr algn="ctr"/>
-          </a:p>
-        </p:txBody>
-      </p:sp>
-      <p:sp>
-        <p:nvSpPr>
-          <p:cNvPr id="33" name="TextBox 32"/>
-          <p:cNvSpPr txBox="1"/>
-          <p:nvPr/>
-        </p:nvSpPr>
-        <p:spPr>
-          <a:xfrm>
-            <a:off x="10085832" y="2880360"/>
-            <a:ext cx="1371600" cy="402336"/>
-          </a:xfrm>
-          <a:prstGeom prst="rect">
-            <a:avLst/>
-          </a:prstGeom>
-          <a:noFill/>
-        </p:spPr>
-        <p:txBody>
-          <a:bodyPr wrap="square" anchor="t" lIns="0" rIns="0" tIns="0" bIns="0">
-            <a:spAutoFit/>
-          </a:bodyPr>
-          <a:lstStyle/>
-          <a:p>
-            <a:pPr algn="l">
-              <a:spcAft>
-                <a:spcPts val="0"/>
-              </a:spcAft>
-            </a:pPr>
-            <a:r>
-              <a:rPr sz="950" b="1">
-                <a:solidFill>
-                  <a:srgbClr val="FFFFFF"/>
-                </a:solidFill>
-                <a:latin typeface="Segoe UI"/>
-              </a:rPr>
-              <a:t>ELK</a:t>
-            </a:r>
-          </a:p>
-          <a:p>
-            <a:pPr algn="l">
-              <a:spcAft>
-                <a:spcPts val="0"/>
-              </a:spcAft>
-            </a:pPr>
-            <a:r>
-              <a:rPr sz="700" b="0">
-                <a:solidFill>
-                  <a:srgbClr val="C9D2DD"/>
-                </a:solidFill>
-                <a:latin typeface="Segoe UI"/>
-              </a:rPr>
-              <a:t>pattern proven · next</a:t>
-            </a:r>
-          </a:p>
-        </p:txBody>
-      </p:sp>
-      <p:sp>
-        <p:nvSpPr>
-          <p:cNvPr id="34" name="Rectangle 33"/>
-          <p:cNvSpPr/>
-          <p:nvPr/>
-        </p:nvSpPr>
-        <p:spPr>
-          <a:xfrm>
-            <a:off x="10012680" y="3401568"/>
-            <a:ext cx="1508760" cy="512064"/>
-          </a:xfrm>
-          <a:prstGeom prst="rect">
-            <a:avLst/>
-          </a:prstGeom>
-          <a:solidFill>
-            <a:srgbClr val="1B2A41"/>
-          </a:solidFill>
-          <a:ln>
-            <a:noFill/>
-          </a:ln>
-          <a:effectLst/>
-        </p:spPr>
-        <p:style>
-          <a:lnRef idx="1">
-            <a:schemeClr val="accent1"/>
-          </a:lnRef>
-          <a:fillRef idx="3">
-            <a:schemeClr val="accent1"/>
-          </a:fillRef>
-          <a:effectRef idx="2">
-            <a:schemeClr val="accent1"/>
-          </a:effectRef>
-          <a:fontRef idx="minor">
-            <a:schemeClr val="lt1"/>
-          </a:fontRef>
-        </p:style>
-        <p:txBody>
-          <a:bodyPr rtlCol="0" anchor="ctr"/>
-          <a:lstStyle/>
-          <a:p>
-            <a:pPr algn="ctr"/>
-          </a:p>
-        </p:txBody>
-      </p:sp>
-      <p:sp>
-        <p:nvSpPr>
-          <p:cNvPr id="35" name="TextBox 34"/>
-          <p:cNvSpPr txBox="1"/>
-          <p:nvPr/>
-        </p:nvSpPr>
-        <p:spPr>
-          <a:xfrm>
-            <a:off x="10085832" y="3465576"/>
-            <a:ext cx="1371600" cy="402336"/>
-          </a:xfrm>
-          <a:prstGeom prst="rect">
-            <a:avLst/>
-          </a:prstGeom>
-          <a:noFill/>
-        </p:spPr>
-        <p:txBody>
-          <a:bodyPr wrap="square" anchor="t" lIns="0" rIns="0" tIns="0" bIns="0">
-            <a:spAutoFit/>
-          </a:bodyPr>
-          <a:lstStyle/>
-          <a:p>
-            <a:pPr algn="l">
-              <a:spcAft>
-                <a:spcPts val="0"/>
-              </a:spcAft>
-            </a:pPr>
-            <a:r>
-              <a:rPr sz="950" b="1">
-                <a:solidFill>
-                  <a:srgbClr val="FFFFFF"/>
-                </a:solidFill>
-                <a:latin typeface="Segoe UI"/>
-              </a:rPr>
-              <a:t>SolarWinds</a:t>
-            </a:r>
-          </a:p>
-          <a:p>
-            <a:pPr algn="l">
-              <a:spcAft>
-                <a:spcPts val="0"/>
-              </a:spcAft>
-            </a:pPr>
-            <a:r>
-              <a:rPr sz="700" b="0">
-                <a:solidFill>
-                  <a:srgbClr val="C9D2DD"/>
-                </a:solidFill>
-                <a:latin typeface="Segoe UI"/>
-              </a:rPr>
-              <a:t>planned</a:t>
-            </a:r>
-          </a:p>
-        </p:txBody>
-      </p:sp>
-      <p:sp>
-        <p:nvSpPr>
-          <p:cNvPr id="36" name="Rectangle 35"/>
-          <p:cNvSpPr/>
-          <p:nvPr/>
-        </p:nvSpPr>
-        <p:spPr>
-          <a:xfrm>
-            <a:off x="10012680" y="3986784"/>
-            <a:ext cx="1508760" cy="512064"/>
-          </a:xfrm>
-          <a:prstGeom prst="rect">
-            <a:avLst/>
-          </a:prstGeom>
-          <a:solidFill>
-            <a:srgbClr val="1B2A41"/>
-          </a:solidFill>
-          <a:ln>
-            <a:noFill/>
-          </a:ln>
-          <a:effectLst/>
-        </p:spPr>
-        <p:style>
-          <a:lnRef idx="1">
-            <a:schemeClr val="accent1"/>
-          </a:lnRef>
-          <a:fillRef idx="3">
-            <a:schemeClr val="accent1"/>
-          </a:fillRef>
-          <a:effectRef idx="2">
-            <a:schemeClr val="accent1"/>
-          </a:effectRef>
-          <a:fontRef idx="minor">
-            <a:schemeClr val="lt1"/>
-          </a:fontRef>
-        </p:style>
-        <p:txBody>
-          <a:bodyPr rtlCol="0" anchor="ctr"/>
-          <a:lstStyle/>
-          <a:p>
-            <a:pPr algn="ctr"/>
-          </a:p>
-        </p:txBody>
-      </p:sp>
-      <p:sp>
-        <p:nvSpPr>
-          <p:cNvPr id="37" name="TextBox 36"/>
-          <p:cNvSpPr txBox="1"/>
-          <p:nvPr/>
-        </p:nvSpPr>
-        <p:spPr>
-          <a:xfrm>
-            <a:off x="10085832" y="4050792"/>
-            <a:ext cx="1371600" cy="402336"/>
-          </a:xfrm>
-          <a:prstGeom prst="rect">
-            <a:avLst/>
-          </a:prstGeom>
-          <a:noFill/>
-        </p:spPr>
-        <p:txBody>
-          <a:bodyPr wrap="square" anchor="t" lIns="0" rIns="0" tIns="0" bIns="0">
-            <a:spAutoFit/>
-          </a:bodyPr>
-          <a:lstStyle/>
-          <a:p>
-            <a:pPr algn="l">
-              <a:spcAft>
-                <a:spcPts val="0"/>
-              </a:spcAft>
-            </a:pPr>
-            <a:r>
-              <a:rPr sz="950" b="1">
-                <a:solidFill>
-                  <a:srgbClr val="FFFFFF"/>
-                </a:solidFill>
-                <a:latin typeface="Segoe UI"/>
-              </a:rPr>
-              <a:t>Moogsoft</a:t>
-            </a:r>
-          </a:p>
-          <a:p>
-            <a:pPr algn="l">
-              <a:spcAft>
-                <a:spcPts val="0"/>
-              </a:spcAft>
-            </a:pPr>
-            <a:r>
-              <a:rPr sz="700" b="0">
-                <a:solidFill>
-                  <a:srgbClr val="C9D2DD"/>
-                </a:solidFill>
-                <a:latin typeface="Segoe UI"/>
-              </a:rPr>
-              <a:t>events → tickets</a:t>
-            </a:r>
-          </a:p>
-        </p:txBody>
-      </p:sp>
-      <p:sp>
-        <p:nvSpPr>
-          <p:cNvPr id="38" name="TextBox 37"/>
-          <p:cNvSpPr txBox="1"/>
-          <p:nvPr/>
-        </p:nvSpPr>
-        <p:spPr>
-          <a:xfrm>
-            <a:off x="9893808" y="4590288"/>
-            <a:ext cx="1746504" cy="237744"/>
-          </a:xfrm>
-          <a:prstGeom prst="rect">
-            <a:avLst/>
-          </a:prstGeom>
-          <a:noFill/>
-        </p:spPr>
-        <p:txBody>
-          <a:bodyPr wrap="square" anchor="t" lIns="0" rIns="0" tIns="0" bIns="0">
-            <a:spAutoFit/>
-          </a:bodyPr>
-          <a:lstStyle/>
-          <a:p>
-            <a:pPr algn="l">
-              <a:spcAft>
-                <a:spcPts val="400"/>
-              </a:spcAft>
-            </a:pPr>
-            <a:r>
-              <a:rPr sz="800" b="0">
-                <a:solidFill>
-                  <a:srgbClr val="7A808A"/>
-                </a:solidFill>
-                <a:latin typeface="Segoe UI"/>
-              </a:rPr>
-              <a:t>6 · configured automatically</a:t>
-            </a:r>
-          </a:p>
-        </p:txBody>
-      </p:sp>
-      <p:sp>
-        <p:nvSpPr>
-          <p:cNvPr id="39" name="Rectangle 38"/>
-          <p:cNvSpPr/>
-          <p:nvPr/>
-        </p:nvSpPr>
-        <p:spPr>
-          <a:xfrm>
-            <a:off x="1993392" y="4864608"/>
-            <a:ext cx="9646920" cy="457200"/>
-          </a:xfrm>
-          <a:prstGeom prst="rect">
-            <a:avLst/>
-          </a:prstGeom>
-          <a:solidFill>
-            <a:srgbClr val="F4F6F8"/>
-          </a:solidFill>
-          <a:ln>
-            <a:noFill/>
-          </a:ln>
-          <a:effectLst/>
-        </p:spPr>
-        <p:style>
-          <a:lnRef idx="1">
-            <a:schemeClr val="accent1"/>
-          </a:lnRef>
-          <a:fillRef idx="3">
-            <a:schemeClr val="accent1"/>
-          </a:fillRef>
-          <a:effectRef idx="2">
-            <a:schemeClr val="accent1"/>
-          </a:effectRef>
-          <a:fontRef idx="minor">
-            <a:schemeClr val="lt1"/>
-          </a:fontRef>
-        </p:style>
-        <p:txBody>
-          <a:bodyPr rtlCol="0" anchor="ctr"/>
-          <a:lstStyle/>
-          <a:p>
-            <a:pPr algn="ctr"/>
-          </a:p>
-        </p:txBody>
-      </p:sp>
-      <p:sp>
-        <p:nvSpPr>
-          <p:cNvPr id="40" name="Left Arrow 39"/>
-          <p:cNvSpPr/>
-          <p:nvPr/>
-        </p:nvSpPr>
-        <p:spPr>
-          <a:xfrm>
-            <a:off x="2103120" y="4983480"/>
-            <a:ext cx="274320" cy="219456"/>
-          </a:xfrm>
-          <a:prstGeom prst="leftArrow">
-            <a:avLst/>
+            <a:off x="731520" y="5138928"/>
+            <a:ext cx="274320" cy="274320"/>
+          </a:xfrm>
+          <a:prstGeom prst="roundRect">
+            <a:avLst>
+              <a:gd name="adj" fmla="val 25000"/>
+            </a:avLst>
           </a:prstGeom>
           <a:solidFill>
             <a:srgbClr val="2E74B5"/>
@@ -8290,247 +8599,98 @@
           </a:fontRef>
         </p:style>
         <p:txBody>
-          <a:bodyPr rtlCol="0" anchor="ctr"/>
+          <a:bodyPr rtlCol="0" anchor="ctr" lIns="0" rIns="0" tIns="0" bIns="0"/>
           <a:lstStyle/>
           <a:p>
             <a:pPr algn="ctr"/>
-          </a:p>
-        </p:txBody>
-      </p:sp>
-      <p:sp>
-        <p:nvSpPr>
-          <p:cNvPr id="41" name="TextBox 40"/>
-          <p:cNvSpPr txBox="1"/>
-          <p:nvPr/>
-        </p:nvSpPr>
-        <p:spPr>
-          <a:xfrm>
-            <a:off x="2487168" y="4974336"/>
-            <a:ext cx="9052560" cy="274320"/>
-          </a:xfrm>
-          <a:prstGeom prst="rect">
-            <a:avLst/>
-          </a:prstGeom>
-          <a:noFill/>
-        </p:spPr>
-        <p:txBody>
-          <a:bodyPr wrap="square" anchor="t" lIns="0" rIns="0" tIns="0" bIns="0">
-            <a:spAutoFit/>
-          </a:bodyPr>
-          <a:lstStyle/>
-          <a:p>
-            <a:pPr algn="l">
-              <a:spcAft>
-                <a:spcPts val="400"/>
+            <a:r>
+              <a:rPr sz="900" b="1">
+                <a:solidFill>
+                  <a:srgbClr val="FFFFFF"/>
+                </a:solidFill>
+                <a:latin typeface="Segoe UI"/>
+              </a:rPr>
+              <a:t>OB</a:t>
+            </a:r>
+          </a:p>
+        </p:txBody>
+      </p:sp>
+      <p:sp>
+        <p:nvSpPr>
+          <p:cNvPr id="47" name="TextBox 46"/>
+          <p:cNvSpPr txBox="1"/>
+          <p:nvPr/>
+        </p:nvSpPr>
+        <p:spPr>
+          <a:xfrm>
+            <a:off x="1152144" y="5065776"/>
+            <a:ext cx="10378440" cy="694944"/>
+          </a:xfrm>
+          <a:prstGeom prst="rect">
+            <a:avLst/>
+          </a:prstGeom>
+          <a:noFill/>
+        </p:spPr>
+        <p:txBody>
+          <a:bodyPr wrap="square" anchor="t" lIns="0" rIns="0" tIns="0" bIns="0">
+            <a:spAutoFit/>
+          </a:bodyPr>
+          <a:lstStyle/>
+          <a:p>
+            <a:pPr algn="l">
+              <a:spcAft>
+                <a:spcPts val="200"/>
               </a:spcAft>
             </a:pPr>
             <a:r>
               <a:rPr sz="1000" b="1">
                 <a:solidFill>
-                  <a:srgbClr val="1B2A41"/>
-                </a:solidFill>
-                <a:latin typeface="Segoe UI"/>
-              </a:rPr>
-              <a:t>7 · Outcome notified back to the requester</a:t>
-            </a:r>
-            <a:r>
-              <a:rPr sz="950" b="0">
-                <a:solidFill>
-                  <a:srgbClr val="40444B"/>
-                </a:solidFill>
-                <a:latin typeface="Segoe UI"/>
-              </a:rPr>
-              <a:t>  —  success live; failure loud (critical notification, red job) so git and reality can never disagree silently.</a:t>
-            </a:r>
-          </a:p>
-        </p:txBody>
-      </p:sp>
-      <p:sp>
-        <p:nvSpPr>
-          <p:cNvPr id="42" name="TextBox 41"/>
-          <p:cNvSpPr txBox="1"/>
-          <p:nvPr/>
-        </p:nvSpPr>
-        <p:spPr>
-          <a:xfrm>
-            <a:off x="548640" y="5486400"/>
-            <a:ext cx="11064240" cy="237744"/>
-          </a:xfrm>
-          <a:prstGeom prst="rect">
-            <a:avLst/>
-          </a:prstGeom>
-          <a:noFill/>
-        </p:spPr>
-        <p:txBody>
-          <a:bodyPr wrap="square" anchor="t" lIns="0" rIns="0" tIns="0" bIns="0">
-            <a:spAutoFit/>
-          </a:bodyPr>
-          <a:lstStyle/>
-          <a:p>
-            <a:pPr algn="l">
-              <a:spcAft>
-                <a:spcPts val="400"/>
-              </a:spcAft>
-            </a:pPr>
-            <a:r>
-              <a:rPr sz="950" b="1">
-                <a:solidFill>
-                  <a:srgbClr val="7A808A"/>
-                </a:solidFill>
-                <a:latin typeface="Segoe UI"/>
-              </a:rPr>
-              <a:t>EACH COMPONENT HAS EXACTLY ONE JOB — DATA FLOWS ONE WAY</a:t>
-            </a:r>
-          </a:p>
-        </p:txBody>
-      </p:sp>
-      <p:sp>
-        <p:nvSpPr>
-          <p:cNvPr id="43" name="TextBox 42"/>
-          <p:cNvSpPr txBox="1"/>
-          <p:nvPr/>
-        </p:nvSpPr>
-        <p:spPr>
-          <a:xfrm>
-            <a:off x="548640" y="5760720"/>
-            <a:ext cx="3611880" cy="640080"/>
-          </a:xfrm>
-          <a:prstGeom prst="rect">
-            <a:avLst/>
-          </a:prstGeom>
-          <a:noFill/>
-        </p:spPr>
-        <p:txBody>
-          <a:bodyPr wrap="square" anchor="t" lIns="0" rIns="0" tIns="0" bIns="0">
-            <a:spAutoFit/>
-          </a:bodyPr>
-          <a:lstStyle/>
-          <a:p>
-            <a:pPr algn="l">
-              <a:spcAft>
-                <a:spcPts val="400"/>
-              </a:spcAft>
-            </a:pPr>
-            <a:r>
-              <a:rPr sz="1050" b="1">
-                <a:solidFill>
-                  <a:srgbClr val="1B2A41"/>
-                </a:solidFill>
-                <a:latin typeface="Segoe UI"/>
-              </a:rPr>
-              <a:t>Backstage</a:t>
-            </a:r>
-            <a:r>
-              <a:rPr sz="950" b="0">
-                <a:solidFill>
-                  <a:srgbClr val="40444B"/>
-                </a:solidFill>
-                <a:latin typeface="Segoe UI"/>
-              </a:rPr>
-              <a:t>  —  wizard, catalog, notifications — never talks to a monitoring tool directly.</a:t>
-            </a:r>
-          </a:p>
-        </p:txBody>
-      </p:sp>
-      <p:sp>
-        <p:nvSpPr>
-          <p:cNvPr id="44" name="TextBox 43"/>
-          <p:cNvSpPr txBox="1"/>
-          <p:nvPr/>
-        </p:nvSpPr>
-        <p:spPr>
-          <a:xfrm>
-            <a:off x="4379976" y="5760720"/>
-            <a:ext cx="3611880" cy="640080"/>
-          </a:xfrm>
-          <a:prstGeom prst="rect">
-            <a:avLst/>
-          </a:prstGeom>
-          <a:noFill/>
-        </p:spPr>
-        <p:txBody>
-          <a:bodyPr wrap="square" anchor="t" lIns="0" rIns="0" tIns="0" bIns="0">
-            <a:spAutoFit/>
-          </a:bodyPr>
-          <a:lstStyle/>
-          <a:p>
-            <a:pPr algn="l">
-              <a:spcAft>
-                <a:spcPts val="400"/>
-              </a:spcAft>
-            </a:pPr>
-            <a:r>
-              <a:rPr sz="1050" b="1">
-                <a:solidFill>
-                  <a:srgbClr val="1B2A41"/>
-                </a:solidFill>
-                <a:latin typeface="Segoe UI"/>
-              </a:rPr>
-              <a:t>Bitbucket</a:t>
-            </a:r>
-            <a:r>
-              <a:rPr sz="950" b="0">
-                <a:solidFill>
-                  <a:srgbClr val="40444B"/>
-                </a:solidFill>
-                <a:latin typeface="Segoe UI"/>
-              </a:rPr>
-              <a:t>  —  record + approval — human-reviewable text only; one config repo per tool.</a:t>
-            </a:r>
-          </a:p>
-        </p:txBody>
-      </p:sp>
-      <p:sp>
-        <p:nvSpPr>
-          <p:cNvPr id="45" name="TextBox 44"/>
-          <p:cNvSpPr txBox="1"/>
-          <p:nvPr/>
-        </p:nvSpPr>
-        <p:spPr>
-          <a:xfrm>
-            <a:off x="8211312" y="5760720"/>
-            <a:ext cx="3611880" cy="640080"/>
-          </a:xfrm>
-          <a:prstGeom prst="rect">
-            <a:avLst/>
-          </a:prstGeom>
-          <a:noFill/>
-        </p:spPr>
-        <p:txBody>
-          <a:bodyPr wrap="square" anchor="t" lIns="0" rIns="0" tIns="0" bIns="0">
-            <a:spAutoFit/>
-          </a:bodyPr>
-          <a:lstStyle/>
-          <a:p>
-            <a:pPr algn="l">
-              <a:spcAft>
-                <a:spcPts val="400"/>
-              </a:spcAft>
-            </a:pPr>
-            <a:r>
-              <a:rPr sz="1050" b="1">
-                <a:solidFill>
-                  <a:srgbClr val="1B2A41"/>
-                </a:solidFill>
-                <a:latin typeface="Segoe UI"/>
-              </a:rPr>
-              <a:t>Ansible</a:t>
-            </a:r>
-            <a:r>
-              <a:rPr sz="950" b="0">
-                <a:solidFill>
-                  <a:srgbClr val="40444B"/>
-                </a:solidFill>
-                <a:latin typeface="Segoe UI"/>
-              </a:rPr>
-              <a:t>  —  reads approved config, pushes to tools — never writes to git. Ever.</a:t>
-            </a:r>
-          </a:p>
-        </p:txBody>
-      </p:sp>
-      <p:sp>
-        <p:nvSpPr>
-          <p:cNvPr id="46" name="Rectangle 45"/>
+                  <a:srgbClr val="FFFFFF"/>
+                </a:solidFill>
+                <a:latin typeface="Segoe UI"/>
+              </a:rPr>
+              <a:t>The flywheel: every request makes the platform smarter. </a:t>
+            </a:r>
+          </a:p>
+          <a:p>
+            <a:pPr algn="l">
+              <a:spcAft>
+                <a:spcPts val="200"/>
+              </a:spcAft>
+            </a:pPr>
+            <a:r>
+              <a:rPr sz="800" b="0">
+                <a:solidFill>
+                  <a:srgbClr val="C9D2DD"/>
+                </a:solidFill>
+                <a:latin typeface="Segoe UI"/>
+              </a:rPr>
+              <a:t>A decade of refined gold — TechDocs, configurations, behavioural schedules from every target tool — accumulates in Bitbucket, rendered as living documentation that cannot drift. The </a:t>
+            </a:r>
+            <a:r>
+              <a:rPr sz="850" b="1">
+                <a:solidFill>
+                  <a:srgbClr val="FFFFFF"/>
+                </a:solidFill>
+                <a:latin typeface="Segoe UI"/>
+              </a:rPr>
+              <a:t>Observability Brain</a:t>
+            </a:r>
+            <a:r>
+              <a:rPr sz="800" b="0">
+                <a:solidFill>
+                  <a:srgbClr val="C9D2DD"/>
+                </a:solidFill>
+                <a:latin typeface="Segoe UI"/>
+              </a:rPr>
+              <a:t> — Backstage’s chatbot, the oracle at the front door — reads that same source of truth to answer, guide, and propose: grounded, cited, always under the approval gate.</a:t>
+            </a:r>
+          </a:p>
+        </p:txBody>
+      </p:sp>
+      <p:sp>
+        <p:nvSpPr>
+          <p:cNvPr id="48" name="Rectangle 47"/>
           <p:cNvSpPr/>
           <p:nvPr/>
         </p:nvSpPr>
@@ -8574,7 +8734,7 @@
       </p:sp>
       <p:sp>
         <p:nvSpPr>
-          <p:cNvPr id="47" name="TextBox 46"/>
+          <p:cNvPr id="49" name="TextBox 48"/>
           <p:cNvSpPr txBox="1"/>
           <p:nvPr/>
         </p:nvSpPr>
@@ -8613,7 +8773,7 @@
       </p:sp>
       <p:sp>
         <p:nvSpPr>
-          <p:cNvPr id="48" name="TextBox 47"/>
+          <p:cNvPr id="50" name="TextBox 49"/>
           <p:cNvSpPr txBox="1"/>
           <p:nvPr/>
         </p:nvSpPr>
@@ -11087,6 +11247,1694 @@
     <p:bg>
       <p:bgPr>
         <a:solidFill>
+          <a:srgbClr val="FFFFFF"/>
+        </a:solidFill>
+        <a:effectLst/>
+      </p:bgPr>
+    </p:bg>
+    <p:spTree>
+      <p:nvGrpSpPr>
+        <p:cNvPr id="1" name=""/>
+        <p:cNvGrpSpPr/>
+        <p:nvPr/>
+      </p:nvGrpSpPr>
+      <p:grpSpPr/>
+      <p:sp>
+        <p:nvSpPr>
+          <p:cNvPr id="2" name="TextBox 1"/>
+          <p:cNvSpPr txBox="1"/>
+          <p:nvPr/>
+        </p:nvSpPr>
+        <p:spPr>
+          <a:xfrm>
+            <a:off x="548640" y="365760"/>
+            <a:ext cx="11064240" cy="274320"/>
+          </a:xfrm>
+          <a:prstGeom prst="rect">
+            <a:avLst/>
+          </a:prstGeom>
+          <a:noFill/>
+        </p:spPr>
+        <p:txBody>
+          <a:bodyPr wrap="square" anchor="t" lIns="0" rIns="0" tIns="0" bIns="0">
+            <a:spAutoFit/>
+          </a:bodyPr>
+          <a:lstStyle/>
+          <a:p>
+            <a:pPr algn="l">
+              <a:spcAft>
+                <a:spcPts val="400"/>
+              </a:spcAft>
+            </a:pPr>
+            <a:r>
+              <a:rPr sz="1000" b="1">
+                <a:solidFill>
+                  <a:srgbClr val="7A808A"/>
+                </a:solidFill>
+                <a:latin typeface="Segoe UI"/>
+              </a:rPr>
+              <a:t>ROADMAP</a:t>
+            </a:r>
+          </a:p>
+        </p:txBody>
+      </p:sp>
+      <p:sp>
+        <p:nvSpPr>
+          <p:cNvPr id="3" name="TextBox 2"/>
+          <p:cNvSpPr txBox="1"/>
+          <p:nvPr/>
+        </p:nvSpPr>
+        <p:spPr>
+          <a:xfrm>
+            <a:off x="548640" y="640080"/>
+            <a:ext cx="11064240" cy="548640"/>
+          </a:xfrm>
+          <a:prstGeom prst="rect">
+            <a:avLst/>
+          </a:prstGeom>
+          <a:noFill/>
+        </p:spPr>
+        <p:txBody>
+          <a:bodyPr wrap="square" anchor="t" lIns="0" rIns="0" tIns="0" bIns="0">
+            <a:spAutoFit/>
+          </a:bodyPr>
+          <a:lstStyle/>
+          <a:p>
+            <a:pPr algn="l">
+              <a:spcAft>
+                <a:spcPts val="400"/>
+              </a:spcAft>
+            </a:pPr>
+            <a:r>
+              <a:rPr sz="2600" b="1">
+                <a:solidFill>
+                  <a:srgbClr val="1B2A41"/>
+                </a:solidFill>
+                <a:latin typeface="Segoe UI"/>
+              </a:rPr>
+              <a:t>The self-service catalogue, phased</a:t>
+            </a:r>
+          </a:p>
+        </p:txBody>
+      </p:sp>
+      <p:sp>
+        <p:nvSpPr>
+          <p:cNvPr id="4" name="Rectangle 3"/>
+          <p:cNvSpPr/>
+          <p:nvPr/>
+        </p:nvSpPr>
+        <p:spPr>
+          <a:xfrm>
+            <a:off x="566928" y="1261872"/>
+            <a:ext cx="914400" cy="32004"/>
+          </a:xfrm>
+          <a:prstGeom prst="rect">
+            <a:avLst/>
+          </a:prstGeom>
+          <a:solidFill>
+            <a:srgbClr val="2E74B5"/>
+          </a:solidFill>
+          <a:ln>
+            <a:noFill/>
+          </a:ln>
+          <a:effectLst/>
+        </p:spPr>
+        <p:style>
+          <a:lnRef idx="1">
+            <a:schemeClr val="accent1"/>
+          </a:lnRef>
+          <a:fillRef idx="3">
+            <a:schemeClr val="accent1"/>
+          </a:fillRef>
+          <a:effectRef idx="2">
+            <a:schemeClr val="accent1"/>
+          </a:effectRef>
+          <a:fontRef idx="minor">
+            <a:schemeClr val="lt1"/>
+          </a:fontRef>
+        </p:style>
+        <p:txBody>
+          <a:bodyPr rtlCol="0" anchor="ctr"/>
+          <a:lstStyle/>
+          <a:p>
+            <a:pPr algn="ctr"/>
+          </a:p>
+        </p:txBody>
+      </p:sp>
+      <p:sp>
+        <p:nvSpPr>
+          <p:cNvPr id="5" name="TextBox 4"/>
+          <p:cNvSpPr txBox="1"/>
+          <p:nvPr/>
+        </p:nvSpPr>
+        <p:spPr>
+          <a:xfrm>
+            <a:off x="548640" y="1371600"/>
+            <a:ext cx="11064240" cy="320040"/>
+          </a:xfrm>
+          <a:prstGeom prst="rect">
+            <a:avLst/>
+          </a:prstGeom>
+          <a:noFill/>
+        </p:spPr>
+        <p:txBody>
+          <a:bodyPr wrap="square" anchor="t" lIns="0" rIns="0" tIns="0" bIns="0">
+            <a:spAutoFit/>
+          </a:bodyPr>
+          <a:lstStyle/>
+          <a:p>
+            <a:pPr algn="l">
+              <a:spcAft>
+                <a:spcPts val="400"/>
+              </a:spcAft>
+            </a:pPr>
+            <a:r>
+              <a:rPr sz="1100" b="0">
+                <a:solidFill>
+                  <a:srgbClr val="7A808A"/>
+                </a:solidFill>
+                <a:latin typeface="Segoe UI"/>
+              </a:rPr>
+              <a:t>Every service below is already designed and demoable in the portal prototype — the roadmap is activation order, not invention.</a:t>
+            </a:r>
+          </a:p>
+        </p:txBody>
+      </p:sp>
+      <p:pic>
+        <p:nvPicPr>
+          <p:cNvPr id="6" name="Picture 5" descr="selfservice_snippet.png"/>
+          <p:cNvPicPr>
+            <a:picLocks noChangeAspect="1"/>
+          </p:cNvPicPr>
+          <p:nvPr/>
+        </p:nvPicPr>
+        <p:blipFill>
+          <a:blip r:embed="rId2"/>
+          <a:stretch>
+            <a:fillRect/>
+          </a:stretch>
+        </p:blipFill>
+        <p:spPr>
+          <a:xfrm>
+            <a:off x="548640" y="1874519"/>
+            <a:ext cx="5074920" cy="2637503"/>
+          </a:xfrm>
+          <a:prstGeom prst="rect">
+            <a:avLst/>
+          </a:prstGeom>
+          <a:effectLst/>
+        </p:spPr>
+      </p:pic>
+      <p:sp>
+        <p:nvSpPr>
+          <p:cNvPr id="7" name="TextBox 6"/>
+          <p:cNvSpPr txBox="1"/>
+          <p:nvPr/>
+        </p:nvSpPr>
+        <p:spPr>
+          <a:xfrm>
+            <a:off x="548640" y="4572000"/>
+            <a:ext cx="5074920" cy="502920"/>
+          </a:xfrm>
+          <a:prstGeom prst="rect">
+            <a:avLst/>
+          </a:prstGeom>
+          <a:noFill/>
+        </p:spPr>
+        <p:txBody>
+          <a:bodyPr wrap="square" anchor="t" lIns="0" rIns="0" tIns="0" bIns="0">
+            <a:spAutoFit/>
+          </a:bodyPr>
+          <a:lstStyle/>
+          <a:p>
+            <a:pPr algn="l">
+              <a:spcAft>
+                <a:spcPts val="100"/>
+              </a:spcAft>
+            </a:pPr>
+            <a:r>
+              <a:rPr sz="950" b="1">
+                <a:solidFill>
+                  <a:srgbClr val="1B2A41"/>
+                </a:solidFill>
+                <a:latin typeface="Segoe UI"/>
+              </a:rPr>
+              <a:t>The prototype today — 11 services, one design language</a:t>
+            </a:r>
+          </a:p>
+          <a:p>
+            <a:pPr algn="l">
+              <a:spcAft>
+                <a:spcPts val="100"/>
+              </a:spcAft>
+            </a:pPr>
+            <a:r>
+              <a:rPr sz="850" b="0">
+                <a:solidFill>
+                  <a:srgbClr val="7A808A"/>
+                </a:solidFill>
+                <a:latin typeface="Segoe UI"/>
+              </a:rPr>
+              <a:t>source: docs/ui-ux-design/mockups/backstage-catalog-v2.html</a:t>
+            </a:r>
+          </a:p>
+        </p:txBody>
+      </p:sp>
+      <p:sp>
+        <p:nvSpPr>
+          <p:cNvPr id="8" name="TextBox 7"/>
+          <p:cNvSpPr txBox="1"/>
+          <p:nvPr/>
+        </p:nvSpPr>
+        <p:spPr>
+          <a:xfrm>
+            <a:off x="5943600" y="1810512"/>
+            <a:ext cx="5669280" cy="219456"/>
+          </a:xfrm>
+          <a:prstGeom prst="rect">
+            <a:avLst/>
+          </a:prstGeom>
+          <a:noFill/>
+        </p:spPr>
+        <p:txBody>
+          <a:bodyPr wrap="square" anchor="t" lIns="0" rIns="0" tIns="0" bIns="0">
+            <a:spAutoFit/>
+          </a:bodyPr>
+          <a:lstStyle/>
+          <a:p>
+            <a:pPr algn="l">
+              <a:spcAft>
+                <a:spcPts val="400"/>
+              </a:spcAft>
+            </a:pPr>
+            <a:r>
+              <a:rPr sz="950" b="1">
+                <a:solidFill>
+                  <a:srgbClr val="2E74B5"/>
+                </a:solidFill>
+                <a:latin typeface="Segoe UI"/>
+              </a:rPr>
+              <a:t>Q3 2026 — FOUNDATION</a:t>
+            </a:r>
+          </a:p>
+        </p:txBody>
+      </p:sp>
+      <p:sp>
+        <p:nvSpPr>
+          <p:cNvPr id="9" name="Rectangle 8"/>
+          <p:cNvSpPr/>
+          <p:nvPr/>
+        </p:nvSpPr>
+        <p:spPr>
+          <a:xfrm>
+            <a:off x="5943600" y="2103120"/>
+            <a:ext cx="73152" cy="73152"/>
+          </a:xfrm>
+          <a:prstGeom prst="rect">
+            <a:avLst/>
+          </a:prstGeom>
+          <a:solidFill>
+            <a:srgbClr val="1B2A41"/>
+          </a:solidFill>
+          <a:ln>
+            <a:noFill/>
+          </a:ln>
+          <a:effectLst/>
+        </p:spPr>
+        <p:style>
+          <a:lnRef idx="1">
+            <a:schemeClr val="accent1"/>
+          </a:lnRef>
+          <a:fillRef idx="3">
+            <a:schemeClr val="accent1"/>
+          </a:fillRef>
+          <a:effectRef idx="2">
+            <a:schemeClr val="accent1"/>
+          </a:effectRef>
+          <a:fontRef idx="minor">
+            <a:schemeClr val="lt1"/>
+          </a:fontRef>
+        </p:style>
+        <p:txBody>
+          <a:bodyPr rtlCol="0" anchor="ctr"/>
+          <a:lstStyle/>
+          <a:p>
+            <a:pPr algn="ctr"/>
+          </a:p>
+        </p:txBody>
+      </p:sp>
+      <p:sp>
+        <p:nvSpPr>
+          <p:cNvPr id="10" name="TextBox 9"/>
+          <p:cNvSpPr txBox="1"/>
+          <p:nvPr/>
+        </p:nvSpPr>
+        <p:spPr>
+          <a:xfrm>
+            <a:off x="6144768" y="2048256"/>
+            <a:ext cx="5486400" cy="274320"/>
+          </a:xfrm>
+          <a:prstGeom prst="rect">
+            <a:avLst/>
+          </a:prstGeom>
+          <a:noFill/>
+        </p:spPr>
+        <p:txBody>
+          <a:bodyPr wrap="square" anchor="t" lIns="0" rIns="0" tIns="0" bIns="0">
+            <a:spAutoFit/>
+          </a:bodyPr>
+          <a:lstStyle/>
+          <a:p>
+            <a:pPr algn="l">
+              <a:spcAft>
+                <a:spcPts val="0"/>
+              </a:spcAft>
+            </a:pPr>
+            <a:r>
+              <a:rPr sz="950" b="1">
+                <a:solidFill>
+                  <a:srgbClr val="1B2A41"/>
+                </a:solidFill>
+                <a:latin typeface="Segoe UI"/>
+              </a:rPr>
+              <a:t>Add Monitoring</a:t>
+            </a:r>
+            <a:r>
+              <a:rPr sz="900" b="0">
+                <a:solidFill>
+                  <a:srgbClr val="40444B"/>
+                </a:solidFill>
+                <a:latin typeface="Segoe UI"/>
+              </a:rPr>
+              <a:t> — CMD, log &amp; process alerts, auto-routed — DX UIM live; production hardening due 30 Sep</a:t>
+            </a:r>
+          </a:p>
+        </p:txBody>
+      </p:sp>
+      <p:sp>
+        <p:nvSpPr>
+          <p:cNvPr id="11" name="Rectangle 10"/>
+          <p:cNvSpPr/>
+          <p:nvPr/>
+        </p:nvSpPr>
+        <p:spPr>
+          <a:xfrm>
+            <a:off x="5943600" y="2368296"/>
+            <a:ext cx="73152" cy="73152"/>
+          </a:xfrm>
+          <a:prstGeom prst="rect">
+            <a:avLst/>
+          </a:prstGeom>
+          <a:solidFill>
+            <a:srgbClr val="1B2A41"/>
+          </a:solidFill>
+          <a:ln>
+            <a:noFill/>
+          </a:ln>
+          <a:effectLst/>
+        </p:spPr>
+        <p:style>
+          <a:lnRef idx="1">
+            <a:schemeClr val="accent1"/>
+          </a:lnRef>
+          <a:fillRef idx="3">
+            <a:schemeClr val="accent1"/>
+          </a:fillRef>
+          <a:effectRef idx="2">
+            <a:schemeClr val="accent1"/>
+          </a:effectRef>
+          <a:fontRef idx="minor">
+            <a:schemeClr val="lt1"/>
+          </a:fontRef>
+        </p:style>
+        <p:txBody>
+          <a:bodyPr rtlCol="0" anchor="ctr"/>
+          <a:lstStyle/>
+          <a:p>
+            <a:pPr algn="ctr"/>
+          </a:p>
+        </p:txBody>
+      </p:sp>
+      <p:sp>
+        <p:nvSpPr>
+          <p:cNvPr id="12" name="TextBox 11"/>
+          <p:cNvSpPr txBox="1"/>
+          <p:nvPr/>
+        </p:nvSpPr>
+        <p:spPr>
+          <a:xfrm>
+            <a:off x="6144768" y="2313432"/>
+            <a:ext cx="5486400" cy="274320"/>
+          </a:xfrm>
+          <a:prstGeom prst="rect">
+            <a:avLst/>
+          </a:prstGeom>
+          <a:noFill/>
+        </p:spPr>
+        <p:txBody>
+          <a:bodyPr wrap="square" anchor="t" lIns="0" rIns="0" tIns="0" bIns="0">
+            <a:spAutoFit/>
+          </a:bodyPr>
+          <a:lstStyle/>
+          <a:p>
+            <a:pPr algn="l">
+              <a:spcAft>
+                <a:spcPts val="0"/>
+              </a:spcAft>
+            </a:pPr>
+            <a:r>
+              <a:rPr sz="950" b="1">
+                <a:solidFill>
+                  <a:srgbClr val="1B2A41"/>
+                </a:solidFill>
+                <a:latin typeface="Segoe UI"/>
+              </a:rPr>
+              <a:t>Register Asset</a:t>
+            </a:r>
+            <a:r>
+              <a:rPr sz="900" b="0">
+                <a:solidFill>
+                  <a:srgbClr val="40444B"/>
+                </a:solidFill>
+                <a:latin typeface="Segoe UI"/>
+              </a:rPr>
+              <a:t> — ad-hoc registration of servers and dashboards into the catalog</a:t>
+            </a:r>
+          </a:p>
+        </p:txBody>
+      </p:sp>
+      <p:sp>
+        <p:nvSpPr>
+          <p:cNvPr id="13" name="TextBox 12"/>
+          <p:cNvSpPr txBox="1"/>
+          <p:nvPr/>
+        </p:nvSpPr>
+        <p:spPr>
+          <a:xfrm>
+            <a:off x="5943600" y="2670048"/>
+            <a:ext cx="5669280" cy="219456"/>
+          </a:xfrm>
+          <a:prstGeom prst="rect">
+            <a:avLst/>
+          </a:prstGeom>
+          <a:noFill/>
+        </p:spPr>
+        <p:txBody>
+          <a:bodyPr wrap="square" anchor="t" lIns="0" rIns="0" tIns="0" bIns="0">
+            <a:spAutoFit/>
+          </a:bodyPr>
+          <a:lstStyle/>
+          <a:p>
+            <a:pPr algn="l">
+              <a:spcAft>
+                <a:spcPts val="400"/>
+              </a:spcAft>
+            </a:pPr>
+            <a:r>
+              <a:rPr sz="950" b="1">
+                <a:solidFill>
+                  <a:srgbClr val="2E74B5"/>
+                </a:solidFill>
+                <a:latin typeface="Segoe UI"/>
+              </a:rPr>
+              <a:t>Q4 2026 — LOGS &amp; AGENTS</a:t>
+            </a:r>
+          </a:p>
+        </p:txBody>
+      </p:sp>
+      <p:sp>
+        <p:nvSpPr>
+          <p:cNvPr id="14" name="Rectangle 13"/>
+          <p:cNvSpPr/>
+          <p:nvPr/>
+        </p:nvSpPr>
+        <p:spPr>
+          <a:xfrm>
+            <a:off x="5943600" y="2962656"/>
+            <a:ext cx="73152" cy="73152"/>
+          </a:xfrm>
+          <a:prstGeom prst="rect">
+            <a:avLst/>
+          </a:prstGeom>
+          <a:solidFill>
+            <a:srgbClr val="1B2A41"/>
+          </a:solidFill>
+          <a:ln>
+            <a:noFill/>
+          </a:ln>
+          <a:effectLst/>
+        </p:spPr>
+        <p:style>
+          <a:lnRef idx="1">
+            <a:schemeClr val="accent1"/>
+          </a:lnRef>
+          <a:fillRef idx="3">
+            <a:schemeClr val="accent1"/>
+          </a:fillRef>
+          <a:effectRef idx="2">
+            <a:schemeClr val="accent1"/>
+          </a:effectRef>
+          <a:fontRef idx="minor">
+            <a:schemeClr val="lt1"/>
+          </a:fontRef>
+        </p:style>
+        <p:txBody>
+          <a:bodyPr rtlCol="0" anchor="ctr"/>
+          <a:lstStyle/>
+          <a:p>
+            <a:pPr algn="ctr"/>
+          </a:p>
+        </p:txBody>
+      </p:sp>
+      <p:sp>
+        <p:nvSpPr>
+          <p:cNvPr id="15" name="TextBox 14"/>
+          <p:cNvSpPr txBox="1"/>
+          <p:nvPr/>
+        </p:nvSpPr>
+        <p:spPr>
+          <a:xfrm>
+            <a:off x="6144768" y="2907792"/>
+            <a:ext cx="5486400" cy="274320"/>
+          </a:xfrm>
+          <a:prstGeom prst="rect">
+            <a:avLst/>
+          </a:prstGeom>
+          <a:noFill/>
+        </p:spPr>
+        <p:txBody>
+          <a:bodyPr wrap="square" anchor="t" lIns="0" rIns="0" tIns="0" bIns="0">
+            <a:spAutoFit/>
+          </a:bodyPr>
+          <a:lstStyle/>
+          <a:p>
+            <a:pPr algn="l">
+              <a:spcAft>
+                <a:spcPts val="0"/>
+              </a:spcAft>
+            </a:pPr>
+            <a:r>
+              <a:rPr sz="950" b="1">
+                <a:solidFill>
+                  <a:srgbClr val="1B2A41"/>
+                </a:solidFill>
+                <a:latin typeface="Segoe UI"/>
+              </a:rPr>
+              <a:t>ELK Log Onboarding</a:t>
+            </a:r>
+            <a:r>
+              <a:rPr sz="900" b="0">
+                <a:solidFill>
+                  <a:srgbClr val="40444B"/>
+                </a:solidFill>
+                <a:latin typeface="Segoe UI"/>
+              </a:rPr>
+              <a:t> — agents, Kafka topic, parsers, indices — one request, one engineer review</a:t>
+            </a:r>
+          </a:p>
+        </p:txBody>
+      </p:sp>
+      <p:sp>
+        <p:nvSpPr>
+          <p:cNvPr id="16" name="Rectangle 15"/>
+          <p:cNvSpPr/>
+          <p:nvPr/>
+        </p:nvSpPr>
+        <p:spPr>
+          <a:xfrm>
+            <a:off x="5943600" y="3227832"/>
+            <a:ext cx="73152" cy="73152"/>
+          </a:xfrm>
+          <a:prstGeom prst="rect">
+            <a:avLst/>
+          </a:prstGeom>
+          <a:solidFill>
+            <a:srgbClr val="1B2A41"/>
+          </a:solidFill>
+          <a:ln>
+            <a:noFill/>
+          </a:ln>
+          <a:effectLst/>
+        </p:spPr>
+        <p:style>
+          <a:lnRef idx="1">
+            <a:schemeClr val="accent1"/>
+          </a:lnRef>
+          <a:fillRef idx="3">
+            <a:schemeClr val="accent1"/>
+          </a:fillRef>
+          <a:effectRef idx="2">
+            <a:schemeClr val="accent1"/>
+          </a:effectRef>
+          <a:fontRef idx="minor">
+            <a:schemeClr val="lt1"/>
+          </a:fontRef>
+        </p:style>
+        <p:txBody>
+          <a:bodyPr rtlCol="0" anchor="ctr"/>
+          <a:lstStyle/>
+          <a:p>
+            <a:pPr algn="ctr"/>
+          </a:p>
+        </p:txBody>
+      </p:sp>
+      <p:sp>
+        <p:nvSpPr>
+          <p:cNvPr id="17" name="TextBox 16"/>
+          <p:cNvSpPr txBox="1"/>
+          <p:nvPr/>
+        </p:nvSpPr>
+        <p:spPr>
+          <a:xfrm>
+            <a:off x="6144768" y="3172968"/>
+            <a:ext cx="5486400" cy="274320"/>
+          </a:xfrm>
+          <a:prstGeom prst="rect">
+            <a:avLst/>
+          </a:prstGeom>
+          <a:noFill/>
+        </p:spPr>
+        <p:txBody>
+          <a:bodyPr wrap="square" anchor="t" lIns="0" rIns="0" tIns="0" bIns="0">
+            <a:spAutoFit/>
+          </a:bodyPr>
+          <a:lstStyle/>
+          <a:p>
+            <a:pPr algn="l">
+              <a:spcAft>
+                <a:spcPts val="0"/>
+              </a:spcAft>
+            </a:pPr>
+            <a:r>
+              <a:rPr sz="950" b="1">
+                <a:solidFill>
+                  <a:srgbClr val="1B2A41"/>
+                </a:solidFill>
+                <a:latin typeface="Segoe UI"/>
+              </a:rPr>
+              <a:t>Install Agent</a:t>
+            </a:r>
+            <a:r>
+              <a:rPr sz="900" b="0">
+                <a:solidFill>
+                  <a:srgbClr val="40444B"/>
+                </a:solidFill>
+                <a:latin typeface="Segoe UI"/>
+              </a:rPr>
+              <a:t> — the right agents per host — ELK, DX UIM robot, OTel — only what is missing</a:t>
+            </a:r>
+          </a:p>
+        </p:txBody>
+      </p:sp>
+      <p:sp>
+        <p:nvSpPr>
+          <p:cNvPr id="18" name="Rectangle 17"/>
+          <p:cNvSpPr/>
+          <p:nvPr/>
+        </p:nvSpPr>
+        <p:spPr>
+          <a:xfrm>
+            <a:off x="5943600" y="3493008"/>
+            <a:ext cx="73152" cy="73152"/>
+          </a:xfrm>
+          <a:prstGeom prst="rect">
+            <a:avLst/>
+          </a:prstGeom>
+          <a:solidFill>
+            <a:srgbClr val="1B2A41"/>
+          </a:solidFill>
+          <a:ln>
+            <a:noFill/>
+          </a:ln>
+          <a:effectLst/>
+        </p:spPr>
+        <p:style>
+          <a:lnRef idx="1">
+            <a:schemeClr val="accent1"/>
+          </a:lnRef>
+          <a:fillRef idx="3">
+            <a:schemeClr val="accent1"/>
+          </a:fillRef>
+          <a:effectRef idx="2">
+            <a:schemeClr val="accent1"/>
+          </a:effectRef>
+          <a:fontRef idx="minor">
+            <a:schemeClr val="lt1"/>
+          </a:fontRef>
+        </p:style>
+        <p:txBody>
+          <a:bodyPr rtlCol="0" anchor="ctr"/>
+          <a:lstStyle/>
+          <a:p>
+            <a:pPr algn="ctr"/>
+          </a:p>
+        </p:txBody>
+      </p:sp>
+      <p:sp>
+        <p:nvSpPr>
+          <p:cNvPr id="19" name="TextBox 18"/>
+          <p:cNvSpPr txBox="1"/>
+          <p:nvPr/>
+        </p:nvSpPr>
+        <p:spPr>
+          <a:xfrm>
+            <a:off x="6144768" y="3438144"/>
+            <a:ext cx="5486400" cy="274320"/>
+          </a:xfrm>
+          <a:prstGeom prst="rect">
+            <a:avLst/>
+          </a:prstGeom>
+          <a:noFill/>
+        </p:spPr>
+        <p:txBody>
+          <a:bodyPr wrap="square" anchor="t" lIns="0" rIns="0" tIns="0" bIns="0">
+            <a:spAutoFit/>
+          </a:bodyPr>
+          <a:lstStyle/>
+          <a:p>
+            <a:pPr algn="l">
+              <a:spcAft>
+                <a:spcPts val="0"/>
+              </a:spcAft>
+            </a:pPr>
+            <a:r>
+              <a:rPr sz="950" b="1">
+                <a:solidFill>
+                  <a:srgbClr val="1B2A41"/>
+                </a:solidFill>
+                <a:latin typeface="Segoe UI"/>
+              </a:rPr>
+              <a:t>Request Log Access</a:t>
+            </a:r>
+            <a:r>
+              <a:rPr sz="900" b="0">
+                <a:solidFill>
+                  <a:srgbClr val="40444B"/>
+                </a:solidFill>
+                <a:latin typeface="Segoe UI"/>
+              </a:rPr>
+              <a:t> — read-only ELK index access — see what each index holds, request the rest</a:t>
+            </a:r>
+          </a:p>
+        </p:txBody>
+      </p:sp>
+      <p:sp>
+        <p:nvSpPr>
+          <p:cNvPr id="20" name="TextBox 19"/>
+          <p:cNvSpPr txBox="1"/>
+          <p:nvPr/>
+        </p:nvSpPr>
+        <p:spPr>
+          <a:xfrm>
+            <a:off x="5943600" y="3794760"/>
+            <a:ext cx="5669280" cy="219456"/>
+          </a:xfrm>
+          <a:prstGeom prst="rect">
+            <a:avLst/>
+          </a:prstGeom>
+          <a:noFill/>
+        </p:spPr>
+        <p:txBody>
+          <a:bodyPr wrap="square" anchor="t" lIns="0" rIns="0" tIns="0" bIns="0">
+            <a:spAutoFit/>
+          </a:bodyPr>
+          <a:lstStyle/>
+          <a:p>
+            <a:pPr algn="l">
+              <a:spcAft>
+                <a:spcPts val="400"/>
+              </a:spcAft>
+            </a:pPr>
+            <a:r>
+              <a:rPr sz="950" b="1">
+                <a:solidFill>
+                  <a:srgbClr val="2E74B5"/>
+                </a:solidFill>
+                <a:latin typeface="Segoe UI"/>
+              </a:rPr>
+              <a:t>Q1 2027 — VISIBILITY</a:t>
+            </a:r>
+          </a:p>
+        </p:txBody>
+      </p:sp>
+      <p:sp>
+        <p:nvSpPr>
+          <p:cNvPr id="21" name="Rectangle 20"/>
+          <p:cNvSpPr/>
+          <p:nvPr/>
+        </p:nvSpPr>
+        <p:spPr>
+          <a:xfrm>
+            <a:off x="5943600" y="4087368"/>
+            <a:ext cx="73152" cy="73152"/>
+          </a:xfrm>
+          <a:prstGeom prst="rect">
+            <a:avLst/>
+          </a:prstGeom>
+          <a:solidFill>
+            <a:srgbClr val="1B2A41"/>
+          </a:solidFill>
+          <a:ln>
+            <a:noFill/>
+          </a:ln>
+          <a:effectLst/>
+        </p:spPr>
+        <p:style>
+          <a:lnRef idx="1">
+            <a:schemeClr val="accent1"/>
+          </a:lnRef>
+          <a:fillRef idx="3">
+            <a:schemeClr val="accent1"/>
+          </a:fillRef>
+          <a:effectRef idx="2">
+            <a:schemeClr val="accent1"/>
+          </a:effectRef>
+          <a:fontRef idx="minor">
+            <a:schemeClr val="lt1"/>
+          </a:fontRef>
+        </p:style>
+        <p:txBody>
+          <a:bodyPr rtlCol="0" anchor="ctr"/>
+          <a:lstStyle/>
+          <a:p>
+            <a:pPr algn="ctr"/>
+          </a:p>
+        </p:txBody>
+      </p:sp>
+      <p:sp>
+        <p:nvSpPr>
+          <p:cNvPr id="22" name="TextBox 21"/>
+          <p:cNvSpPr txBox="1"/>
+          <p:nvPr/>
+        </p:nvSpPr>
+        <p:spPr>
+          <a:xfrm>
+            <a:off x="6144768" y="4032504"/>
+            <a:ext cx="5486400" cy="274320"/>
+          </a:xfrm>
+          <a:prstGeom prst="rect">
+            <a:avLst/>
+          </a:prstGeom>
+          <a:noFill/>
+        </p:spPr>
+        <p:txBody>
+          <a:bodyPr wrap="square" anchor="t" lIns="0" rIns="0" tIns="0" bIns="0">
+            <a:spAutoFit/>
+          </a:bodyPr>
+          <a:lstStyle/>
+          <a:p>
+            <a:pPr algn="l">
+              <a:spcAft>
+                <a:spcPts val="0"/>
+              </a:spcAft>
+            </a:pPr>
+            <a:r>
+              <a:rPr sz="950" b="1">
+                <a:solidFill>
+                  <a:srgbClr val="1B2A41"/>
+                </a:solidFill>
+                <a:latin typeface="Segoe UI"/>
+              </a:rPr>
+              <a:t>Reports</a:t>
+            </a:r>
+            <a:r>
+              <a:rPr sz="900" b="0">
+                <a:solidFill>
+                  <a:srgbClr val="40444B"/>
+                </a:solidFill>
+                <a:latin typeface="Segoe UI"/>
+              </a:rPr>
+              <a:t> — daily reconciliation — assets missing from ELK, unmonitored, or drifted</a:t>
+            </a:r>
+          </a:p>
+        </p:txBody>
+      </p:sp>
+      <p:sp>
+        <p:nvSpPr>
+          <p:cNvPr id="23" name="Rectangle 22"/>
+          <p:cNvSpPr/>
+          <p:nvPr/>
+        </p:nvSpPr>
+        <p:spPr>
+          <a:xfrm>
+            <a:off x="5943600" y="4352544"/>
+            <a:ext cx="73152" cy="73152"/>
+          </a:xfrm>
+          <a:prstGeom prst="rect">
+            <a:avLst/>
+          </a:prstGeom>
+          <a:solidFill>
+            <a:srgbClr val="1B2A41"/>
+          </a:solidFill>
+          <a:ln>
+            <a:noFill/>
+          </a:ln>
+          <a:effectLst/>
+        </p:spPr>
+        <p:style>
+          <a:lnRef idx="1">
+            <a:schemeClr val="accent1"/>
+          </a:lnRef>
+          <a:fillRef idx="3">
+            <a:schemeClr val="accent1"/>
+          </a:fillRef>
+          <a:effectRef idx="2">
+            <a:schemeClr val="accent1"/>
+          </a:effectRef>
+          <a:fontRef idx="minor">
+            <a:schemeClr val="lt1"/>
+          </a:fontRef>
+        </p:style>
+        <p:txBody>
+          <a:bodyPr rtlCol="0" anchor="ctr"/>
+          <a:lstStyle/>
+          <a:p>
+            <a:pPr algn="ctr"/>
+          </a:p>
+        </p:txBody>
+      </p:sp>
+      <p:sp>
+        <p:nvSpPr>
+          <p:cNvPr id="24" name="TextBox 23"/>
+          <p:cNvSpPr txBox="1"/>
+          <p:nvPr/>
+        </p:nvSpPr>
+        <p:spPr>
+          <a:xfrm>
+            <a:off x="6144768" y="4297680"/>
+            <a:ext cx="5486400" cy="274320"/>
+          </a:xfrm>
+          <a:prstGeom prst="rect">
+            <a:avLst/>
+          </a:prstGeom>
+          <a:noFill/>
+        </p:spPr>
+        <p:txBody>
+          <a:bodyPr wrap="square" anchor="t" lIns="0" rIns="0" tIns="0" bIns="0">
+            <a:spAutoFit/>
+          </a:bodyPr>
+          <a:lstStyle/>
+          <a:p>
+            <a:pPr algn="l">
+              <a:spcAft>
+                <a:spcPts val="0"/>
+              </a:spcAft>
+            </a:pPr>
+            <a:r>
+              <a:rPr sz="950" b="1">
+                <a:solidFill>
+                  <a:srgbClr val="1B2A41"/>
+                </a:solidFill>
+                <a:latin typeface="Segoe UI"/>
+              </a:rPr>
+              <a:t>Dashboard Inventory</a:t>
+            </a:r>
+            <a:r>
+              <a:rPr sz="900" b="0">
+                <a:solidFill>
+                  <a:srgbClr val="40444B"/>
+                </a:solidFill>
+                <a:latin typeface="Segoe UI"/>
+              </a:rPr>
+              <a:t> — every dashboard described and linked — one page, always current</a:t>
+            </a:r>
+          </a:p>
+        </p:txBody>
+      </p:sp>
+      <p:sp>
+        <p:nvSpPr>
+          <p:cNvPr id="25" name="Rectangle 24"/>
+          <p:cNvSpPr/>
+          <p:nvPr/>
+        </p:nvSpPr>
+        <p:spPr>
+          <a:xfrm>
+            <a:off x="5943600" y="4617720"/>
+            <a:ext cx="73152" cy="73152"/>
+          </a:xfrm>
+          <a:prstGeom prst="rect">
+            <a:avLst/>
+          </a:prstGeom>
+          <a:solidFill>
+            <a:srgbClr val="1B2A41"/>
+          </a:solidFill>
+          <a:ln>
+            <a:noFill/>
+          </a:ln>
+          <a:effectLst/>
+        </p:spPr>
+        <p:style>
+          <a:lnRef idx="1">
+            <a:schemeClr val="accent1"/>
+          </a:lnRef>
+          <a:fillRef idx="3">
+            <a:schemeClr val="accent1"/>
+          </a:fillRef>
+          <a:effectRef idx="2">
+            <a:schemeClr val="accent1"/>
+          </a:effectRef>
+          <a:fontRef idx="minor">
+            <a:schemeClr val="lt1"/>
+          </a:fontRef>
+        </p:style>
+        <p:txBody>
+          <a:bodyPr rtlCol="0" anchor="ctr"/>
+          <a:lstStyle/>
+          <a:p>
+            <a:pPr algn="ctr"/>
+          </a:p>
+        </p:txBody>
+      </p:sp>
+      <p:sp>
+        <p:nvSpPr>
+          <p:cNvPr id="26" name="TextBox 25"/>
+          <p:cNvSpPr txBox="1"/>
+          <p:nvPr/>
+        </p:nvSpPr>
+        <p:spPr>
+          <a:xfrm>
+            <a:off x="6144768" y="4562856"/>
+            <a:ext cx="5486400" cy="274320"/>
+          </a:xfrm>
+          <a:prstGeom prst="rect">
+            <a:avLst/>
+          </a:prstGeom>
+          <a:noFill/>
+        </p:spPr>
+        <p:txBody>
+          <a:bodyPr wrap="square" anchor="t" lIns="0" rIns="0" tIns="0" bIns="0">
+            <a:spAutoFit/>
+          </a:bodyPr>
+          <a:lstStyle/>
+          <a:p>
+            <a:pPr algn="l">
+              <a:spcAft>
+                <a:spcPts val="0"/>
+              </a:spcAft>
+            </a:pPr>
+            <a:r>
+              <a:rPr sz="950" b="1">
+                <a:solidFill>
+                  <a:srgbClr val="1B2A41"/>
+                </a:solidFill>
+                <a:latin typeface="Segoe UI"/>
+              </a:rPr>
+              <a:t>Data Dictionary</a:t>
+            </a:r>
+            <a:r>
+              <a:rPr sz="900" b="0">
+                <a:solidFill>
+                  <a:srgbClr val="40444B"/>
+                </a:solidFill>
+                <a:latin typeface="Segoe UI"/>
+              </a:rPr>
+              <a:t> — what lives in ELK — every index and its function</a:t>
+            </a:r>
+          </a:p>
+        </p:txBody>
+      </p:sp>
+      <p:sp>
+        <p:nvSpPr>
+          <p:cNvPr id="27" name="TextBox 26"/>
+          <p:cNvSpPr txBox="1"/>
+          <p:nvPr/>
+        </p:nvSpPr>
+        <p:spPr>
+          <a:xfrm>
+            <a:off x="5943600" y="4919472"/>
+            <a:ext cx="5669280" cy="219456"/>
+          </a:xfrm>
+          <a:prstGeom prst="rect">
+            <a:avLst/>
+          </a:prstGeom>
+          <a:noFill/>
+        </p:spPr>
+        <p:txBody>
+          <a:bodyPr wrap="square" anchor="t" lIns="0" rIns="0" tIns="0" bIns="0">
+            <a:spAutoFit/>
+          </a:bodyPr>
+          <a:lstStyle/>
+          <a:p>
+            <a:pPr algn="l">
+              <a:spcAft>
+                <a:spcPts val="400"/>
+              </a:spcAft>
+            </a:pPr>
+            <a:r>
+              <a:rPr sz="950" b="1">
+                <a:solidFill>
+                  <a:srgbClr val="2E74B5"/>
+                </a:solidFill>
+                <a:latin typeface="Segoe UI"/>
+              </a:rPr>
+              <a:t>Q2 2027 — ASSURANCE</a:t>
+            </a:r>
+          </a:p>
+        </p:txBody>
+      </p:sp>
+      <p:sp>
+        <p:nvSpPr>
+          <p:cNvPr id="28" name="Rectangle 27"/>
+          <p:cNvSpPr/>
+          <p:nvPr/>
+        </p:nvSpPr>
+        <p:spPr>
+          <a:xfrm>
+            <a:off x="5943600" y="5212079"/>
+            <a:ext cx="73152" cy="73152"/>
+          </a:xfrm>
+          <a:prstGeom prst="rect">
+            <a:avLst/>
+          </a:prstGeom>
+          <a:solidFill>
+            <a:srgbClr val="1B2A41"/>
+          </a:solidFill>
+          <a:ln>
+            <a:noFill/>
+          </a:ln>
+          <a:effectLst/>
+        </p:spPr>
+        <p:style>
+          <a:lnRef idx="1">
+            <a:schemeClr val="accent1"/>
+          </a:lnRef>
+          <a:fillRef idx="3">
+            <a:schemeClr val="accent1"/>
+          </a:fillRef>
+          <a:effectRef idx="2">
+            <a:schemeClr val="accent1"/>
+          </a:effectRef>
+          <a:fontRef idx="minor">
+            <a:schemeClr val="lt1"/>
+          </a:fontRef>
+        </p:style>
+        <p:txBody>
+          <a:bodyPr rtlCol="0" anchor="ctr"/>
+          <a:lstStyle/>
+          <a:p>
+            <a:pPr algn="ctr"/>
+          </a:p>
+        </p:txBody>
+      </p:sp>
+      <p:sp>
+        <p:nvSpPr>
+          <p:cNvPr id="29" name="TextBox 28"/>
+          <p:cNvSpPr txBox="1"/>
+          <p:nvPr/>
+        </p:nvSpPr>
+        <p:spPr>
+          <a:xfrm>
+            <a:off x="6144768" y="5157216"/>
+            <a:ext cx="5486400" cy="274320"/>
+          </a:xfrm>
+          <a:prstGeom prst="rect">
+            <a:avLst/>
+          </a:prstGeom>
+          <a:noFill/>
+        </p:spPr>
+        <p:txBody>
+          <a:bodyPr wrap="square" anchor="t" lIns="0" rIns="0" tIns="0" bIns="0">
+            <a:spAutoFit/>
+          </a:bodyPr>
+          <a:lstStyle/>
+          <a:p>
+            <a:pPr algn="l">
+              <a:spcAft>
+                <a:spcPts val="0"/>
+              </a:spcAft>
+            </a:pPr>
+            <a:r>
+              <a:rPr sz="950" b="1">
+                <a:solidFill>
+                  <a:srgbClr val="1B2A41"/>
+                </a:solidFill>
+                <a:latin typeface="Segoe UI"/>
+              </a:rPr>
+              <a:t>Observability Score</a:t>
+            </a:r>
+            <a:r>
+              <a:rPr sz="900" b="0">
+                <a:solidFill>
+                  <a:srgbClr val="40444B"/>
+                </a:solidFill>
+                <a:latin typeface="Segoe UI"/>
+              </a:rPr>
+              <a:t> — scorecard and certification level per asset, with remediation links</a:t>
+            </a:r>
+          </a:p>
+        </p:txBody>
+      </p:sp>
+      <p:sp>
+        <p:nvSpPr>
+          <p:cNvPr id="30" name="Rectangle 29"/>
+          <p:cNvSpPr/>
+          <p:nvPr/>
+        </p:nvSpPr>
+        <p:spPr>
+          <a:xfrm>
+            <a:off x="5943600" y="5477255"/>
+            <a:ext cx="73152" cy="73152"/>
+          </a:xfrm>
+          <a:prstGeom prst="rect">
+            <a:avLst/>
+          </a:prstGeom>
+          <a:solidFill>
+            <a:srgbClr val="1B2A41"/>
+          </a:solidFill>
+          <a:ln>
+            <a:noFill/>
+          </a:ln>
+          <a:effectLst/>
+        </p:spPr>
+        <p:style>
+          <a:lnRef idx="1">
+            <a:schemeClr val="accent1"/>
+          </a:lnRef>
+          <a:fillRef idx="3">
+            <a:schemeClr val="accent1"/>
+          </a:fillRef>
+          <a:effectRef idx="2">
+            <a:schemeClr val="accent1"/>
+          </a:effectRef>
+          <a:fontRef idx="minor">
+            <a:schemeClr val="lt1"/>
+          </a:fontRef>
+        </p:style>
+        <p:txBody>
+          <a:bodyPr rtlCol="0" anchor="ctr"/>
+          <a:lstStyle/>
+          <a:p>
+            <a:pPr algn="ctr"/>
+          </a:p>
+        </p:txBody>
+      </p:sp>
+      <p:sp>
+        <p:nvSpPr>
+          <p:cNvPr id="31" name="TextBox 30"/>
+          <p:cNvSpPr txBox="1"/>
+          <p:nvPr/>
+        </p:nvSpPr>
+        <p:spPr>
+          <a:xfrm>
+            <a:off x="6144768" y="5422392"/>
+            <a:ext cx="5486400" cy="274320"/>
+          </a:xfrm>
+          <a:prstGeom prst="rect">
+            <a:avLst/>
+          </a:prstGeom>
+          <a:noFill/>
+        </p:spPr>
+        <p:txBody>
+          <a:bodyPr wrap="square" anchor="t" lIns="0" rIns="0" tIns="0" bIns="0">
+            <a:spAutoFit/>
+          </a:bodyPr>
+          <a:lstStyle/>
+          <a:p>
+            <a:pPr algn="l">
+              <a:spcAft>
+                <a:spcPts val="0"/>
+              </a:spcAft>
+            </a:pPr>
+            <a:r>
+              <a:rPr sz="950" b="1">
+                <a:solidFill>
+                  <a:srgbClr val="1B2A41"/>
+                </a:solidFill>
+                <a:latin typeface="Segoe UI"/>
+              </a:rPr>
+              <a:t>Synthetic Alerting</a:t>
+            </a:r>
+            <a:r>
+              <a:rPr sz="900" b="0">
+                <a:solidFill>
+                  <a:srgbClr val="40444B"/>
+                </a:solidFill>
+                <a:latin typeface="Segoe UI"/>
+              </a:rPr>
+              <a:t> — fire-drill an alert end to end — synthetic event in, [DRILL] ticket out</a:t>
+            </a:r>
+          </a:p>
+        </p:txBody>
+      </p:sp>
+      <p:sp>
+        <p:nvSpPr>
+          <p:cNvPr id="32" name="Rectangle 31"/>
+          <p:cNvSpPr/>
+          <p:nvPr/>
+        </p:nvSpPr>
+        <p:spPr>
+          <a:xfrm>
+            <a:off x="5943600" y="5742431"/>
+            <a:ext cx="73152" cy="73152"/>
+          </a:xfrm>
+          <a:prstGeom prst="rect">
+            <a:avLst/>
+          </a:prstGeom>
+          <a:solidFill>
+            <a:srgbClr val="1B2A41"/>
+          </a:solidFill>
+          <a:ln>
+            <a:noFill/>
+          </a:ln>
+          <a:effectLst/>
+        </p:spPr>
+        <p:style>
+          <a:lnRef idx="1">
+            <a:schemeClr val="accent1"/>
+          </a:lnRef>
+          <a:fillRef idx="3">
+            <a:schemeClr val="accent1"/>
+          </a:fillRef>
+          <a:effectRef idx="2">
+            <a:schemeClr val="accent1"/>
+          </a:effectRef>
+          <a:fontRef idx="minor">
+            <a:schemeClr val="lt1"/>
+          </a:fontRef>
+        </p:style>
+        <p:txBody>
+          <a:bodyPr rtlCol="0" anchor="ctr"/>
+          <a:lstStyle/>
+          <a:p>
+            <a:pPr algn="ctr"/>
+          </a:p>
+        </p:txBody>
+      </p:sp>
+      <p:sp>
+        <p:nvSpPr>
+          <p:cNvPr id="33" name="TextBox 32"/>
+          <p:cNvSpPr txBox="1"/>
+          <p:nvPr/>
+        </p:nvSpPr>
+        <p:spPr>
+          <a:xfrm>
+            <a:off x="6144768" y="5687568"/>
+            <a:ext cx="5486400" cy="274320"/>
+          </a:xfrm>
+          <a:prstGeom prst="rect">
+            <a:avLst/>
+          </a:prstGeom>
+          <a:noFill/>
+        </p:spPr>
+        <p:txBody>
+          <a:bodyPr wrap="square" anchor="t" lIns="0" rIns="0" tIns="0" bIns="0">
+            <a:spAutoFit/>
+          </a:bodyPr>
+          <a:lstStyle/>
+          <a:p>
+            <a:pPr algn="l">
+              <a:spcAft>
+                <a:spcPts val="0"/>
+              </a:spcAft>
+            </a:pPr>
+            <a:r>
+              <a:rPr sz="950" b="1">
+                <a:solidFill>
+                  <a:srgbClr val="1B2A41"/>
+                </a:solidFill>
+                <a:latin typeface="Segoe UI"/>
+              </a:rPr>
+              <a:t>Alert Suppression</a:t>
+            </a:r>
+            <a:r>
+              <a:rPr sz="900" b="0">
+                <a:solidFill>
+                  <a:srgbClr val="40444B"/>
+                </a:solidFill>
+                <a:latin typeface="Segoe UI"/>
+              </a:rPr>
+              <a:t> — governed change windows — approved, recorded, always auto-expiring</a:t>
+            </a:r>
+          </a:p>
+        </p:txBody>
+      </p:sp>
+      <p:sp>
+        <p:nvSpPr>
+          <p:cNvPr id="34" name="TextBox 33"/>
+          <p:cNvSpPr txBox="1"/>
+          <p:nvPr/>
+        </p:nvSpPr>
+        <p:spPr>
+          <a:xfrm>
+            <a:off x="5943600" y="6044183"/>
+            <a:ext cx="5669280" cy="219456"/>
+          </a:xfrm>
+          <a:prstGeom prst="rect">
+            <a:avLst/>
+          </a:prstGeom>
+          <a:noFill/>
+        </p:spPr>
+        <p:txBody>
+          <a:bodyPr wrap="square" anchor="t" lIns="0" rIns="0" tIns="0" bIns="0">
+            <a:spAutoFit/>
+          </a:bodyPr>
+          <a:lstStyle/>
+          <a:p>
+            <a:pPr algn="l">
+              <a:spcAft>
+                <a:spcPts val="400"/>
+              </a:spcAft>
+            </a:pPr>
+            <a:r>
+              <a:rPr sz="950" b="1">
+                <a:solidFill>
+                  <a:srgbClr val="2E74B5"/>
+                </a:solidFill>
+                <a:latin typeface="Segoe UI"/>
+              </a:rPr>
+              <a:t>H2 2027 — INTELLIGENCE</a:t>
+            </a:r>
+          </a:p>
+        </p:txBody>
+      </p:sp>
+      <p:sp>
+        <p:nvSpPr>
+          <p:cNvPr id="35" name="Rectangle 34"/>
+          <p:cNvSpPr/>
+          <p:nvPr/>
+        </p:nvSpPr>
+        <p:spPr>
+          <a:xfrm>
+            <a:off x="5943600" y="6336791"/>
+            <a:ext cx="73152" cy="73152"/>
+          </a:xfrm>
+          <a:prstGeom prst="rect">
+            <a:avLst/>
+          </a:prstGeom>
+          <a:solidFill>
+            <a:srgbClr val="1B2A41"/>
+          </a:solidFill>
+          <a:ln>
+            <a:noFill/>
+          </a:ln>
+          <a:effectLst/>
+        </p:spPr>
+        <p:style>
+          <a:lnRef idx="1">
+            <a:schemeClr val="accent1"/>
+          </a:lnRef>
+          <a:fillRef idx="3">
+            <a:schemeClr val="accent1"/>
+          </a:fillRef>
+          <a:effectRef idx="2">
+            <a:schemeClr val="accent1"/>
+          </a:effectRef>
+          <a:fontRef idx="minor">
+            <a:schemeClr val="lt1"/>
+          </a:fontRef>
+        </p:style>
+        <p:txBody>
+          <a:bodyPr rtlCol="0" anchor="ctr"/>
+          <a:lstStyle/>
+          <a:p>
+            <a:pPr algn="ctr"/>
+          </a:p>
+        </p:txBody>
+      </p:sp>
+      <p:sp>
+        <p:nvSpPr>
+          <p:cNvPr id="36" name="TextBox 35"/>
+          <p:cNvSpPr txBox="1"/>
+          <p:nvPr/>
+        </p:nvSpPr>
+        <p:spPr>
+          <a:xfrm>
+            <a:off x="6144768" y="6281927"/>
+            <a:ext cx="5486400" cy="274320"/>
+          </a:xfrm>
+          <a:prstGeom prst="rect">
+            <a:avLst/>
+          </a:prstGeom>
+          <a:noFill/>
+        </p:spPr>
+        <p:txBody>
+          <a:bodyPr wrap="square" anchor="t" lIns="0" rIns="0" tIns="0" bIns="0">
+            <a:spAutoFit/>
+          </a:bodyPr>
+          <a:lstStyle/>
+          <a:p>
+            <a:pPr algn="l">
+              <a:spcAft>
+                <a:spcPts val="0"/>
+              </a:spcAft>
+            </a:pPr>
+            <a:r>
+              <a:rPr sz="950" b="1">
+                <a:solidFill>
+                  <a:srgbClr val="1B2A41"/>
+                </a:solidFill>
+                <a:latin typeface="Segoe UI"/>
+              </a:rPr>
+              <a:t>Observability Brain</a:t>
+            </a:r>
+            <a:r>
+              <a:rPr sz="900" b="0">
+                <a:solidFill>
+                  <a:srgbClr val="40444B"/>
+                </a:solidFill>
+                <a:latin typeface="Segoe UI"/>
+              </a:rPr>
+              <a:t> — grounded search and answers over the second brain — AI proposes, humans approve</a:t>
+            </a:r>
+          </a:p>
+        </p:txBody>
+      </p:sp>
+      <p:sp>
+        <p:nvSpPr>
+          <p:cNvPr id="37" name="Rectangle 36"/>
+          <p:cNvSpPr/>
+          <p:nvPr/>
+        </p:nvSpPr>
+        <p:spPr>
+          <a:xfrm>
+            <a:off x="548640" y="6455664"/>
+            <a:ext cx="11091672" cy="10972"/>
+          </a:xfrm>
+          <a:prstGeom prst="rect">
+            <a:avLst/>
+          </a:prstGeom>
+          <a:solidFill>
+            <a:srgbClr val="D8DCE1"/>
+          </a:solidFill>
+          <a:ln>
+            <a:noFill/>
+          </a:ln>
+          <a:effectLst/>
+        </p:spPr>
+        <p:style>
+          <a:lnRef idx="1">
+            <a:schemeClr val="accent1"/>
+          </a:lnRef>
+          <a:fillRef idx="3">
+            <a:schemeClr val="accent1"/>
+          </a:fillRef>
+          <a:effectRef idx="2">
+            <a:schemeClr val="accent1"/>
+          </a:effectRef>
+          <a:fontRef idx="minor">
+            <a:schemeClr val="lt1"/>
+          </a:fontRef>
+        </p:style>
+        <p:txBody>
+          <a:bodyPr rtlCol="0" anchor="ctr"/>
+          <a:lstStyle/>
+          <a:p>
+            <a:pPr algn="ctr"/>
+          </a:p>
+        </p:txBody>
+      </p:sp>
+      <p:sp>
+        <p:nvSpPr>
+          <p:cNvPr id="38" name="TextBox 37"/>
+          <p:cNvSpPr txBox="1"/>
+          <p:nvPr/>
+        </p:nvSpPr>
+        <p:spPr>
+          <a:xfrm>
+            <a:off x="548640" y="6510528"/>
+            <a:ext cx="8229600" cy="274320"/>
+          </a:xfrm>
+          <a:prstGeom prst="rect">
+            <a:avLst/>
+          </a:prstGeom>
+          <a:noFill/>
+        </p:spPr>
+        <p:txBody>
+          <a:bodyPr wrap="square" anchor="t" lIns="0" rIns="0" tIns="0" bIns="0">
+            <a:spAutoFit/>
+          </a:bodyPr>
+          <a:lstStyle/>
+          <a:p>
+            <a:pPr algn="l">
+              <a:spcAft>
+                <a:spcPts val="400"/>
+              </a:spcAft>
+            </a:pPr>
+            <a:r>
+              <a:rPr sz="850" b="0">
+                <a:solidFill>
+                  <a:srgbClr val="7A808A"/>
+                </a:solidFill>
+                <a:latin typeface="Segoe UI"/>
+              </a:rPr>
+              <a:t>Observability Portal — Executive Briefing</a:t>
+            </a:r>
+          </a:p>
+        </p:txBody>
+      </p:sp>
+      <p:sp>
+        <p:nvSpPr>
+          <p:cNvPr id="39" name="TextBox 38"/>
+          <p:cNvSpPr txBox="1"/>
+          <p:nvPr/>
+        </p:nvSpPr>
+        <p:spPr>
+          <a:xfrm>
+            <a:off x="10972800" y="6510528"/>
+            <a:ext cx="667512" cy="274320"/>
+          </a:xfrm>
+          <a:prstGeom prst="rect">
+            <a:avLst/>
+          </a:prstGeom>
+          <a:noFill/>
+        </p:spPr>
+        <p:txBody>
+          <a:bodyPr wrap="square" anchor="t" lIns="0" rIns="0" tIns="0" bIns="0">
+            <a:spAutoFit/>
+          </a:bodyPr>
+          <a:lstStyle/>
+          <a:p>
+            <a:pPr algn="r">
+              <a:spcAft>
+                <a:spcPts val="400"/>
+              </a:spcAft>
+            </a:pPr>
+            <a:r>
+              <a:rPr sz="850" b="0">
+                <a:solidFill>
+                  <a:srgbClr val="7A808A"/>
+                </a:solidFill>
+                <a:latin typeface="Segoe UI"/>
+              </a:rPr>
+              <a:t>5</a:t>
+            </a:r>
+          </a:p>
+        </p:txBody>
+      </p:sp>
+    </p:spTree>
+  </p:cSld>
+  <p:clrMapOvr>
+    <a:masterClrMapping/>
+  </p:clrMapOvr>
+</p:sld>
+</file>
+
+<file path=ppt/slides/slide6.xml><?xml version="1.0" encoding="utf-8"?>
+<p:sld xmlns:a="http://schemas.openxmlformats.org/drawingml/2006/main" xmlns:p="http://schemas.openxmlformats.org/presentationml/2006/main" xmlns:r="http://schemas.openxmlformats.org/officeDocument/2006/relationships">
+  <p:cSld>
+    <p:bg>
+      <p:bgPr>
+        <a:solidFill>
           <a:srgbClr val="1B2A41"/>
         </a:solidFill>
         <a:effectLst/>
@@ -11728,7 +13576,7 @@
                 </a:solidFill>
                 <a:latin typeface="Segoe UI"/>
               </a:rPr>
-              <a:t>5</a:t>
+              <a:t>6</a:t>
             </a:r>
           </a:p>
         </p:txBody>

</xml_diff>

<commit_message>
docs: remove outdated observability portal executive deck versions and update the current deck
</commit_message>
<xml_diff>
--- a/docs/ui-ux-design/diagrams/observability-portal-exec-deck.pptx
+++ b/docs/ui-ux-design/diagrams/observability-portal-exec-deck.pptx
@@ -3174,7 +3174,7 @@
                 </a:solidFill>
                 <a:latin typeface="Segoe UI"/>
               </a:rPr>
-              <a:t>The Observability Portal — what it is</a:t>
+              <a:t>The Observability Portal — What it is</a:t>
             </a:r>
           </a:p>
         </p:txBody>
@@ -3231,8 +3231,8 @@
         </p:nvSpPr>
         <p:spPr>
           <a:xfrm>
-            <a:off x="548640" y="1371600"/>
-            <a:ext cx="11064240" cy="365760"/>
+            <a:off x="548640" y="1335024"/>
+            <a:ext cx="11064240" cy="256032"/>
           </a:xfrm>
           <a:prstGeom prst="rect">
             <a:avLst/>
@@ -3251,26 +3251,167 @@
               </a:spcAft>
             </a:pPr>
             <a:r>
-              <a:rPr sz="1150" b="0">
+              <a:rPr sz="1150" b="1">
+                <a:solidFill>
+                  <a:srgbClr val="2E74B5"/>
+                </a:solidFill>
+                <a:latin typeface="Segoe UI"/>
+              </a:rPr>
+              <a:t>An Observability Transformation</a:t>
+            </a:r>
+            <a:r>
+              <a:rPr sz="1100" b="0">
                 <a:solidFill>
                   <a:srgbClr val="7A808A"/>
                 </a:solidFill>
                 <a:latin typeface="Segoe UI"/>
               </a:rPr>
-              <a:t>A self-service portal, built on open-source Backstage, that turns every monitoring request into a governed, automated pipeline — users see services, never tools.</a:t>
-            </a:r>
-          </a:p>
-        </p:txBody>
-      </p:sp>
-      <p:sp>
-        <p:nvSpPr>
-          <p:cNvPr id="6" name="Rectangle 5"/>
+              <a:t> — an evolution of how observability is run: full user self-service, practised as platform engineering.</a:t>
+            </a:r>
+          </a:p>
+        </p:txBody>
+      </p:sp>
+      <p:sp>
+        <p:nvSpPr>
+          <p:cNvPr id="6" name="TextBox 5"/>
+          <p:cNvSpPr txBox="1"/>
+          <p:nvPr/>
+        </p:nvSpPr>
+        <p:spPr>
+          <a:xfrm>
+            <a:off x="548640" y="1591056"/>
+            <a:ext cx="11064240" cy="256032"/>
+          </a:xfrm>
+          <a:prstGeom prst="rect">
+            <a:avLst/>
+          </a:prstGeom>
+          <a:noFill/>
+        </p:spPr>
+        <p:txBody>
+          <a:bodyPr wrap="square" anchor="t" lIns="0" rIns="0" tIns="0" bIns="0">
+            <a:spAutoFit/>
+          </a:bodyPr>
+          <a:lstStyle/>
+          <a:p>
+            <a:pPr algn="l">
+              <a:spcAft>
+                <a:spcPts val="400"/>
+              </a:spcAft>
+            </a:pPr>
+            <a:r>
+              <a:rPr sz="1050" b="1">
+                <a:solidFill>
+                  <a:srgbClr val="1B2A41"/>
+                </a:solidFill>
+                <a:latin typeface="Segoe UI"/>
+              </a:rPr>
+              <a:t>The Portal is a product</a:t>
+            </a:r>
+            <a:r>
+              <a:rPr sz="1000" b="0">
+                <a:solidFill>
+                  <a:srgbClr val="7A808A"/>
+                </a:solidFill>
+                <a:latin typeface="Segoe UI"/>
+              </a:rPr>
+              <a:t> — part of every engineer’s toolset, built on open-source Backstage: engineers enable themselves across the platform tools behind it. Users see services, never tools.</a:t>
+            </a:r>
+          </a:p>
+        </p:txBody>
+      </p:sp>
+      <p:sp>
+        <p:nvSpPr>
+          <p:cNvPr id="7" name="TextBox 6"/>
+          <p:cNvSpPr txBox="1"/>
+          <p:nvPr/>
+        </p:nvSpPr>
+        <p:spPr>
+          <a:xfrm>
+            <a:off x="548640" y="1847088"/>
+            <a:ext cx="11064240" cy="475488"/>
+          </a:xfrm>
+          <a:prstGeom prst="rect">
+            <a:avLst/>
+          </a:prstGeom>
+          <a:noFill/>
+        </p:spPr>
+        <p:txBody>
+          <a:bodyPr wrap="square" anchor="t" lIns="0" rIns="0" tIns="0" bIns="0">
+            <a:spAutoFit/>
+          </a:bodyPr>
+          <a:lstStyle/>
+          <a:p>
+            <a:pPr algn="l">
+              <a:spcAft>
+                <a:spcPts val="400"/>
+              </a:spcAft>
+            </a:pPr>
+            <a:r>
+              <a:rPr sz="1050" b="1">
+                <a:solidFill>
+                  <a:srgbClr val="2E74B5"/>
+                </a:solidFill>
+                <a:latin typeface="Segoe UI"/>
+              </a:rPr>
+              <a:t>And it is the channel</a:t>
+            </a:r>
+            <a:r>
+              <a:rPr sz="1000" b="0">
+                <a:solidFill>
+                  <a:srgbClr val="7A808A"/>
+                </a:solidFill>
+                <a:latin typeface="Segoe UI"/>
+              </a:rPr>
+              <a:t> — the elimination of </a:t>
+            </a:r>
+            <a:r>
+              <a:rPr sz="1000" b="1">
+                <a:solidFill>
+                  <a:srgbClr val="1B2A41"/>
+                </a:solidFill>
+                <a:latin typeface="Segoe UI"/>
+              </a:rPr>
+              <a:t>institutional blind spots.</a:t>
+            </a:r>
+            <a:r>
+              <a:rPr sz="1000" b="0">
+                <a:solidFill>
+                  <a:srgbClr val="7A808A"/>
+                </a:solidFill>
+                <a:latin typeface="Segoe UI"/>
+              </a:rPr>
+              <a:t> Ownership, process, and status cease to be tribal knowledge held by individuals; they become published capabilities of one platform. </a:t>
+            </a:r>
+            <a:r>
+              <a:rPr sz="1000" b="1">
+                <a:solidFill>
+                  <a:srgbClr val="1B2A41"/>
+                </a:solidFill>
+                <a:latin typeface="Segoe UI"/>
+              </a:rPr>
+              <a:t>Automation does the work; open governance keeps it visible</a:t>
+            </a:r>
+            <a:r>
+              <a:rPr sz="1000" b="0">
+                <a:solidFill>
+                  <a:srgbClr val="7A808A"/>
+                </a:solidFill>
+                <a:latin typeface="Segoe UI"/>
+              </a:rPr>
+              <a:t> — a single front door for every enquiry and request: open book, self-service, always on.</a:t>
+            </a:r>
+          </a:p>
+        </p:txBody>
+      </p:sp>
+      <p:sp>
+        <p:nvSpPr>
+          <p:cNvPr id="8" name="Rectangle 7"/>
           <p:cNvSpPr/>
           <p:nvPr/>
         </p:nvSpPr>
         <p:spPr>
           <a:xfrm>
-            <a:off x="548640" y="1874519"/>
+            <a:off x="548640" y="2450592"/>
             <a:ext cx="3520440" cy="25603"/>
           </a:xfrm>
           <a:prstGeom prst="rect">
@@ -3308,14 +3449,14 @@
       </p:sp>
       <p:sp>
         <p:nvSpPr>
-          <p:cNvPr id="7" name="TextBox 6"/>
-          <p:cNvSpPr txBox="1"/>
-          <p:nvPr/>
-        </p:nvSpPr>
-        <p:spPr>
-          <a:xfrm>
-            <a:off x="548640" y="2002536"/>
-            <a:ext cx="3520440" cy="320040"/>
+          <p:cNvPr id="9" name="TextBox 8"/>
+          <p:cNvSpPr txBox="1"/>
+          <p:nvPr/>
+        </p:nvSpPr>
+        <p:spPr>
+          <a:xfrm>
+            <a:off x="548640" y="2560320"/>
+            <a:ext cx="3520440" cy="256032"/>
           </a:xfrm>
           <a:prstGeom prst="rect">
             <a:avLst/>
@@ -3334,7 +3475,7 @@
               </a:spcAft>
             </a:pPr>
             <a:r>
-              <a:rPr sz="1300" b="1">
+              <a:rPr sz="1250" b="1">
                 <a:solidFill>
                   <a:srgbClr val="1B2A41"/>
                 </a:solidFill>
@@ -3347,13 +3488,52 @@
       </p:sp>
       <p:sp>
         <p:nvSpPr>
-          <p:cNvPr id="8" name="Rectangle 7"/>
+          <p:cNvPr id="10" name="TextBox 9"/>
+          <p:cNvSpPr txBox="1"/>
+          <p:nvPr/>
+        </p:nvSpPr>
+        <p:spPr>
+          <a:xfrm>
+            <a:off x="548640" y="2816352"/>
+            <a:ext cx="3520440" cy="310896"/>
+          </a:xfrm>
+          <a:prstGeom prst="rect">
+            <a:avLst/>
+          </a:prstGeom>
+          <a:noFill/>
+        </p:spPr>
+        <p:txBody>
+          <a:bodyPr wrap="square" anchor="t" lIns="0" rIns="0" tIns="0" bIns="0">
+            <a:spAutoFit/>
+          </a:bodyPr>
+          <a:lstStyle/>
+          <a:p>
+            <a:pPr algn="l">
+              <a:spcAft>
+                <a:spcPts val="0"/>
+              </a:spcAft>
+            </a:pPr>
+            <a:r>
+              <a:rPr sz="850" b="0" i="1">
+                <a:solidFill>
+                  <a:srgbClr val="7A808A"/>
+                </a:solidFill>
+                <a:latin typeface="Segoe UI"/>
+              </a:rPr>
+              <a:t>Remove every barrier to entry: any engineer switches observability on in minutes, correctly, without knowing the tools behind it.</a:t>
+            </a:r>
+          </a:p>
+        </p:txBody>
+      </p:sp>
+      <p:sp>
+        <p:nvSpPr>
+          <p:cNvPr id="11" name="Rectangle 10"/>
           <p:cNvSpPr/>
           <p:nvPr/>
         </p:nvSpPr>
         <p:spPr>
           <a:xfrm>
-            <a:off x="548640" y="2432304"/>
+            <a:off x="548640" y="3246120"/>
             <a:ext cx="73152" cy="73152"/>
           </a:xfrm>
           <a:prstGeom prst="rect">
@@ -3391,14 +3571,14 @@
       </p:sp>
       <p:sp>
         <p:nvSpPr>
-          <p:cNvPr id="9" name="TextBox 8"/>
-          <p:cNvSpPr txBox="1"/>
-          <p:nvPr/>
-        </p:nvSpPr>
-        <p:spPr>
-          <a:xfrm>
-            <a:off x="749808" y="2377440"/>
-            <a:ext cx="3319272" cy="566928"/>
+          <p:cNvPr id="12" name="TextBox 11"/>
+          <p:cNvSpPr txBox="1"/>
+          <p:nvPr/>
+        </p:nvSpPr>
+        <p:spPr>
+          <a:xfrm>
+            <a:off x="749808" y="3200400"/>
+            <a:ext cx="3319272" cy="274320"/>
           </a:xfrm>
           <a:prstGeom prst="rect">
             <a:avLst/>
@@ -3417,7 +3597,7 @@
               </a:spcAft>
             </a:pPr>
             <a:r>
-              <a:rPr sz="1050" b="1">
+              <a:rPr sz="950" b="1">
                 <a:solidFill>
                   <a:srgbClr val="1B2A41"/>
                 </a:solidFill>
@@ -3426,7 +3606,7 @@
               <a:t>Add Monitoring</a:t>
             </a:r>
             <a:r>
-              <a:rPr sz="1000" b="0">
+              <a:rPr sz="900" b="0">
                 <a:solidFill>
                   <a:srgbClr val="40444B"/>
                 </a:solidFill>
@@ -3439,13 +3619,13 @@
       </p:sp>
       <p:sp>
         <p:nvSpPr>
-          <p:cNvPr id="10" name="Rectangle 9"/>
+          <p:cNvPr id="13" name="Rectangle 12"/>
           <p:cNvSpPr/>
           <p:nvPr/>
         </p:nvSpPr>
         <p:spPr>
           <a:xfrm>
-            <a:off x="548640" y="2980944"/>
+            <a:off x="548640" y="3538727"/>
             <a:ext cx="73152" cy="73152"/>
           </a:xfrm>
           <a:prstGeom prst="rect">
@@ -3483,14 +3663,14 @@
       </p:sp>
       <p:sp>
         <p:nvSpPr>
-          <p:cNvPr id="11" name="TextBox 10"/>
-          <p:cNvSpPr txBox="1"/>
-          <p:nvPr/>
-        </p:nvSpPr>
-        <p:spPr>
-          <a:xfrm>
-            <a:off x="749808" y="2926080"/>
-            <a:ext cx="3319272" cy="566928"/>
+          <p:cNvPr id="14" name="TextBox 13"/>
+          <p:cNvSpPr txBox="1"/>
+          <p:nvPr/>
+        </p:nvSpPr>
+        <p:spPr>
+          <a:xfrm>
+            <a:off x="749808" y="3493008"/>
+            <a:ext cx="3319272" cy="274320"/>
           </a:xfrm>
           <a:prstGeom prst="rect">
             <a:avLst/>
@@ -3509,7 +3689,7 @@
               </a:spcAft>
             </a:pPr>
             <a:r>
-              <a:rPr sz="1050" b="1">
+              <a:rPr sz="950" b="1">
                 <a:solidFill>
                   <a:srgbClr val="1B2A41"/>
                 </a:solidFill>
@@ -3518,7 +3698,7 @@
               <a:t>ELK Log Onboarding</a:t>
             </a:r>
             <a:r>
-              <a:rPr sz="1000" b="0">
+              <a:rPr sz="900" b="0">
                 <a:solidFill>
                   <a:srgbClr val="40444B"/>
                 </a:solidFill>
@@ -3531,13 +3711,13 @@
       </p:sp>
       <p:sp>
         <p:nvSpPr>
-          <p:cNvPr id="12" name="Rectangle 11"/>
+          <p:cNvPr id="15" name="Rectangle 14"/>
           <p:cNvSpPr/>
           <p:nvPr/>
         </p:nvSpPr>
         <p:spPr>
           <a:xfrm>
-            <a:off x="548640" y="3529584"/>
+            <a:off x="548640" y="3831335"/>
             <a:ext cx="73152" cy="73152"/>
           </a:xfrm>
           <a:prstGeom prst="rect">
@@ -3575,14 +3755,14 @@
       </p:sp>
       <p:sp>
         <p:nvSpPr>
-          <p:cNvPr id="13" name="TextBox 12"/>
-          <p:cNvSpPr txBox="1"/>
-          <p:nvPr/>
-        </p:nvSpPr>
-        <p:spPr>
-          <a:xfrm>
-            <a:off x="749808" y="3474720"/>
-            <a:ext cx="3319272" cy="566928"/>
+          <p:cNvPr id="16" name="TextBox 15"/>
+          <p:cNvSpPr txBox="1"/>
+          <p:nvPr/>
+        </p:nvSpPr>
+        <p:spPr>
+          <a:xfrm>
+            <a:off x="749808" y="3785615"/>
+            <a:ext cx="3319272" cy="274320"/>
           </a:xfrm>
           <a:prstGeom prst="rect">
             <a:avLst/>
@@ -3601,7 +3781,7 @@
               </a:spcAft>
             </a:pPr>
             <a:r>
-              <a:rPr sz="1050" b="1">
+              <a:rPr sz="950" b="1">
                 <a:solidFill>
                   <a:srgbClr val="1B2A41"/>
                 </a:solidFill>
@@ -3610,7 +3790,7 @@
               <a:t>Access &amp; Asset Registry</a:t>
             </a:r>
             <a:r>
-              <a:rPr sz="1000" b="0">
+              <a:rPr sz="900" b="0">
                 <a:solidFill>
                   <a:srgbClr val="40444B"/>
                 </a:solidFill>
@@ -3623,13 +3803,13 @@
       </p:sp>
       <p:sp>
         <p:nvSpPr>
-          <p:cNvPr id="14" name="Rectangle 13"/>
+          <p:cNvPr id="17" name="Rectangle 16"/>
           <p:cNvSpPr/>
           <p:nvPr/>
         </p:nvSpPr>
         <p:spPr>
           <a:xfrm>
-            <a:off x="4379976" y="1874519"/>
+            <a:off x="4379976" y="2450592"/>
             <a:ext cx="3520440" cy="25603"/>
           </a:xfrm>
           <a:prstGeom prst="rect">
@@ -3667,14 +3847,14 @@
       </p:sp>
       <p:sp>
         <p:nvSpPr>
-          <p:cNvPr id="15" name="TextBox 14"/>
-          <p:cNvSpPr txBox="1"/>
-          <p:nvPr/>
-        </p:nvSpPr>
-        <p:spPr>
-          <a:xfrm>
-            <a:off x="4379976" y="2002536"/>
-            <a:ext cx="3520440" cy="320040"/>
+          <p:cNvPr id="18" name="TextBox 17"/>
+          <p:cNvSpPr txBox="1"/>
+          <p:nvPr/>
+        </p:nvSpPr>
+        <p:spPr>
+          <a:xfrm>
+            <a:off x="4379976" y="2560320"/>
+            <a:ext cx="3520440" cy="256032"/>
           </a:xfrm>
           <a:prstGeom prst="rect">
             <a:avLst/>
@@ -3693,7 +3873,7 @@
               </a:spcAft>
             </a:pPr>
             <a:r>
-              <a:rPr sz="1300" b="1">
+              <a:rPr sz="1250" b="1">
                 <a:solidFill>
                   <a:srgbClr val="1B2A41"/>
                 </a:solidFill>
@@ -3706,13 +3886,52 @@
       </p:sp>
       <p:sp>
         <p:nvSpPr>
-          <p:cNvPr id="16" name="Rectangle 15"/>
+          <p:cNvPr id="19" name="TextBox 18"/>
+          <p:cNvSpPr txBox="1"/>
+          <p:nvPr/>
+        </p:nvSpPr>
+        <p:spPr>
+          <a:xfrm>
+            <a:off x="4379976" y="2816352"/>
+            <a:ext cx="3520440" cy="310896"/>
+          </a:xfrm>
+          <a:prstGeom prst="rect">
+            <a:avLst/>
+          </a:prstGeom>
+          <a:noFill/>
+        </p:spPr>
+        <p:txBody>
+          <a:bodyPr wrap="square" anchor="t" lIns="0" rIns="0" tIns="0" bIns="0">
+            <a:spAutoFit/>
+          </a:bodyPr>
+          <a:lstStyle/>
+          <a:p>
+            <a:pPr algn="l">
+              <a:spcAft>
+                <a:spcPts val="0"/>
+              </a:spcAft>
+            </a:pPr>
+            <a:r>
+              <a:rPr sz="850" b="0" i="1">
+                <a:solidFill>
+                  <a:srgbClr val="7A808A"/>
+                </a:solidFill>
+                <a:latin typeface="Segoe UI"/>
+              </a:rPr>
+              <a:t>Make coverage provable: continuously verify that what should be observed is observed — and works — before an incident asks.</a:t>
+            </a:r>
+          </a:p>
+        </p:txBody>
+      </p:sp>
+      <p:sp>
+        <p:nvSpPr>
+          <p:cNvPr id="20" name="Rectangle 19"/>
           <p:cNvSpPr/>
           <p:nvPr/>
         </p:nvSpPr>
         <p:spPr>
           <a:xfrm>
-            <a:off x="4379976" y="2432304"/>
+            <a:off x="4379976" y="3246120"/>
             <a:ext cx="73152" cy="73152"/>
           </a:xfrm>
           <a:prstGeom prst="rect">
@@ -3750,14 +3969,14 @@
       </p:sp>
       <p:sp>
         <p:nvSpPr>
-          <p:cNvPr id="17" name="TextBox 16"/>
-          <p:cNvSpPr txBox="1"/>
-          <p:nvPr/>
-        </p:nvSpPr>
-        <p:spPr>
-          <a:xfrm>
-            <a:off x="4581144" y="2377440"/>
-            <a:ext cx="3319272" cy="566928"/>
+          <p:cNvPr id="21" name="TextBox 20"/>
+          <p:cNvSpPr txBox="1"/>
+          <p:nvPr/>
+        </p:nvSpPr>
+        <p:spPr>
+          <a:xfrm>
+            <a:off x="4581144" y="3200400"/>
+            <a:ext cx="3319272" cy="274320"/>
           </a:xfrm>
           <a:prstGeom prst="rect">
             <a:avLst/>
@@ -3776,7 +3995,7 @@
               </a:spcAft>
             </a:pPr>
             <a:r>
-              <a:rPr sz="1050" b="1">
+              <a:rPr sz="950" b="1">
                 <a:solidFill>
                   <a:srgbClr val="1B2A41"/>
                 </a:solidFill>
@@ -3785,7 +4004,7 @@
               <a:t>Observability Score</a:t>
             </a:r>
             <a:r>
-              <a:rPr sz="1000" b="0">
+              <a:rPr sz="900" b="0">
                 <a:solidFill>
                   <a:srgbClr val="40444B"/>
                 </a:solidFill>
@@ -3798,13 +4017,13 @@
       </p:sp>
       <p:sp>
         <p:nvSpPr>
-          <p:cNvPr id="18" name="Rectangle 17"/>
+          <p:cNvPr id="22" name="Rectangle 21"/>
           <p:cNvSpPr/>
           <p:nvPr/>
         </p:nvSpPr>
         <p:spPr>
           <a:xfrm>
-            <a:off x="4379976" y="2980944"/>
+            <a:off x="4379976" y="3538727"/>
             <a:ext cx="73152" cy="73152"/>
           </a:xfrm>
           <a:prstGeom prst="rect">
@@ -3842,14 +4061,14 @@
       </p:sp>
       <p:sp>
         <p:nvSpPr>
-          <p:cNvPr id="19" name="TextBox 18"/>
-          <p:cNvSpPr txBox="1"/>
-          <p:nvPr/>
-        </p:nvSpPr>
-        <p:spPr>
-          <a:xfrm>
-            <a:off x="4581144" y="2926080"/>
-            <a:ext cx="3319272" cy="566928"/>
+          <p:cNvPr id="23" name="TextBox 22"/>
+          <p:cNvSpPr txBox="1"/>
+          <p:nvPr/>
+        </p:nvSpPr>
+        <p:spPr>
+          <a:xfrm>
+            <a:off x="4581144" y="3493008"/>
+            <a:ext cx="3319272" cy="274320"/>
           </a:xfrm>
           <a:prstGeom prst="rect">
             <a:avLst/>
@@ -3868,7 +4087,7 @@
               </a:spcAft>
             </a:pPr>
             <a:r>
-              <a:rPr sz="1050" b="1">
+              <a:rPr sz="950" b="1">
                 <a:solidFill>
                   <a:srgbClr val="1B2A41"/>
                 </a:solidFill>
@@ -3877,7 +4096,7 @@
               <a:t>Synthetic Alerting</a:t>
             </a:r>
             <a:r>
-              <a:rPr sz="1000" b="0">
+              <a:rPr sz="900" b="0">
                 <a:solidFill>
                   <a:srgbClr val="40444B"/>
                 </a:solidFill>
@@ -3890,13 +4109,13 @@
       </p:sp>
       <p:sp>
         <p:nvSpPr>
-          <p:cNvPr id="20" name="Rectangle 19"/>
+          <p:cNvPr id="24" name="Rectangle 23"/>
           <p:cNvSpPr/>
           <p:nvPr/>
         </p:nvSpPr>
         <p:spPr>
           <a:xfrm>
-            <a:off x="4379976" y="3529584"/>
+            <a:off x="4379976" y="3831335"/>
             <a:ext cx="73152" cy="73152"/>
           </a:xfrm>
           <a:prstGeom prst="rect">
@@ -3934,14 +4153,14 @@
       </p:sp>
       <p:sp>
         <p:nvSpPr>
-          <p:cNvPr id="21" name="TextBox 20"/>
-          <p:cNvSpPr txBox="1"/>
-          <p:nvPr/>
-        </p:nvSpPr>
-        <p:spPr>
-          <a:xfrm>
-            <a:off x="4581144" y="3474720"/>
-            <a:ext cx="3319272" cy="566928"/>
+          <p:cNvPr id="25" name="TextBox 24"/>
+          <p:cNvSpPr txBox="1"/>
+          <p:nvPr/>
+        </p:nvSpPr>
+        <p:spPr>
+          <a:xfrm>
+            <a:off x="4581144" y="3785615"/>
+            <a:ext cx="3319272" cy="274320"/>
           </a:xfrm>
           <a:prstGeom prst="rect">
             <a:avLst/>
@@ -3960,7 +4179,7 @@
               </a:spcAft>
             </a:pPr>
             <a:r>
-              <a:rPr sz="1050" b="1">
+              <a:rPr sz="950" b="1">
                 <a:solidFill>
                   <a:srgbClr val="1B2A41"/>
                 </a:solidFill>
@@ -3969,7 +4188,7 @@
               <a:t>Reconciliation Reports</a:t>
             </a:r>
             <a:r>
-              <a:rPr sz="1000" b="0">
+              <a:rPr sz="900" b="0">
                 <a:solidFill>
                   <a:srgbClr val="40444B"/>
                 </a:solidFill>
@@ -3982,13 +4201,13 @@
       </p:sp>
       <p:sp>
         <p:nvSpPr>
-          <p:cNvPr id="22" name="Rectangle 21"/>
+          <p:cNvPr id="26" name="Rectangle 25"/>
           <p:cNvSpPr/>
           <p:nvPr/>
         </p:nvSpPr>
         <p:spPr>
           <a:xfrm>
-            <a:off x="8211312" y="1874519"/>
+            <a:off x="8211312" y="2450592"/>
             <a:ext cx="3520440" cy="25603"/>
           </a:xfrm>
           <a:prstGeom prst="rect">
@@ -4026,14 +4245,14 @@
       </p:sp>
       <p:sp>
         <p:nvSpPr>
-          <p:cNvPr id="23" name="TextBox 22"/>
-          <p:cNvSpPr txBox="1"/>
-          <p:nvPr/>
-        </p:nvSpPr>
-        <p:spPr>
-          <a:xfrm>
-            <a:off x="8211312" y="2002536"/>
-            <a:ext cx="3520440" cy="320040"/>
+          <p:cNvPr id="27" name="TextBox 26"/>
+          <p:cNvSpPr txBox="1"/>
+          <p:nvPr/>
+        </p:nvSpPr>
+        <p:spPr>
+          <a:xfrm>
+            <a:off x="8211312" y="2560320"/>
+            <a:ext cx="3520440" cy="256032"/>
           </a:xfrm>
           <a:prstGeom prst="rect">
             <a:avLst/>
@@ -4052,7 +4271,7 @@
               </a:spcAft>
             </a:pPr>
             <a:r>
-              <a:rPr sz="1300" b="1">
+              <a:rPr sz="1250" b="1">
                 <a:solidFill>
                   <a:srgbClr val="1B2A41"/>
                 </a:solidFill>
@@ -4065,13 +4284,52 @@
       </p:sp>
       <p:sp>
         <p:nvSpPr>
-          <p:cNvPr id="24" name="Rectangle 23"/>
+          <p:cNvPr id="28" name="TextBox 27"/>
+          <p:cNvSpPr txBox="1"/>
+          <p:nvPr/>
+        </p:nvSpPr>
+        <p:spPr>
+          <a:xfrm>
+            <a:off x="8211312" y="2816352"/>
+            <a:ext cx="3520440" cy="310896"/>
+          </a:xfrm>
+          <a:prstGeom prst="rect">
+            <a:avLst/>
+          </a:prstGeom>
+          <a:noFill/>
+        </p:spPr>
+        <p:txBody>
+          <a:bodyPr wrap="square" anchor="t" lIns="0" rIns="0" tIns="0" bIns="0">
+            <a:spAutoFit/>
+          </a:bodyPr>
+          <a:lstStyle/>
+          <a:p>
+            <a:pPr algn="l">
+              <a:spcAft>
+                <a:spcPts val="0"/>
+              </a:spcAft>
+            </a:pPr>
+            <a:r>
+              <a:rPr sz="850" b="0" i="1">
+                <a:solidFill>
+                  <a:srgbClr val="7A808A"/>
+                </a:solidFill>
+                <a:latin typeface="Segoe UI"/>
+              </a:rPr>
+              <a:t>Make knowledge self-serve: every answer about the estate available instantly, grounded in the source of truth and cited.</a:t>
+            </a:r>
+          </a:p>
+        </p:txBody>
+      </p:sp>
+      <p:sp>
+        <p:nvSpPr>
+          <p:cNvPr id="29" name="Rectangle 28"/>
           <p:cNvSpPr/>
           <p:nvPr/>
         </p:nvSpPr>
         <p:spPr>
           <a:xfrm>
-            <a:off x="8211312" y="2432304"/>
+            <a:off x="8211312" y="3246120"/>
             <a:ext cx="73152" cy="73152"/>
           </a:xfrm>
           <a:prstGeom prst="rect">
@@ -4109,14 +4367,14 @@
       </p:sp>
       <p:sp>
         <p:nvSpPr>
-          <p:cNvPr id="25" name="TextBox 24"/>
-          <p:cNvSpPr txBox="1"/>
-          <p:nvPr/>
-        </p:nvSpPr>
-        <p:spPr>
-          <a:xfrm>
-            <a:off x="8412480" y="2377440"/>
-            <a:ext cx="3319272" cy="566928"/>
+          <p:cNvPr id="30" name="TextBox 29"/>
+          <p:cNvSpPr txBox="1"/>
+          <p:nvPr/>
+        </p:nvSpPr>
+        <p:spPr>
+          <a:xfrm>
+            <a:off x="8412480" y="3200400"/>
+            <a:ext cx="3319272" cy="274320"/>
           </a:xfrm>
           <a:prstGeom prst="rect">
             <a:avLst/>
@@ -4135,7 +4393,7 @@
               </a:spcAft>
             </a:pPr>
             <a:r>
-              <a:rPr sz="1050" b="1">
+              <a:rPr sz="950" b="1">
                 <a:solidFill>
                   <a:srgbClr val="1B2A41"/>
                 </a:solidFill>
@@ -4144,7 +4402,7 @@
               <a:t>Search</a:t>
             </a:r>
             <a:r>
-              <a:rPr sz="1000" b="0">
+              <a:rPr sz="900" b="0">
                 <a:solidFill>
                   <a:srgbClr val="40444B"/>
                 </a:solidFill>
@@ -4157,13 +4415,13 @@
       </p:sp>
       <p:sp>
         <p:nvSpPr>
-          <p:cNvPr id="26" name="Rectangle 25"/>
+          <p:cNvPr id="31" name="Rectangle 30"/>
           <p:cNvSpPr/>
           <p:nvPr/>
         </p:nvSpPr>
         <p:spPr>
           <a:xfrm>
-            <a:off x="8211312" y="2980944"/>
+            <a:off x="8211312" y="3538727"/>
             <a:ext cx="73152" cy="73152"/>
           </a:xfrm>
           <a:prstGeom prst="rect">
@@ -4201,14 +4459,14 @@
       </p:sp>
       <p:sp>
         <p:nvSpPr>
-          <p:cNvPr id="27" name="TextBox 26"/>
-          <p:cNvSpPr txBox="1"/>
-          <p:nvPr/>
-        </p:nvSpPr>
-        <p:spPr>
-          <a:xfrm>
-            <a:off x="8412480" y="2926080"/>
-            <a:ext cx="3319272" cy="566928"/>
+          <p:cNvPr id="32" name="TextBox 31"/>
+          <p:cNvSpPr txBox="1"/>
+          <p:nvPr/>
+        </p:nvSpPr>
+        <p:spPr>
+          <a:xfrm>
+            <a:off x="8412480" y="3493008"/>
+            <a:ext cx="3319272" cy="274320"/>
           </a:xfrm>
           <a:prstGeom prst="rect">
             <a:avLst/>
@@ -4227,7 +4485,7 @@
               </a:spcAft>
             </a:pPr>
             <a:r>
-              <a:rPr sz="1050" b="1">
+              <a:rPr sz="950" b="1">
                 <a:solidFill>
                   <a:srgbClr val="1B2A41"/>
                 </a:solidFill>
@@ -4236,7 +4494,7 @@
               <a:t>Ask</a:t>
             </a:r>
             <a:r>
-              <a:rPr sz="1000" b="0">
+              <a:rPr sz="900" b="0">
                 <a:solidFill>
                   <a:srgbClr val="40444B"/>
                 </a:solidFill>
@@ -4249,13 +4507,13 @@
       </p:sp>
       <p:sp>
         <p:nvSpPr>
-          <p:cNvPr id="28" name="Rectangle 27"/>
+          <p:cNvPr id="33" name="Rectangle 32"/>
           <p:cNvSpPr/>
           <p:nvPr/>
         </p:nvSpPr>
         <p:spPr>
           <a:xfrm>
-            <a:off x="8211312" y="3529584"/>
+            <a:off x="8211312" y="3831335"/>
             <a:ext cx="73152" cy="73152"/>
           </a:xfrm>
           <a:prstGeom prst="rect">
@@ -4293,14 +4551,14 @@
       </p:sp>
       <p:sp>
         <p:nvSpPr>
-          <p:cNvPr id="29" name="TextBox 28"/>
-          <p:cNvSpPr txBox="1"/>
-          <p:nvPr/>
-        </p:nvSpPr>
-        <p:spPr>
-          <a:xfrm>
-            <a:off x="8412480" y="3474720"/>
-            <a:ext cx="3319272" cy="566928"/>
+          <p:cNvPr id="34" name="TextBox 33"/>
+          <p:cNvSpPr txBox="1"/>
+          <p:nvPr/>
+        </p:nvSpPr>
+        <p:spPr>
+          <a:xfrm>
+            <a:off x="8412480" y="3785615"/>
+            <a:ext cx="3319272" cy="274320"/>
           </a:xfrm>
           <a:prstGeom prst="rect">
             <a:avLst/>
@@ -4319,7 +4577,7 @@
               </a:spcAft>
             </a:pPr>
             <a:r>
-              <a:rPr sz="1050" b="1">
+              <a:rPr sz="950" b="1">
                 <a:solidFill>
                   <a:srgbClr val="1B2A41"/>
                 </a:solidFill>
@@ -4328,7 +4586,7 @@
               <a:t>Act</a:t>
             </a:r>
             <a:r>
-              <a:rPr sz="1000" b="0">
+              <a:rPr sz="900" b="0">
                 <a:solidFill>
                   <a:srgbClr val="40444B"/>
                 </a:solidFill>
@@ -4341,14 +4599,14 @@
       </p:sp>
       <p:sp>
         <p:nvSpPr>
-          <p:cNvPr id="30" name="TextBox 29"/>
-          <p:cNvSpPr txBox="1"/>
-          <p:nvPr/>
-        </p:nvSpPr>
-        <p:spPr>
-          <a:xfrm>
-            <a:off x="548640" y="4160520"/>
-            <a:ext cx="11064240" cy="256032"/>
+          <p:cNvPr id="35" name="TextBox 34"/>
+          <p:cNvSpPr txBox="1"/>
+          <p:nvPr/>
+        </p:nvSpPr>
+        <p:spPr>
+          <a:xfrm>
+            <a:off x="548640" y="4114800"/>
+            <a:ext cx="11064240" cy="237744"/>
           </a:xfrm>
           <a:prstGeom prst="rect">
             <a:avLst/>
@@ -4380,13 +4638,13 @@
       </p:sp>
       <p:sp>
         <p:nvSpPr>
-          <p:cNvPr id="31" name="Chevron 30"/>
+          <p:cNvPr id="36" name="Chevron 35"/>
           <p:cNvSpPr/>
           <p:nvPr/>
         </p:nvSpPr>
         <p:spPr>
           <a:xfrm>
-            <a:off x="548640" y="4453128"/>
+            <a:off x="548640" y="4389120"/>
             <a:ext cx="2377440" cy="658368"/>
           </a:xfrm>
           <a:prstGeom prst="chevron">
@@ -4417,21 +4675,22 @@
           </a:fontRef>
         </p:style>
         <p:txBody>
-          <a:bodyPr rtlCol="0" anchor="ctr" wrap="square" lIns="237744" tIns="54864"/>
+          <a:bodyPr rtlCol="0" anchor="ctr" wrap="square" lIns="274320" rIns="128016" tIns="18288" bIns="18288"/>
           <a:lstStyle/>
           <a:p>
             <a:pPr algn="ctr"/>
             <a:r>
-              <a:rPr sz="1050" b="1">
+              <a:rPr sz="1000" b="1">
                 <a:solidFill>
                   <a:srgbClr val="FFFFFF"/>
                 </a:solidFill>
                 <a:latin typeface="Segoe UI"/>
               </a:rPr>
-              <a:t>Request</a:t>
-            </a:r>
-          </a:p>
-          <a:p>
+              <a:t>Assisted Request</a:t>
+            </a:r>
+          </a:p>
+          <a:p>
+            <a:pPr algn="ctr"/>
             <a:r>
               <a:rPr sz="800">
                 <a:solidFill>
@@ -4439,20 +4698,20 @@
                 </a:solidFill>
                 <a:latin typeface="Segoe UI"/>
               </a:rPr>
-              <a:t>maker</a:t>
-            </a:r>
-          </a:p>
-        </p:txBody>
-      </p:sp>
-      <p:sp>
-        <p:nvSpPr>
-          <p:cNvPr id="32" name="Chevron 31"/>
+              <a:t>self-service, done in minutes</a:t>
+            </a:r>
+          </a:p>
+        </p:txBody>
+      </p:sp>
+      <p:sp>
+        <p:nvSpPr>
+          <p:cNvPr id="37" name="Chevron 36"/>
           <p:cNvSpPr/>
           <p:nvPr/>
         </p:nvSpPr>
         <p:spPr>
           <a:xfrm>
-            <a:off x="2752344" y="4453128"/>
+            <a:off x="2752344" y="4389120"/>
             <a:ext cx="2377440" cy="658368"/>
           </a:xfrm>
           <a:prstGeom prst="chevron">
@@ -4483,21 +4742,22 @@
           </a:fontRef>
         </p:style>
         <p:txBody>
-          <a:bodyPr rtlCol="0" anchor="ctr" wrap="square" lIns="237744" tIns="54864"/>
+          <a:bodyPr rtlCol="0" anchor="ctr" wrap="square" lIns="274320" rIns="128016" tIns="18288" bIns="18288"/>
           <a:lstStyle/>
           <a:p>
             <a:pPr algn="ctr"/>
             <a:r>
-              <a:rPr sz="1050" b="1">
+              <a:rPr sz="1000" b="1">
                 <a:solidFill>
                   <a:srgbClr val="FFFFFF"/>
                 </a:solidFill>
                 <a:latin typeface="Segoe UI"/>
               </a:rPr>
-              <a:t>Pull request</a:t>
-            </a:r>
-          </a:p>
-          <a:p>
+              <a:t>Maker–Checker</a:t>
+            </a:r>
+          </a:p>
+          <a:p>
+            <a:pPr algn="ctr"/>
             <a:r>
               <a:rPr sz="800">
                 <a:solidFill>
@@ -4505,20 +4765,20 @@
                 </a:solidFill>
                 <a:latin typeface="Segoe UI"/>
               </a:rPr>
-              <a:t>config as code</a:t>
-            </a:r>
-          </a:p>
-        </p:txBody>
-      </p:sp>
-      <p:sp>
-        <p:nvSpPr>
-          <p:cNvPr id="33" name="Chevron 32"/>
+              <a:t>approval via pull request</a:t>
+            </a:r>
+          </a:p>
+        </p:txBody>
+      </p:sp>
+      <p:sp>
+        <p:nvSpPr>
+          <p:cNvPr id="38" name="Chevron 37"/>
           <p:cNvSpPr/>
           <p:nvPr/>
         </p:nvSpPr>
         <p:spPr>
           <a:xfrm>
-            <a:off x="4956048" y="4453128"/>
+            <a:off x="4956048" y="4389120"/>
             <a:ext cx="2377440" cy="658368"/>
           </a:xfrm>
           <a:prstGeom prst="chevron">
@@ -4527,10 +4787,12 @@
             </a:avLst>
           </a:prstGeom>
           <a:solidFill>
-            <a:srgbClr val="1B2A41"/>
+            <a:srgbClr val="FFFFFF"/>
           </a:solidFill>
-          <a:ln>
-            <a:noFill/>
+          <a:ln w="22225">
+            <a:solidFill>
+              <a:srgbClr val="2E74B5"/>
+            </a:solidFill>
           </a:ln>
           <a:effectLst/>
         </p:spPr>
@@ -4549,108 +4811,43 @@
           </a:fontRef>
         </p:style>
         <p:txBody>
-          <a:bodyPr rtlCol="0" anchor="ctr" wrap="square" lIns="237744" tIns="54864"/>
+          <a:bodyPr rtlCol="0" anchor="ctr" wrap="square" lIns="274320" rIns="128016" tIns="18288" bIns="18288"/>
           <a:lstStyle/>
           <a:p>
             <a:pPr algn="ctr"/>
             <a:r>
-              <a:rPr sz="1050" b="1">
-                <a:solidFill>
-                  <a:srgbClr val="FFFFFF"/>
-                </a:solidFill>
-                <a:latin typeface="Segoe UI"/>
-              </a:rPr>
-              <a:t>Approval</a:t>
-            </a:r>
-          </a:p>
-          <a:p>
+              <a:rPr sz="1000" b="1">
+                <a:solidFill>
+                  <a:srgbClr val="1B2A41"/>
+                </a:solidFill>
+                <a:latin typeface="Segoe UI"/>
+              </a:rPr>
+              <a:t>Git — the record</a:t>
+            </a:r>
+          </a:p>
+          <a:p>
+            <a:pPr algn="ctr"/>
             <a:r>
               <a:rPr sz="800">
                 <a:solidFill>
-                  <a:srgbClr val="C9D2DD"/>
-                </a:solidFill>
-                <a:latin typeface="Segoe UI"/>
-              </a:rPr>
-              <a:t>checker, never maker</a:t>
-            </a:r>
-          </a:p>
-        </p:txBody>
-      </p:sp>
-      <p:sp>
-        <p:nvSpPr>
-          <p:cNvPr id="34" name="Chevron 33"/>
+                  <a:srgbClr val="2E74B5"/>
+                </a:solidFill>
+                <a:latin typeface="Segoe UI"/>
+              </a:rPr>
+              <a:t>the single source of truth</a:t>
+            </a:r>
+          </a:p>
+        </p:txBody>
+      </p:sp>
+      <p:sp>
+        <p:nvSpPr>
+          <p:cNvPr id="39" name="Chevron 38"/>
           <p:cNvSpPr/>
           <p:nvPr/>
         </p:nvSpPr>
         <p:spPr>
           <a:xfrm>
-            <a:off x="7159752" y="4453128"/>
-            <a:ext cx="2377440" cy="658368"/>
-          </a:xfrm>
-          <a:prstGeom prst="chevron">
-            <a:avLst>
-              <a:gd name="adj" fmla="val 50000"/>
-            </a:avLst>
-          </a:prstGeom>
-          <a:solidFill>
-            <a:srgbClr val="1B2A41"/>
-          </a:solidFill>
-          <a:ln>
-            <a:noFill/>
-          </a:ln>
-          <a:effectLst/>
-        </p:spPr>
-        <p:style>
-          <a:lnRef idx="1">
-            <a:schemeClr val="accent1"/>
-          </a:lnRef>
-          <a:fillRef idx="3">
-            <a:schemeClr val="accent1"/>
-          </a:fillRef>
-          <a:effectRef idx="2">
-            <a:schemeClr val="accent1"/>
-          </a:effectRef>
-          <a:fontRef idx="minor">
-            <a:schemeClr val="lt1"/>
-          </a:fontRef>
-        </p:style>
-        <p:txBody>
-          <a:bodyPr rtlCol="0" anchor="ctr" wrap="square" lIns="237744" tIns="54864"/>
-          <a:lstStyle/>
-          <a:p>
-            <a:pPr algn="ctr"/>
-            <a:r>
-              <a:rPr sz="1050" b="1">
-                <a:solidFill>
-                  <a:srgbClr val="FFFFFF"/>
-                </a:solidFill>
-                <a:latin typeface="Segoe UI"/>
-              </a:rPr>
-              <a:t>Git — the record</a:t>
-            </a:r>
-          </a:p>
-          <a:p>
-            <a:r>
-              <a:rPr sz="800">
-                <a:solidFill>
-                  <a:srgbClr val="C9D2DD"/>
-                </a:solidFill>
-                <a:latin typeface="Segoe UI"/>
-              </a:rPr>
-              <a:t>main is truth</a:t>
-            </a:r>
-          </a:p>
-        </p:txBody>
-      </p:sp>
-      <p:sp>
-        <p:nvSpPr>
-          <p:cNvPr id="35" name="Chevron 34"/>
-          <p:cNvSpPr/>
-          <p:nvPr/>
-        </p:nvSpPr>
-        <p:spPr>
-          <a:xfrm>
-            <a:off x="9363456" y="4453128"/>
+            <a:off x="7159752" y="4389120"/>
             <a:ext cx="2377440" cy="658368"/>
           </a:xfrm>
           <a:prstGeom prst="chevron">
@@ -4681,12 +4878,12 @@
           </a:fontRef>
         </p:style>
         <p:txBody>
-          <a:bodyPr rtlCol="0" anchor="ctr" wrap="square" lIns="237744" tIns="54864"/>
+          <a:bodyPr rtlCol="0" anchor="ctr" wrap="square" lIns="274320" rIns="128016" tIns="18288" bIns="18288"/>
           <a:lstStyle/>
           <a:p>
             <a:pPr algn="ctr"/>
             <a:r>
-              <a:rPr sz="1050" b="1">
+              <a:rPr sz="1000" b="1">
                 <a:solidFill>
                   <a:srgbClr val="FFFFFF"/>
                 </a:solidFill>
@@ -4696,6 +4893,7 @@
             </a:r>
           </a:p>
           <a:p>
+            <a:pPr algn="ctr"/>
             <a:r>
               <a:rPr sz="800">
                 <a:solidFill>
@@ -4703,20 +4901,87 @@
                 </a:solidFill>
                 <a:latin typeface="Segoe UI"/>
               </a:rPr>
-              <a:t>read-only from git</a:t>
-            </a:r>
-          </a:p>
-        </p:txBody>
-      </p:sp>
-      <p:sp>
-        <p:nvSpPr>
-          <p:cNvPr id="36" name="TextBox 35"/>
-          <p:cNvSpPr txBox="1"/>
-          <p:nvPr/>
-        </p:nvSpPr>
-        <p:spPr>
-          <a:xfrm>
-            <a:off x="548640" y="5239512"/>
+              <a:t>no manual changes</a:t>
+            </a:r>
+          </a:p>
+        </p:txBody>
+      </p:sp>
+      <p:sp>
+        <p:nvSpPr>
+          <p:cNvPr id="40" name="Chevron 39"/>
+          <p:cNvSpPr/>
+          <p:nvPr/>
+        </p:nvSpPr>
+        <p:spPr>
+          <a:xfrm>
+            <a:off x="9363456" y="4389120"/>
+            <a:ext cx="2377440" cy="658368"/>
+          </a:xfrm>
+          <a:prstGeom prst="chevron">
+            <a:avLst>
+              <a:gd name="adj" fmla="val 50000"/>
+            </a:avLst>
+          </a:prstGeom>
+          <a:solidFill>
+            <a:srgbClr val="2E74B5"/>
+          </a:solidFill>
+          <a:ln>
+            <a:noFill/>
+          </a:ln>
+          <a:effectLst/>
+        </p:spPr>
+        <p:style>
+          <a:lnRef idx="1">
+            <a:schemeClr val="accent1"/>
+          </a:lnRef>
+          <a:fillRef idx="3">
+            <a:schemeClr val="accent1"/>
+          </a:fillRef>
+          <a:effectRef idx="2">
+            <a:schemeClr val="accent1"/>
+          </a:effectRef>
+          <a:fontRef idx="minor">
+            <a:schemeClr val="lt1"/>
+          </a:fontRef>
+        </p:style>
+        <p:txBody>
+          <a:bodyPr rtlCol="0" anchor="ctr" wrap="square" lIns="274320" rIns="128016" tIns="18288" bIns="18288"/>
+          <a:lstStyle/>
+          <a:p>
+            <a:pPr algn="ctr"/>
+            <a:r>
+              <a:rPr sz="1000" b="1">
+                <a:solidFill>
+                  <a:srgbClr val="FFFFFF"/>
+                </a:solidFill>
+                <a:latin typeface="Segoe UI"/>
+              </a:rPr>
+              <a:t>Drift detection</a:t>
+            </a:r>
+          </a:p>
+          <a:p>
+            <a:pPr algn="ctr"/>
+            <a:r>
+              <a:rPr sz="800">
+                <a:solidFill>
+                  <a:srgbClr val="C9D2DD"/>
+                </a:solidFill>
+                <a:latin typeface="Segoe UI"/>
+              </a:rPr>
+              <a:t>continuous verification</a:t>
+            </a:r>
+          </a:p>
+        </p:txBody>
+      </p:sp>
+      <p:sp>
+        <p:nvSpPr>
+          <p:cNvPr id="41" name="TextBox 40"/>
+          <p:cNvSpPr txBox="1"/>
+          <p:nvPr/>
+        </p:nvSpPr>
+        <p:spPr>
+          <a:xfrm>
+            <a:off x="548640" y="5157216"/>
             <a:ext cx="11064240" cy="292608"/>
           </a:xfrm>
           <a:prstGeom prst="rect">
@@ -4742,7 +5007,7 @@
                 </a:solidFill>
                 <a:latin typeface="Segoe UI"/>
               </a:rPr>
-              <a:t>AI proposes, humans approve, git records</a:t>
+              <a:t>AI guided, humans approve, git records</a:t>
             </a:r>
             <a:r>
               <a:rPr sz="1100" b="0">
@@ -4751,20 +5016,29 @@
                 </a:solidFill>
                 <a:latin typeface="Segoe UI"/>
               </a:rPr>
-              <a:t>  —  no one, and nothing, writes to a platform directly.</a:t>
-            </a:r>
-          </a:p>
-        </p:txBody>
-      </p:sp>
-      <p:sp>
-        <p:nvSpPr>
-          <p:cNvPr id="37" name="Rectangle 36"/>
+              <a:t>  —  no one, and nothing, writes to a platform directly. </a:t>
+            </a:r>
+            <a:r>
+              <a:rPr sz="1100" b="1">
+                <a:solidFill>
+                  <a:srgbClr val="1B2A41"/>
+                </a:solidFill>
+                <a:latin typeface="Segoe UI"/>
+              </a:rPr>
+              <a:t>Drift is impossible by construction — not fought by discipline.</a:t>
+            </a:r>
+          </a:p>
+        </p:txBody>
+      </p:sp>
+      <p:sp>
+        <p:nvSpPr>
+          <p:cNvPr id="42" name="Rectangle 41"/>
           <p:cNvSpPr/>
           <p:nvPr/>
         </p:nvSpPr>
         <p:spPr>
           <a:xfrm>
-            <a:off x="548640" y="5650992"/>
+            <a:off x="548640" y="5596128"/>
             <a:ext cx="11091672" cy="10972"/>
           </a:xfrm>
           <a:prstGeom prst="rect">
@@ -4802,13 +5076,13 @@
       </p:sp>
       <p:sp>
         <p:nvSpPr>
-          <p:cNvPr id="38" name="TextBox 37"/>
-          <p:cNvSpPr txBox="1"/>
-          <p:nvPr/>
-        </p:nvSpPr>
-        <p:spPr>
-          <a:xfrm>
-            <a:off x="548640" y="5760720"/>
+          <p:cNvPr id="43" name="TextBox 42"/>
+          <p:cNvSpPr txBox="1"/>
+          <p:nvPr/>
+        </p:nvSpPr>
+        <p:spPr>
+          <a:xfrm>
+            <a:off x="548640" y="5705856"/>
             <a:ext cx="11064240" cy="685800"/>
           </a:xfrm>
           <a:prstGeom prst="rect">
@@ -4902,7 +5176,7 @@
       </p:sp>
       <p:sp>
         <p:nvSpPr>
-          <p:cNvPr id="39" name="Rectangle 38"/>
+          <p:cNvPr id="44" name="Rectangle 43"/>
           <p:cNvSpPr/>
           <p:nvPr/>
         </p:nvSpPr>
@@ -4946,7 +5220,7 @@
       </p:sp>
       <p:sp>
         <p:nvSpPr>
-          <p:cNvPr id="40" name="TextBox 39"/>
+          <p:cNvPr id="45" name="TextBox 44"/>
           <p:cNvSpPr txBox="1"/>
           <p:nvPr/>
         </p:nvSpPr>
@@ -4985,7 +5259,7 @@
       </p:sp>
       <p:sp>
         <p:nvSpPr>
-          <p:cNvPr id="41" name="TextBox 40"/>
+          <p:cNvPr id="46" name="TextBox 45"/>
           <p:cNvSpPr txBox="1"/>
           <p:nvPr/>
         </p:nvSpPr>
@@ -5198,13 +5472,22 @@
               </a:spcAft>
             </a:pPr>
             <a:r>
+              <a:rPr sz="1150" b="1">
+                <a:solidFill>
+                  <a:srgbClr val="1B2A41"/>
+                </a:solidFill>
+                <a:latin typeface="Segoe UI"/>
+              </a:rPr>
+              <a:t>The tools kept modernising — the practice stood still</a:t>
+            </a:r>
+            <a:r>
               <a:rPr sz="1150" b="0">
                 <a:solidFill>
                   <a:srgbClr val="7A808A"/>
                 </a:solidFill>
                 <a:latin typeface="Segoe UI"/>
               </a:rPr>
-              <a:t>A decade of interrupt-driven operations — find an engineer, ask, wait — does not scale to thousands of hosts, hundreds of applications, and four monitoring tools.</a:t>
+              <a:t> — a decade invested in platforms, with no innovation in how observability itself is done: siloed automation, no continuity, while the estate it watches exploded.</a:t>
             </a:r>
           </a:p>
         </p:txBody>
@@ -5287,7 +5570,7 @@
                 </a:solidFill>
                 <a:latin typeface="Segoe UI"/>
               </a:rPr>
-              <a:t>Every request is a conversation</a:t>
+              <a:t>A sprawl of tools, no product</a:t>
             </a:r>
           </a:p>
         </p:txBody>
@@ -5326,7 +5609,7 @@
                 </a:solidFill>
                 <a:latin typeface="Segoe UI"/>
               </a:rPr>
-              <a:t>The queue is really a person — days of waiting for minutes of change.</a:t>
+              <a:t>Complex platforms grown side by side, with no singular product to orchestrate them — enabling yourself depends on finding the right engineer.</a:t>
             </a:r>
           </a:p>
         </p:txBody>
@@ -5409,7 +5692,7 @@
                 </a:solidFill>
                 <a:latin typeface="Segoe UI"/>
               </a:rPr>
-              <a:t>Documentation drifts</a:t>
+              <a:t>No knowable way to “do observability”</a:t>
             </a:r>
           </a:p>
         </p:txBody>
@@ -5448,7 +5731,7 @@
                 </a:solidFill>
                 <a:latin typeface="Segoe UI"/>
               </a:rPr>
-              <a:t>Inventories go stale the week they are written; nobody trusts them, so requests fall back to the engineers — the cycle sustains itself.</a:t>
+              <a:t>The documentation exists — Confluence pages grown stale, bloated, and burdensome. Nobody trusts them; everybody falls back to asking.</a:t>
             </a:r>
           </a:p>
         </p:txBody>
@@ -5531,7 +5814,7 @@
                 </a:solidFill>
                 <a:latin typeface="Segoe UI"/>
               </a:rPr>
-              <a:t>Approvals and audit are informal</a:t>
+              <a:t>Operations struck and stuck</a:t>
             </a:r>
           </a:p>
         </p:txBody>
@@ -5570,7 +5853,7 @@
                 </a:solidFill>
                 <a:latin typeface="Segoe UI"/>
               </a:rPr>
-              <a:t>Hand-made changes leave no record of who asked, who approved, what changed.</a:t>
+              <a:t>Massive volume, the same stale problems arriving daily. With the explosion of microservices and AI, operational fatigue is the common illness.</a:t>
             </a:r>
           </a:p>
         </p:txBody>
@@ -6126,7 +6409,7 @@
                 </a:solidFill>
                 <a:latin typeface="Segoe UI"/>
               </a:rPr>
-              <a:t>THE RETURN</a:t>
+              <a:t>VALUE ARISES NATURALLY — A NATURAL EFFECT OF THE DESIGN</a:t>
             </a:r>
           </a:p>
         </p:txBody>
@@ -6155,25 +6438,18 @@
           <a:p>
             <a:pPr algn="l">
               <a:spcAft>
-                <a:spcPts val="200"/>
-              </a:spcAft>
-            </a:pPr>
-            <a:r>
-              <a:rPr sz="1100" b="1">
+                <a:spcPts val="300"/>
+              </a:spcAft>
+            </a:pPr>
+            <a:r>
+              <a:rPr sz="1050" b="1">
                 <a:solidFill>
                   <a:srgbClr val="1B2A41"/>
                 </a:solidFill>
                 <a:latin typeface="Segoe UI"/>
               </a:rPr>
-              <a:t>~75 engineer-hours a month per 100 requests — roughly half an FTE</a:t>
-            </a:r>
-          </a:p>
-          <a:p>
-            <a:pPr algn="l">
-              <a:spcAft>
-                <a:spcPts val="200"/>
-              </a:spcAft>
-            </a:pPr>
+              <a:t>An evolution, not a fix</a:t>
+            </a:r>
             <a:r>
               <a:rPr sz="1000" b="0">
                 <a:solidFill>
@@ -6181,7 +6457,32 @@
                 </a:solidFill>
                 <a:latin typeface="Segoe UI"/>
               </a:rPr>
-              <a:t>before counting requesters’ waiting time or audit preparation; a one-quarter baseline makes it measured fact.</a:t>
+              <a:t> — engineers freed from toil back to engineering; a self-service culture; knowledge that compounds instead of decays.</a:t>
+            </a:r>
+          </a:p>
+          <a:p>
+            <a:pPr algn="l">
+              <a:spcAft>
+                <a:spcPts val="300"/>
+              </a:spcAft>
+            </a:pPr>
+            <a:r>
+              <a:rPr sz="1050" b="1">
+                <a:solidFill>
+                  <a:srgbClr val="2E74B5"/>
+                </a:solidFill>
+                <a:latin typeface="Segoe UI"/>
+              </a:rPr>
+              <a:t>The next frontier</a:t>
+            </a:r>
+            <a:r>
+              <a:rPr sz="1000" b="0">
+                <a:solidFill>
+                  <a:srgbClr val="40444B"/>
+                </a:solidFill>
+                <a:latin typeface="Segoe UI"/>
+              </a:rPr>
+              <a:t> — once decided, the second brain unlocks AI-guided operations: proactive, predictive observability, and a platform-engineering pattern the wider bank can reuse.</a:t>
             </a:r>
           </a:p>
         </p:txBody>
@@ -6914,23 +7215,23 @@
         </p:nvSpPr>
         <p:spPr>
           <a:xfrm>
-            <a:off x="1901952" y="1783080"/>
-            <a:ext cx="2249424" cy="640080"/>
-          </a:xfrm>
-          <a:prstGeom prst="rect">
-            <a:avLst/>
-          </a:prstGeom>
-          <a:noFill/>
-        </p:spPr>
-        <p:txBody>
-          <a:bodyPr wrap="square" anchor="t" lIns="0" rIns="0" tIns="0" bIns="0">
-            <a:spAutoFit/>
-          </a:bodyPr>
-          <a:lstStyle/>
-          <a:p>
-            <a:pPr algn="l">
-              <a:spcAft>
-                <a:spcPts val="100"/>
+            <a:off x="1920240" y="1755648"/>
+            <a:ext cx="2212848" cy="676656"/>
+          </a:xfrm>
+          <a:prstGeom prst="rect">
+            <a:avLst/>
+          </a:prstGeom>
+          <a:noFill/>
+        </p:spPr>
+        <p:txBody>
+          <a:bodyPr wrap="square" anchor="ctr" lIns="0" rIns="0" tIns="0" bIns="0">
+            <a:spAutoFit/>
+          </a:bodyPr>
+          <a:lstStyle/>
+          <a:p>
+            <a:pPr algn="l">
+              <a:spcAft>
+                <a:spcPts val="200"/>
               </a:spcAft>
             </a:pPr>
             <a:r>
@@ -6949,13 +7250,13 @@
                 </a:solidFill>
                 <a:latin typeface="Segoe UI"/>
               </a:rPr>
-              <a:t>Scaffolder wizard</a:t>
-            </a:r>
-          </a:p>
-          <a:p>
-            <a:pPr algn="l">
-              <a:spcAft>
-                <a:spcPts val="100"/>
+              <a:t>Guided request form</a:t>
+            </a:r>
+          </a:p>
+          <a:p>
+            <a:pPr algn="l">
+              <a:spcAft>
+                <a:spcPts val="200"/>
               </a:spcAft>
             </a:pPr>
             <a:r>
@@ -6965,7 +7266,7 @@
                 </a:solidFill>
                 <a:latin typeface="Segoe UI"/>
               </a:rPr>
-              <a:t>Template collects the form; emits a tool-neutral domain-model JSON + catalog-info.yaml.</a:t>
+              <a:t>A step-by-step wizard captures the need and produces one standard, tool-neutral request document.</a:t>
             </a:r>
           </a:p>
         </p:txBody>
@@ -7024,23 +7325,23 @@
         </p:nvSpPr>
         <p:spPr>
           <a:xfrm>
-            <a:off x="1901952" y="2587751"/>
-            <a:ext cx="2249424" cy="640080"/>
-          </a:xfrm>
-          <a:prstGeom prst="rect">
-            <a:avLst/>
-          </a:prstGeom>
-          <a:noFill/>
-        </p:spPr>
-        <p:txBody>
-          <a:bodyPr wrap="square" anchor="t" lIns="0" rIns="0" tIns="0" bIns="0">
-            <a:spAutoFit/>
-          </a:bodyPr>
-          <a:lstStyle/>
-          <a:p>
-            <a:pPr algn="l">
-              <a:spcAft>
-                <a:spcPts val="100"/>
+            <a:off x="1920240" y="2560320"/>
+            <a:ext cx="2212848" cy="676656"/>
+          </a:xfrm>
+          <a:prstGeom prst="rect">
+            <a:avLst/>
+          </a:prstGeom>
+          <a:noFill/>
+        </p:spPr>
+        <p:txBody>
+          <a:bodyPr wrap="square" anchor="ctr" lIns="0" rIns="0" tIns="0" bIns="0">
+            <a:spAutoFit/>
+          </a:bodyPr>
+          <a:lstStyle/>
+          <a:p>
+            <a:pPr algn="l">
+              <a:spcAft>
+                <a:spcPts val="200"/>
               </a:spcAft>
             </a:pPr>
             <a:r>
@@ -7059,13 +7360,13 @@
                 </a:solidFill>
                 <a:latin typeface="Segoe UI"/>
               </a:rPr>
-              <a:t>publish:bitbucketServer</a:t>
-            </a:r>
-          </a:p>
-          <a:p>
-            <a:pPr algn="l">
-              <a:spcAft>
-                <a:spcPts val="100"/>
+              <a:t>Auto-filed to git</a:t>
+            </a:r>
+          </a:p>
+          <a:p>
+            <a:pPr algn="l">
+              <a:spcAft>
+                <a:spcPts val="200"/>
               </a:spcAft>
             </a:pPr>
             <a:r>
@@ -7075,7 +7376,7 @@
                 </a:solidFill>
                 <a:latin typeface="Segoe UI"/>
               </a:rPr>
-              <a:t>All git plumbing: branch staging/&lt;env&gt;-&lt;asset&gt;, two generated commits. No human git.</a:t>
+              <a:t>The portal files the request in git automatically — its own branch, ready for review. No human touches git.</a:t>
             </a:r>
           </a:p>
         </p:txBody>
@@ -7134,23 +7435,23 @@
         </p:nvSpPr>
         <p:spPr>
           <a:xfrm>
-            <a:off x="1901952" y="3392424"/>
-            <a:ext cx="2249424" cy="603504"/>
-          </a:xfrm>
-          <a:prstGeom prst="rect">
-            <a:avLst/>
-          </a:prstGeom>
-          <a:noFill/>
-        </p:spPr>
-        <p:txBody>
-          <a:bodyPr wrap="square" anchor="t" lIns="0" rIns="0" tIns="0" bIns="0">
-            <a:spAutoFit/>
-          </a:bodyPr>
-          <a:lstStyle/>
-          <a:p>
-            <a:pPr algn="l">
-              <a:spcAft>
-                <a:spcPts val="100"/>
+            <a:off x="1920240" y="3364992"/>
+            <a:ext cx="2212848" cy="640080"/>
+          </a:xfrm>
+          <a:prstGeom prst="rect">
+            <a:avLst/>
+          </a:prstGeom>
+          <a:noFill/>
+        </p:spPr>
+        <p:txBody>
+          <a:bodyPr wrap="square" anchor="ctr" lIns="0" rIns="0" tIns="0" bIns="0">
+            <a:spAutoFit/>
+          </a:bodyPr>
+          <a:lstStyle/>
+          <a:p>
+            <a:pPr algn="l">
+              <a:spcAft>
+                <a:spcPts val="200"/>
               </a:spcAft>
             </a:pPr>
             <a:r>
@@ -7175,7 +7476,7 @@
           <a:p>
             <a:pPr algn="l">
               <a:spcAft>
-                <a:spcPts val="100"/>
+                <a:spcPts val="200"/>
               </a:spcAft>
             </a:pPr>
             <a:r>
@@ -7367,7 +7668,7 @@
                 </a:solidFill>
                 <a:latin typeface="Segoe UI"/>
               </a:rPr>
-              <a:t>BITBUCKET</a:t>
+              <a:t>BITBUCKET · THE RECORD</a:t>
             </a:r>
           </a:p>
         </p:txBody>
@@ -7426,23 +7727,23 @@
         </p:nvSpPr>
         <p:spPr>
           <a:xfrm>
-            <a:off x="4846320" y="1783080"/>
-            <a:ext cx="1975103" cy="676656"/>
-          </a:xfrm>
-          <a:prstGeom prst="rect">
-            <a:avLst/>
-          </a:prstGeom>
-          <a:noFill/>
-        </p:spPr>
-        <p:txBody>
-          <a:bodyPr wrap="square" anchor="t" lIns="0" rIns="0" tIns="0" bIns="0">
-            <a:spAutoFit/>
-          </a:bodyPr>
-          <a:lstStyle/>
-          <a:p>
-            <a:pPr algn="l">
-              <a:spcAft>
-                <a:spcPts val="100"/>
+            <a:off x="4864608" y="1755648"/>
+            <a:ext cx="1938528" cy="713232"/>
+          </a:xfrm>
+          <a:prstGeom prst="rect">
+            <a:avLst/>
+          </a:prstGeom>
+          <a:noFill/>
+        </p:spPr>
+        <p:txBody>
+          <a:bodyPr wrap="square" anchor="ctr" lIns="0" rIns="0" tIns="0" bIns="0">
+            <a:spAutoFit/>
+          </a:bodyPr>
+          <a:lstStyle/>
+          <a:p>
+            <a:pPr algn="l">
+              <a:spcAft>
+                <a:spcPts val="200"/>
               </a:spcAft>
             </a:pPr>
             <a:r>
@@ -7461,13 +7762,13 @@
                 </a:solidFill>
                 <a:latin typeface="Segoe UI"/>
               </a:rPr>
-              <a:t>PR → merge to main</a:t>
-            </a:r>
-          </a:p>
-          <a:p>
-            <a:pPr algn="l">
-              <a:spcAft>
-                <a:spcPts val="100"/>
+              <a:t>Approve &amp; merge</a:t>
+            </a:r>
+          </a:p>
+          <a:p>
+            <a:pPr algn="l">
+              <a:spcAft>
+                <a:spcPts val="200"/>
               </a:spcAft>
             </a:pPr>
             <a:r>
@@ -7477,7 +7778,7 @@
                 </a:solidFill>
                 <a:latin typeface="Segoe UI"/>
               </a:rPr>
-              <a:t>main = production truth; staging deleted after merge. The merge IS the approval; git IS the audit trail (who, what, when).</a:t>
+              <a:t>The approver merges the change — the merge IS the approval, and git keeps the permanent record: who, what, when.</a:t>
             </a:r>
           </a:p>
         </p:txBody>
@@ -7536,23 +7837,23 @@
         </p:nvSpPr>
         <p:spPr>
           <a:xfrm>
-            <a:off x="4846320" y="2642615"/>
-            <a:ext cx="1975103" cy="621792"/>
-          </a:xfrm>
-          <a:prstGeom prst="rect">
-            <a:avLst/>
-          </a:prstGeom>
-          <a:noFill/>
-        </p:spPr>
-        <p:txBody>
-          <a:bodyPr wrap="square" anchor="t" lIns="0" rIns="0" tIns="0" bIns="0">
-            <a:spAutoFit/>
-          </a:bodyPr>
-          <a:lstStyle/>
-          <a:p>
-            <a:pPr algn="l">
-              <a:spcAft>
-                <a:spcPts val="100"/>
+            <a:off x="4864608" y="2615184"/>
+            <a:ext cx="1938528" cy="658368"/>
+          </a:xfrm>
+          <a:prstGeom prst="rect">
+            <a:avLst/>
+          </a:prstGeom>
+          <a:noFill/>
+        </p:spPr>
+        <p:txBody>
+          <a:bodyPr wrap="square" anchor="ctr" lIns="0" rIns="0" tIns="0" bIns="0">
+            <a:spAutoFit/>
+          </a:bodyPr>
+          <a:lstStyle/>
+          <a:p>
+            <a:pPr algn="l">
+              <a:spcAft>
+                <a:spcPts val="200"/>
               </a:spcAft>
             </a:pPr>
             <a:r>
@@ -7571,13 +7872,13 @@
                 </a:solidFill>
                 <a:latin typeface="Segoe UI"/>
               </a:rPr>
-              <a:t>repo:refs_changed</a:t>
-            </a:r>
-          </a:p>
-          <a:p>
-            <a:pPr algn="l">
-              <a:spcAft>
-                <a:spcPts val="100"/>
+              <a:t>Approval triggers automation</a:t>
+            </a:r>
+          </a:p>
+          <a:p>
+            <a:pPr algn="l">
+              <a:spcAft>
+                <a:spcPts val="200"/>
               </a:spcAft>
             </a:pPr>
             <a:r>
@@ -7587,7 +7888,7 @@
                 </a:solidFill>
                 <a:latin typeface="Segoe UI"/>
               </a:rPr>
-              <a:t>Push webhook fires on main with fromHash/toHash — the only bridge between phases.</a:t>
+              <a:t>The moment a change lands, git signals the automation — no scheduler, no queue, no hand-off.</a:t>
             </a:r>
           </a:p>
         </p:txBody>
@@ -7646,37 +7947,28 @@
         </p:nvSpPr>
         <p:spPr>
           <a:xfrm>
-            <a:off x="4846320" y="3447288"/>
-            <a:ext cx="1975103" cy="548640"/>
-          </a:xfrm>
-          <a:prstGeom prst="rect">
-            <a:avLst/>
-          </a:prstGeom>
-          <a:noFill/>
-        </p:spPr>
-        <p:txBody>
-          <a:bodyPr wrap="square" anchor="t" lIns="0" rIns="0" tIns="0" bIns="0">
-            <a:spAutoFit/>
-          </a:bodyPr>
-          <a:lstStyle/>
-          <a:p>
-            <a:pPr algn="l">
-              <a:spcAft>
-                <a:spcPts val="100"/>
+            <a:off x="4864608" y="3419856"/>
+            <a:ext cx="1938528" cy="585216"/>
+          </a:xfrm>
+          <a:prstGeom prst="rect">
+            <a:avLst/>
+          </a:prstGeom>
+          <a:noFill/>
+        </p:spPr>
+        <p:txBody>
+          <a:bodyPr wrap="square" anchor="ctr" lIns="0" rIns="0" tIns="0" bIns="0">
+            <a:spAutoFit/>
+          </a:bodyPr>
+          <a:lstStyle/>
+          <a:p>
+            <a:pPr algn="l">
+              <a:spcAft>
+                <a:spcPts val="200"/>
               </a:spcAft>
             </a:pPr>
             <a:r>
               <a:rPr sz="950" b="1">
                 <a:solidFill>
-                  <a:srgbClr val="2E74B5"/>
-                </a:solidFill>
-                <a:latin typeface="Segoe UI"/>
-              </a:rPr>
-              <a:t> · </a:t>
-            </a:r>
-            <a:r>
-              <a:rPr sz="950" b="1">
-                <a:solidFill>
                   <a:srgbClr val="1B2A41"/>
                 </a:solidFill>
                 <a:latin typeface="Segoe UI"/>
@@ -7687,7 +7979,7 @@
           <a:p>
             <a:pPr algn="l">
               <a:spcAft>
-                <a:spcPts val="100"/>
+                <a:spcPts val="200"/>
               </a:spcAft>
             </a:pPr>
             <a:r>
@@ -7697,7 +7989,7 @@
                 </a:solidFill>
                 <a:latin typeface="Segoe UI"/>
               </a:rPr>
-              <a:t>dxuim-config · elk-watchers · solarwinds-config — same folder + metadata conventions.</a:t>
+              <a:t>Every tool’s configuration in its own repository, under one shared convention.</a:t>
             </a:r>
           </a:p>
         </p:txBody>
@@ -7879,7 +8171,7 @@
                 </a:solidFill>
                 <a:latin typeface="Segoe UI"/>
               </a:rPr>
-              <a:t>ANSIBLE</a:t>
+              <a:t>ANSIBLE · AUTOMATION</a:t>
             </a:r>
           </a:p>
         </p:txBody>
@@ -7938,23 +8230,23 @@
         </p:nvSpPr>
         <p:spPr>
           <a:xfrm>
-            <a:off x="7516367" y="1783080"/>
-            <a:ext cx="2066543" cy="749808"/>
-          </a:xfrm>
-          <a:prstGeom prst="rect">
-            <a:avLst/>
-          </a:prstGeom>
-          <a:noFill/>
-        </p:spPr>
-        <p:txBody>
-          <a:bodyPr wrap="square" anchor="t" lIns="0" rIns="0" tIns="0" bIns="0">
-            <a:spAutoFit/>
-          </a:bodyPr>
-          <a:lstStyle/>
-          <a:p>
-            <a:pPr algn="l">
-              <a:spcAft>
-                <a:spcPts val="100"/>
+            <a:off x="7534655" y="1755648"/>
+            <a:ext cx="2029967" cy="786384"/>
+          </a:xfrm>
+          <a:prstGeom prst="rect">
+            <a:avLst/>
+          </a:prstGeom>
+          <a:noFill/>
+        </p:spPr>
+        <p:txBody>
+          <a:bodyPr wrap="square" anchor="ctr" lIns="0" rIns="0" tIns="0" bIns="0">
+            <a:spAutoFit/>
+          </a:bodyPr>
+          <a:lstStyle/>
+          <a:p>
+            <a:pPr algn="l">
+              <a:spcAft>
+                <a:spcPts val="200"/>
               </a:spcAft>
             </a:pPr>
             <a:r>
@@ -7973,13 +8265,13 @@
                 </a:solidFill>
                 <a:latin typeface="Segoe UI"/>
               </a:rPr>
-              <a:t>No clone — REST reads</a:t>
-            </a:r>
-          </a:p>
-          <a:p>
-            <a:pPr algn="l">
-              <a:spcAft>
-                <a:spcPts val="100"/>
+              <a:t>Reads the approved change</a:t>
+            </a:r>
+          </a:p>
+          <a:p>
+            <a:pPr algn="l">
+              <a:spcAft>
+                <a:spcPts val="200"/>
               </a:spcAft>
             </a:pPr>
             <a:r>
@@ -7989,7 +8281,7 @@
                 </a:solidFill>
                 <a:latin typeface="Segoe UI"/>
               </a:rPr>
-              <a:t>compare/changes + raw file reads via Bitbucket API. Three triggers: webhook range · single file · full re-sync (drift repair).</a:t>
+              <a:t>Automation reads exactly what was approved — one change, one file, or a full re-sync to repair drift.</a:t>
             </a:r>
           </a:p>
         </p:txBody>
@@ -8048,23 +8340,23 @@
         </p:nvSpPr>
         <p:spPr>
           <a:xfrm>
-            <a:off x="7516367" y="2715768"/>
-            <a:ext cx="2066543" cy="676656"/>
-          </a:xfrm>
-          <a:prstGeom prst="rect">
-            <a:avLst/>
-          </a:prstGeom>
-          <a:noFill/>
-        </p:spPr>
-        <p:txBody>
-          <a:bodyPr wrap="square" anchor="t" lIns="0" rIns="0" tIns="0" bIns="0">
-            <a:spAutoFit/>
-          </a:bodyPr>
-          <a:lstStyle/>
-          <a:p>
-            <a:pPr algn="l">
-              <a:spcAft>
-                <a:spcPts val="100"/>
+            <a:off x="7534655" y="2688336"/>
+            <a:ext cx="2029967" cy="713232"/>
+          </a:xfrm>
+          <a:prstGeom prst="rect">
+            <a:avLst/>
+          </a:prstGeom>
+          <a:noFill/>
+        </p:spPr>
+        <p:txBody>
+          <a:bodyPr wrap="square" anchor="ctr" lIns="0" rIns="0" tIns="0" bIns="0">
+            <a:spAutoFit/>
+          </a:bodyPr>
+          <a:lstStyle/>
+          <a:p>
+            <a:pPr algn="l">
+              <a:spcAft>
+                <a:spcPts val="200"/>
               </a:spcAft>
             </a:pPr>
             <a:r>
@@ -8089,7 +8381,7 @@
           <a:p>
             <a:pPr algn="l">
               <a:spcAft>
-                <a:spcPts val="100"/>
+                <a:spcPts val="200"/>
               </a:spcAft>
             </a:pPr>
             <a:r>
@@ -8099,7 +8391,7 @@
                 </a:solidFill>
                 <a:latin typeface="Segoe UI"/>
               </a:rPr>
-              <a:t>Neutral JSON → per-tool format; metadata block stripped; idempotent PUT, 3 retries; Vault creds, no_log on secrets.</a:t>
+              <a:t>The standard request is translated into each tool’s own language and applied — safe to re-run, retried on failure, credentials vaulted.</a:t>
             </a:r>
           </a:p>
         </p:txBody>
@@ -8158,37 +8450,28 @@
         </p:nvSpPr>
         <p:spPr>
           <a:xfrm>
-            <a:off x="7516367" y="3575303"/>
-            <a:ext cx="2066543" cy="420623"/>
-          </a:xfrm>
-          <a:prstGeom prst="rect">
-            <a:avLst/>
-          </a:prstGeom>
-          <a:noFill/>
-        </p:spPr>
-        <p:txBody>
-          <a:bodyPr wrap="square" anchor="t" lIns="0" rIns="0" tIns="0" bIns="0">
-            <a:spAutoFit/>
-          </a:bodyPr>
-          <a:lstStyle/>
-          <a:p>
-            <a:pPr algn="l">
-              <a:spcAft>
-                <a:spcPts val="100"/>
+            <a:off x="7534655" y="3547872"/>
+            <a:ext cx="2029967" cy="457199"/>
+          </a:xfrm>
+          <a:prstGeom prst="rect">
+            <a:avLst/>
+          </a:prstGeom>
+          <a:noFill/>
+        </p:spPr>
+        <p:txBody>
+          <a:bodyPr wrap="square" anchor="ctr" lIns="0" rIns="0" tIns="0" bIns="0">
+            <a:spAutoFit/>
+          </a:bodyPr>
+          <a:lstStyle/>
+          <a:p>
+            <a:pPr algn="l">
+              <a:spcAft>
+                <a:spcPts val="200"/>
               </a:spcAft>
             </a:pPr>
             <a:r>
               <a:rPr sz="950" b="1">
                 <a:solidFill>
-                  <a:srgbClr val="2E74B5"/>
-                </a:solidFill>
-                <a:latin typeface="Segoe UI"/>
-              </a:rPr>
-              <a:t> · </a:t>
-            </a:r>
-            <a:r>
-              <a:rPr sz="950" b="1">
-                <a:solidFill>
                   <a:srgbClr val="1B2A41"/>
                 </a:solidFill>
                 <a:latin typeface="Segoe UI"/>
@@ -8199,7 +8482,7 @@
           <a:p>
             <a:pPr algn="l">
               <a:spcAft>
-                <a:spcPts val="100"/>
+                <a:spcPts val="200"/>
               </a:spcAft>
             </a:pPr>
             <a:r>
@@ -8209,7 +8492,7 @@
                 </a:solidFill>
                 <a:latin typeface="Segoe UI"/>
               </a:rPr>
-              <a:t>The roles contain zero git-write calls.</a:t>
+              <a:t>Automation can read the record — it can never rewrite it.</a:t>
             </a:r>
           </a:p>
         </p:txBody>
@@ -8395,7 +8678,7 @@
         </p:nvSpPr>
         <p:spPr>
           <a:xfrm>
-            <a:off x="10232136" y="1737360"/>
+            <a:off x="10232136" y="1856232"/>
             <a:ext cx="201168" cy="201168"/>
           </a:xfrm>
           <a:prstGeom prst="roundRect">
@@ -8450,23 +8733,23 @@
         </p:nvSpPr>
         <p:spPr>
           <a:xfrm>
-            <a:off x="10479024" y="1719072"/>
-            <a:ext cx="1042415" cy="475488"/>
-          </a:xfrm>
-          <a:prstGeom prst="rect">
-            <a:avLst/>
-          </a:prstGeom>
-          <a:noFill/>
-        </p:spPr>
-        <p:txBody>
-          <a:bodyPr wrap="square" anchor="t" lIns="0" rIns="0" tIns="0" bIns="0">
-            <a:spAutoFit/>
-          </a:bodyPr>
-          <a:lstStyle/>
-          <a:p>
-            <a:pPr algn="l">
-              <a:spcAft>
-                <a:spcPts val="0"/>
+            <a:off x="10488168" y="1700784"/>
+            <a:ext cx="1024128" cy="512064"/>
+          </a:xfrm>
+          <a:prstGeom prst="rect">
+            <a:avLst/>
+          </a:prstGeom>
+          <a:noFill/>
+        </p:spPr>
+        <p:txBody>
+          <a:bodyPr wrap="square" anchor="ctr" lIns="0" rIns="0" tIns="0" bIns="0">
+            <a:spAutoFit/>
+          </a:bodyPr>
+          <a:lstStyle/>
+          <a:p>
+            <a:pPr algn="l">
+              <a:spcAft>
+                <a:spcPts val="100"/>
               </a:spcAft>
             </a:pPr>
             <a:r>
@@ -8482,17 +8765,17 @@
           <a:p>
             <a:pPr algn="l">
               <a:spcAft>
-                <a:spcPts val="0"/>
-              </a:spcAft>
-            </a:pPr>
-            <a:r>
-              <a:rPr sz="650" b="0">
+                <a:spcPts val="100"/>
+              </a:spcAft>
+            </a:pPr>
+            <a:r>
+              <a:rPr sz="700" b="0">
                 <a:solidFill>
                   <a:srgbClr val="40444B"/>
                 </a:solidFill>
-                <a:latin typeface="Consolas"/>
-              </a:rPr>
-              <a:t>PUT /uimapi/probes/…/config</a:t>
+                <a:latin typeface="Segoe UI"/>
+              </a:rPr>
+              <a:t>infrastructure</a:t>
             </a:r>
           </a:p>
         </p:txBody>
@@ -8551,7 +8834,7 @@
         </p:nvSpPr>
         <p:spPr>
           <a:xfrm>
-            <a:off x="10232136" y="2359152"/>
+            <a:off x="10232136" y="2478024"/>
             <a:ext cx="201168" cy="201168"/>
           </a:xfrm>
           <a:prstGeom prst="roundRect">
@@ -8606,23 +8889,23 @@
         </p:nvSpPr>
         <p:spPr>
           <a:xfrm>
-            <a:off x="10479024" y="2340864"/>
-            <a:ext cx="1042415" cy="475488"/>
-          </a:xfrm>
-          <a:prstGeom prst="rect">
-            <a:avLst/>
-          </a:prstGeom>
-          <a:noFill/>
-        </p:spPr>
-        <p:txBody>
-          <a:bodyPr wrap="square" anchor="t" lIns="0" rIns="0" tIns="0" bIns="0">
-            <a:spAutoFit/>
-          </a:bodyPr>
-          <a:lstStyle/>
-          <a:p>
-            <a:pPr algn="l">
-              <a:spcAft>
-                <a:spcPts val="0"/>
+            <a:off x="10488168" y="2322576"/>
+            <a:ext cx="1024128" cy="512064"/>
+          </a:xfrm>
+          <a:prstGeom prst="rect">
+            <a:avLst/>
+          </a:prstGeom>
+          <a:noFill/>
+        </p:spPr>
+        <p:txBody>
+          <a:bodyPr wrap="square" anchor="ctr" lIns="0" rIns="0" tIns="0" bIns="0">
+            <a:spAutoFit/>
+          </a:bodyPr>
+          <a:lstStyle/>
+          <a:p>
+            <a:pPr algn="l">
+              <a:spcAft>
+                <a:spcPts val="100"/>
               </a:spcAft>
             </a:pPr>
             <a:r>
@@ -8638,17 +8921,17 @@
           <a:p>
             <a:pPr algn="l">
               <a:spcAft>
-                <a:spcPts val="0"/>
-              </a:spcAft>
-            </a:pPr>
-            <a:r>
-              <a:rPr sz="650" b="0">
+                <a:spcPts val="100"/>
+              </a:spcAft>
+            </a:pPr>
+            <a:r>
+              <a:rPr sz="700" b="0">
                 <a:solidFill>
                   <a:srgbClr val="40444B"/>
                 </a:solidFill>
-                <a:latin typeface="Consolas"/>
-              </a:rPr>
-              <a:t>ES Watcher API</a:t>
+                <a:latin typeface="Segoe UI"/>
+              </a:rPr>
+              <a:t>logs &amp; search</a:t>
             </a:r>
           </a:p>
         </p:txBody>
@@ -8707,7 +8990,7 @@
         </p:nvSpPr>
         <p:spPr>
           <a:xfrm>
-            <a:off x="10232136" y="2980944"/>
+            <a:off x="10232136" y="3099816"/>
             <a:ext cx="201168" cy="201168"/>
           </a:xfrm>
           <a:prstGeom prst="roundRect">
@@ -8762,23 +9045,23 @@
         </p:nvSpPr>
         <p:spPr>
           <a:xfrm>
-            <a:off x="10479024" y="2962656"/>
-            <a:ext cx="1042415" cy="475488"/>
-          </a:xfrm>
-          <a:prstGeom prst="rect">
-            <a:avLst/>
-          </a:prstGeom>
-          <a:noFill/>
-        </p:spPr>
-        <p:txBody>
-          <a:bodyPr wrap="square" anchor="t" lIns="0" rIns="0" tIns="0" bIns="0">
-            <a:spAutoFit/>
-          </a:bodyPr>
-          <a:lstStyle/>
-          <a:p>
-            <a:pPr algn="l">
-              <a:spcAft>
-                <a:spcPts val="0"/>
+            <a:off x="10488168" y="2944368"/>
+            <a:ext cx="1024128" cy="512064"/>
+          </a:xfrm>
+          <a:prstGeom prst="rect">
+            <a:avLst/>
+          </a:prstGeom>
+          <a:noFill/>
+        </p:spPr>
+        <p:txBody>
+          <a:bodyPr wrap="square" anchor="ctr" lIns="0" rIns="0" tIns="0" bIns="0">
+            <a:spAutoFit/>
+          </a:bodyPr>
+          <a:lstStyle/>
+          <a:p>
+            <a:pPr algn="l">
+              <a:spcAft>
+                <a:spcPts val="100"/>
               </a:spcAft>
             </a:pPr>
             <a:r>
@@ -8794,17 +9077,17 @@
           <a:p>
             <a:pPr algn="l">
               <a:spcAft>
-                <a:spcPts val="0"/>
-              </a:spcAft>
-            </a:pPr>
-            <a:r>
-              <a:rPr sz="650" b="0">
+                <a:spcPts val="100"/>
+              </a:spcAft>
+            </a:pPr>
+            <a:r>
+              <a:rPr sz="700" b="0">
                 <a:solidFill>
                   <a:srgbClr val="40444B"/>
                 </a:solidFill>
-                <a:latin typeface="Consolas"/>
-              </a:rPr>
-              <a:t>Orion API · planned</a:t>
+                <a:latin typeface="Segoe UI"/>
+              </a:rPr>
+              <a:t>network · planned</a:t>
             </a:r>
           </a:p>
         </p:txBody>
@@ -8863,7 +9146,7 @@
         </p:nvSpPr>
         <p:spPr>
           <a:xfrm>
-            <a:off x="10232136" y="3602736"/>
+            <a:off x="10232136" y="3721608"/>
             <a:ext cx="201168" cy="201168"/>
           </a:xfrm>
           <a:prstGeom prst="roundRect">
@@ -8918,23 +9201,23 @@
         </p:nvSpPr>
         <p:spPr>
           <a:xfrm>
-            <a:off x="10479024" y="3584448"/>
-            <a:ext cx="1042415" cy="475488"/>
-          </a:xfrm>
-          <a:prstGeom prst="rect">
-            <a:avLst/>
-          </a:prstGeom>
-          <a:noFill/>
-        </p:spPr>
-        <p:txBody>
-          <a:bodyPr wrap="square" anchor="t" lIns="0" rIns="0" tIns="0" bIns="0">
-            <a:spAutoFit/>
-          </a:bodyPr>
-          <a:lstStyle/>
-          <a:p>
-            <a:pPr algn="l">
-              <a:spcAft>
-                <a:spcPts val="0"/>
+            <a:off x="10488168" y="3566160"/>
+            <a:ext cx="1024128" cy="512064"/>
+          </a:xfrm>
+          <a:prstGeom prst="rect">
+            <a:avLst/>
+          </a:prstGeom>
+          <a:noFill/>
+        </p:spPr>
+        <p:txBody>
+          <a:bodyPr wrap="square" anchor="ctr" lIns="0" rIns="0" tIns="0" bIns="0">
+            <a:spAutoFit/>
+          </a:bodyPr>
+          <a:lstStyle/>
+          <a:p>
+            <a:pPr algn="l">
+              <a:spcAft>
+                <a:spcPts val="100"/>
               </a:spcAft>
             </a:pPr>
             <a:r>
@@ -8950,17 +9233,17 @@
           <a:p>
             <a:pPr algn="l">
               <a:spcAft>
-                <a:spcPts val="0"/>
-              </a:spcAft>
-            </a:pPr>
-            <a:r>
-              <a:rPr sz="650" b="0">
+                <a:spcPts val="100"/>
+              </a:spcAft>
+            </a:pPr>
+            <a:r>
+              <a:rPr sz="700" b="0">
                 <a:solidFill>
                   <a:srgbClr val="40444B"/>
                 </a:solidFill>
-                <a:latin typeface="Consolas"/>
-              </a:rPr>
-              <a:t>events → HPSM</a:t>
+                <a:latin typeface="Segoe UI"/>
+              </a:rPr>
+              <a:t>events → tickets</a:t>
             </a:r>
           </a:p>
         </p:txBody>
@@ -9061,16 +9344,16 @@
         </p:nvSpPr>
         <p:spPr>
           <a:xfrm>
-            <a:off x="2121408" y="4242816"/>
-            <a:ext cx="9418320" cy="256032"/>
-          </a:xfrm>
-          <a:prstGeom prst="rect">
-            <a:avLst/>
-          </a:prstGeom>
-          <a:noFill/>
-        </p:spPr>
-        <p:txBody>
-          <a:bodyPr wrap="square" anchor="t" lIns="0" rIns="0" tIns="0" bIns="0">
+            <a:off x="2121408" y="4187952"/>
+            <a:ext cx="9326880" cy="347472"/>
+          </a:xfrm>
+          <a:prstGeom prst="rect">
+            <a:avLst/>
+          </a:prstGeom>
+          <a:noFill/>
+        </p:spPr>
+        <p:txBody>
+          <a:bodyPr wrap="square" anchor="ctr" lIns="0" rIns="0" tIns="0" bIns="0">
             <a:spAutoFit/>
           </a:bodyPr>
           <a:lstStyle/>
@@ -9087,7 +9370,7 @@
                 </a:solidFill>
                 <a:latin typeface="Segoe UI"/>
               </a:rPr>
-              <a:t>8 · notify_requester → Backstage Notifications</a:t>
+              <a:t>8 · Requester notified — every time</a:t>
             </a:r>
             <a:r>
               <a:rPr sz="850" b="0">
@@ -9096,7 +9379,7 @@
                 </a:solidFill>
                 <a:latin typeface="Segoe UI"/>
               </a:rPr>
-              <a:t>  —  shared role, every slice reports back: success live; failure = critical severity + failed job, so git and reality never disagree silently.</a:t>
+              <a:t>  —  success reported live; failure reported loudly and flagged critical, so the record and reality can never disagree silently.</a:t>
             </a:r>
           </a:p>
         </p:txBody>
@@ -9199,16 +9482,16 @@
         </p:nvSpPr>
         <p:spPr>
           <a:xfrm>
-            <a:off x="2121408" y="4654296"/>
-            <a:ext cx="9418320" cy="384048"/>
-          </a:xfrm>
-          <a:prstGeom prst="rect">
-            <a:avLst/>
-          </a:prstGeom>
-          <a:noFill/>
-        </p:spPr>
-        <p:txBody>
-          <a:bodyPr wrap="square" anchor="t" lIns="0" rIns="0" tIns="0" bIns="0">
+            <a:off x="2121408" y="4608576"/>
+            <a:ext cx="9326880" cy="457200"/>
+          </a:xfrm>
+          <a:prstGeom prst="rect">
+            <a:avLst/>
+          </a:prstGeom>
+          <a:noFill/>
+        </p:spPr>
+        <p:txBody>
+          <a:bodyPr wrap="square" anchor="ctr" lIns="0" rIns="0" tIns="0" bIns="0">
             <a:spAutoFit/>
           </a:bodyPr>
           <a:lstStyle/>
@@ -9234,7 +9517,7 @@
                 </a:solidFill>
                 <a:latin typeface="Segoe UI"/>
               </a:rPr>
-              <a:t>A scheduled reconciliation reads the live config from each target API and diffs it against main. Any configuration mutated directly on a tool surfaces as drift: the platform owner is notified in Backstage, the Reports service shows the delta, and the fix is governed — an idempotent full re-sync or an approved change. Never a silent overwrite.</a:t>
+              <a:t>A scheduled check reads the live configuration back from every tool and compares it with the record. Anything changed directly on a tool surfaces as drift: the owner is notified, the Reports service shows the difference, and the fix stays governed — a safe re-sync or an approved change. Never a silent overwrite.</a:t>
             </a:r>
           </a:p>
         </p:txBody>
@@ -9337,7 +9620,7 @@
         </p:nvSpPr>
         <p:spPr>
           <a:xfrm>
-            <a:off x="713232" y="5230368"/>
+            <a:off x="713232" y="5257800"/>
             <a:ext cx="237744" cy="237744"/>
           </a:xfrm>
           <a:prstGeom prst="roundRect">
@@ -9392,16 +9675,16 @@
         </p:nvSpPr>
         <p:spPr>
           <a:xfrm>
-            <a:off x="1042415" y="5175504"/>
-            <a:ext cx="10515600" cy="420624"/>
-          </a:xfrm>
-          <a:prstGeom prst="rect">
-            <a:avLst/>
-          </a:prstGeom>
-          <a:noFill/>
-        </p:spPr>
-        <p:txBody>
-          <a:bodyPr wrap="square" anchor="t" lIns="0" rIns="0" tIns="0" bIns="0">
+            <a:off x="1042415" y="5120640"/>
+            <a:ext cx="10469880" cy="512064"/>
+          </a:xfrm>
+          <a:prstGeom prst="rect">
+            <a:avLst/>
+          </a:prstGeom>
+          <a:noFill/>
+        </p:spPr>
+        <p:txBody>
+          <a:bodyPr wrap="square" anchor="ctr" lIns="0" rIns="0" tIns="0" bIns="0">
             <a:spAutoFit/>
           </a:bodyPr>
           <a:lstStyle/>
@@ -9427,7 +9710,7 @@
                 </a:solidFill>
                 <a:latin typeface="Segoe UI"/>
               </a:rPr>
-              <a:t>Docs-as-code in the same repos; catalog-info.yaml registers every asset; Backstage renders documentation from the very files Ansible applies — so it cannot drift from reality.</a:t>
+              <a:t>Documentation lives beside the configuration and is rendered straight from it — every asset registered with its owner, dashboards, and docs attached. It cannot drift from reality.</a:t>
             </a:r>
           </a:p>
         </p:txBody>
@@ -9475,7 +9758,7 @@
                 </a:solidFill>
                 <a:latin typeface="Segoe UI"/>
               </a:rPr>
-              <a:t>data flows one way (Backstage writes git; Ansible reads git, writes tools)  ·  idempotent everywhere (desired state, not diffs)  ·  empty ≠ delete</a:t>
+              <a:t>data flows one way — the portal writes the record, automation reads it  ·  every action is safe to repeat  ·  nothing is ever deleted implicitly</a:t>
             </a:r>
           </a:p>
         </p:txBody>
@@ -9532,7 +9815,7 @@
         </p:nvSpPr>
         <p:spPr>
           <a:xfrm>
-            <a:off x="713232" y="6016752"/>
+            <a:off x="713232" y="6021324"/>
             <a:ext cx="274320" cy="274320"/>
           </a:xfrm>
           <a:prstGeom prst="roundRect">
@@ -9587,16 +9870,16 @@
         </p:nvSpPr>
         <p:spPr>
           <a:xfrm>
-            <a:off x="1115568" y="5925312"/>
-            <a:ext cx="10424160" cy="475488"/>
-          </a:xfrm>
-          <a:prstGeom prst="rect">
-            <a:avLst/>
-          </a:prstGeom>
-          <a:noFill/>
-        </p:spPr>
-        <p:txBody>
-          <a:bodyPr wrap="square" anchor="t" lIns="0" rIns="0" tIns="0" bIns="0">
+            <a:off x="1115568" y="5888736"/>
+            <a:ext cx="10378440" cy="530352"/>
+          </a:xfrm>
+          <a:prstGeom prst="rect">
+            <a:avLst/>
+          </a:prstGeom>
+          <a:noFill/>
+        </p:spPr>
+        <p:txBody>
+          <a:bodyPr wrap="square" anchor="ctr" lIns="0" rIns="0" tIns="0" bIns="0">
             <a:spAutoFit/>
           </a:bodyPr>
           <a:lstStyle/>
@@ -9989,7 +10272,7 @@
         <p:spPr>
           <a:xfrm>
             <a:off x="777240" y="2103120"/>
-            <a:ext cx="841248" cy="457200"/>
+            <a:ext cx="877824" cy="457200"/>
           </a:xfrm>
           <a:prstGeom prst="rect">
             <a:avLst/>
@@ -10034,8 +10317,8 @@
         </p:nvSpPr>
         <p:spPr>
           <a:xfrm>
-            <a:off x="832103" y="2157984"/>
-            <a:ext cx="731520" cy="365760"/>
+            <a:off x="813816" y="2130551"/>
+            <a:ext cx="804672" cy="402336"/>
           </a:xfrm>
           <a:prstGeom prst="rect">
             <a:avLst/>
@@ -10054,14 +10337,13 @@
               </a:spcAft>
             </a:pPr>
             <a:r>
-              <a:rPr sz="800" b="1">
+              <a:rPr sz="750" b="1">
                 <a:solidFill>
                   <a:srgbClr val="3E4C63"/>
                 </a:solidFill>
                 <a:latin typeface="Segoe UI"/>
               </a:rPr>
-              <a:t>Ping / call
-engineer</a:t>
+              <a:t>Ping / call engineer</a:t>
             </a:r>
           </a:p>
         </p:txBody>
@@ -10074,7 +10356,7 @@
         </p:nvSpPr>
         <p:spPr>
           <a:xfrm>
-            <a:off x="1627632" y="2212848"/>
+            <a:off x="1659636" y="2212848"/>
             <a:ext cx="182880" cy="274320"/>
           </a:xfrm>
           <a:prstGeom prst="rect">
@@ -10113,8 +10395,8 @@
         </p:nvSpPr>
         <p:spPr>
           <a:xfrm>
-            <a:off x="1801368" y="2103120"/>
-            <a:ext cx="841248" cy="457200"/>
+            <a:off x="1819655" y="2103120"/>
+            <a:ext cx="877824" cy="457200"/>
           </a:xfrm>
           <a:prstGeom prst="rect">
             <a:avLst/>
@@ -10159,8 +10441,8 @@
         </p:nvSpPr>
         <p:spPr>
           <a:xfrm>
-            <a:off x="1856232" y="2157984"/>
-            <a:ext cx="731520" cy="365760"/>
+            <a:off x="1856231" y="2130551"/>
+            <a:ext cx="804672" cy="402336"/>
           </a:xfrm>
           <a:prstGeom prst="rect">
             <a:avLst/>
@@ -10179,14 +10461,13 @@
               </a:spcAft>
             </a:pPr>
             <a:r>
-              <a:rPr sz="800" b="1">
+              <a:rPr sz="750" b="1">
                 <a:solidFill>
                   <a:srgbClr val="3E4C63"/>
                 </a:solidFill>
                 <a:latin typeface="Segoe UI"/>
               </a:rPr>
-              <a:t>Confluence
-free-form page</a:t>
+              <a:t>Confluence page</a:t>
             </a:r>
           </a:p>
         </p:txBody>
@@ -10199,7 +10480,7 @@
         </p:nvSpPr>
         <p:spPr>
           <a:xfrm>
-            <a:off x="2651760" y="2212848"/>
+            <a:off x="2702051" y="2212848"/>
             <a:ext cx="182880" cy="274320"/>
           </a:xfrm>
           <a:prstGeom prst="rect">
@@ -10238,8 +10519,8 @@
         </p:nvSpPr>
         <p:spPr>
           <a:xfrm>
-            <a:off x="2825496" y="2103120"/>
-            <a:ext cx="841248" cy="457200"/>
+            <a:off x="2862072" y="2103120"/>
+            <a:ext cx="877824" cy="457200"/>
           </a:xfrm>
           <a:prstGeom prst="rect">
             <a:avLst/>
@@ -10284,8 +10565,8 @@
         </p:nvSpPr>
         <p:spPr>
           <a:xfrm>
-            <a:off x="2880360" y="2157984"/>
-            <a:ext cx="731520" cy="365760"/>
+            <a:off x="2898648" y="2130551"/>
+            <a:ext cx="804672" cy="402336"/>
           </a:xfrm>
           <a:prstGeom prst="rect">
             <a:avLst/>
@@ -10304,14 +10585,13 @@
               </a:spcAft>
             </a:pPr>
             <a:r>
-              <a:rPr sz="800" b="1">
+              <a:rPr sz="750" b="1">
                 <a:solidFill>
                   <a:srgbClr val="3E4C63"/>
                 </a:solidFill>
                 <a:latin typeface="Segoe UI"/>
               </a:rPr>
-              <a:t>Jira ticket
-raised</a:t>
+              <a:t>Jira ticket</a:t>
             </a:r>
           </a:p>
         </p:txBody>
@@ -10324,7 +10604,7 @@
         </p:nvSpPr>
         <p:spPr>
           <a:xfrm>
-            <a:off x="3675888" y="2212848"/>
+            <a:off x="3744468" y="2212848"/>
             <a:ext cx="182880" cy="274320"/>
           </a:xfrm>
           <a:prstGeom prst="rect">
@@ -10363,8 +10643,8 @@
         </p:nvSpPr>
         <p:spPr>
           <a:xfrm>
-            <a:off x="3849624" y="2103120"/>
-            <a:ext cx="841248" cy="457200"/>
+            <a:off x="3904487" y="2103120"/>
+            <a:ext cx="877824" cy="457200"/>
           </a:xfrm>
           <a:prstGeom prst="rect">
             <a:avLst/>
@@ -10409,8 +10689,8 @@
         </p:nvSpPr>
         <p:spPr>
           <a:xfrm>
-            <a:off x="3904488" y="2157984"/>
-            <a:ext cx="731520" cy="365760"/>
+            <a:off x="3941063" y="2130551"/>
+            <a:ext cx="804672" cy="402336"/>
           </a:xfrm>
           <a:prstGeom prst="rect">
             <a:avLst/>
@@ -10429,14 +10709,13 @@
               </a:spcAft>
             </a:pPr>
             <a:r>
-              <a:rPr sz="800" b="1">
+              <a:rPr sz="750" b="1">
                 <a:solidFill>
                   <a:srgbClr val="3E4C63"/>
                 </a:solidFill>
                 <a:latin typeface="Segoe UI"/>
               </a:rPr>
-              <a:t>Manual
-implementation</a:t>
+              <a:t>Manual change</a:t>
             </a:r>
           </a:p>
         </p:txBody>
@@ -10449,7 +10728,7 @@
         </p:nvSpPr>
         <p:spPr>
           <a:xfrm>
-            <a:off x="4700016" y="2212848"/>
+            <a:off x="4786883" y="2212848"/>
             <a:ext cx="182880" cy="274320"/>
           </a:xfrm>
           <a:prstGeom prst="rect">
@@ -10488,8 +10767,8 @@
         </p:nvSpPr>
         <p:spPr>
           <a:xfrm>
-            <a:off x="4873752" y="2103120"/>
-            <a:ext cx="841248" cy="457200"/>
+            <a:off x="4946903" y="2103120"/>
+            <a:ext cx="877824" cy="457200"/>
           </a:xfrm>
           <a:prstGeom prst="rect">
             <a:avLst/>
@@ -10534,8 +10813,8 @@
         </p:nvSpPr>
         <p:spPr>
           <a:xfrm>
-            <a:off x="4928616" y="2157984"/>
-            <a:ext cx="731520" cy="365760"/>
+            <a:off x="4983479" y="2130551"/>
+            <a:ext cx="804672" cy="402336"/>
           </a:xfrm>
           <a:prstGeom prst="rect">
             <a:avLst/>
@@ -10554,14 +10833,13 @@
               </a:spcAft>
             </a:pPr>
             <a:r>
-              <a:rPr sz="800" b="1">
+              <a:rPr sz="750" b="1">
                 <a:solidFill>
                   <a:srgbClr val="3E4C63"/>
                 </a:solidFill>
                 <a:latin typeface="Segoe UI"/>
               </a:rPr>
-              <a:t>Slow review
-&amp; approval</a:t>
+              <a:t>Slow approval</a:t>
             </a:r>
           </a:p>
         </p:txBody>
@@ -10639,7 +10917,7 @@
                 </a:solidFill>
                 <a:latin typeface="Segoe UI"/>
               </a:rPr>
-              <a:t>Requests start by pinging or calling an engineer — the queue is a person</a:t>
+              <a:t>Observability is the supporting cast — and the punching bag when incidents hit: essential to everyone, invested in by no one</a:t>
             </a:r>
           </a:p>
         </p:txBody>
@@ -10717,7 +10995,7 @@
                 </a:solidFill>
                 <a:latin typeface="Segoe UI"/>
               </a:rPr>
-              <a:t>Requirements land in a massive, free-flow Confluence page with no structure (before 2022: Word documents — maintenance was a nightmare)</a:t>
+              <a:t>The tools modernised into a bigger stack of boxes — complexity grew with the organisation, but no continuity of automation grew with it</a:t>
             </a:r>
           </a:p>
         </p:txBody>
@@ -10795,7 +11073,7 @@
                 </a:solidFill>
                 <a:latin typeface="Segoe UI"/>
               </a:rPr>
-              <a:t>A Jira ticket hands the work to a platform engineer — repetitive, and massive at volume</a:t>
+              <a:t>The human IS the workflow: every request, change, and answer routes through an engineer by hand (Confluence page → Jira ticket → manual work)</a:t>
             </a:r>
           </a:p>
         </p:txBody>
@@ -10873,7 +11151,7 @@
                 </a:solidFill>
                 <a:latin typeface="Segoe UI"/>
               </a:rPr>
-              <a:t>Approval workflow and reviews consume days of elapsed time</a:t>
+              <a:t>The dependency is now dangerous: even SME engineers make mistakes — fatigue turns expertise into risk</a:t>
             </a:r>
           </a:p>
         </p:txBody>
@@ -10951,7 +11229,7 @@
                 </a:solidFill>
                 <a:latin typeface="Segoe UI"/>
               </a:rPr>
-              <a:t>Senior engineers are consumed by documentation upkeep and liaising — little capacity left for capacity management and improvement</a:t>
+              <a:t>No human can keep up with the scaling rule — volume grows with the estate; the team does not</a:t>
             </a:r>
           </a:p>
         </p:txBody>
@@ -11137,8 +11415,8 @@
         </p:nvSpPr>
         <p:spPr>
           <a:xfrm>
-            <a:off x="6665976" y="2157984"/>
-            <a:ext cx="950976" cy="365760"/>
+            <a:off x="6647688" y="2130551"/>
+            <a:ext cx="987551" cy="402336"/>
           </a:xfrm>
           <a:prstGeom prst="rect">
             <a:avLst/>
@@ -11157,7 +11435,7 @@
               </a:spcAft>
             </a:pPr>
             <a:r>
-              <a:rPr sz="800" b="1">
+              <a:rPr sz="750" b="1">
                 <a:solidFill>
                   <a:srgbClr val="FFFFFF"/>
                 </a:solidFill>
@@ -11259,8 +11537,8 @@
         </p:nvSpPr>
         <p:spPr>
           <a:xfrm>
-            <a:off x="7918704" y="2157984"/>
-            <a:ext cx="950976" cy="365760"/>
+            <a:off x="7900416" y="2130551"/>
+            <a:ext cx="987551" cy="402336"/>
           </a:xfrm>
           <a:prstGeom prst="rect">
             <a:avLst/>
@@ -11279,7 +11557,7 @@
               </a:spcAft>
             </a:pPr>
             <a:r>
-              <a:rPr sz="800" b="1">
+              <a:rPr sz="750" b="1">
                 <a:solidFill>
                   <a:srgbClr val="FFFFFF"/>
                 </a:solidFill>
@@ -11381,8 +11659,8 @@
         </p:nvSpPr>
         <p:spPr>
           <a:xfrm>
-            <a:off x="9171432" y="2157984"/>
-            <a:ext cx="950976" cy="365760"/>
+            <a:off x="9153144" y="2130551"/>
+            <a:ext cx="987551" cy="402336"/>
           </a:xfrm>
           <a:prstGeom prst="rect">
             <a:avLst/>
@@ -11401,7 +11679,7 @@
               </a:spcAft>
             </a:pPr>
             <a:r>
-              <a:rPr sz="800" b="1">
+              <a:rPr sz="750" b="1">
                 <a:solidFill>
                   <a:srgbClr val="FFFFFF"/>
                 </a:solidFill>
@@ -11503,8 +11781,8 @@
         </p:nvSpPr>
         <p:spPr>
           <a:xfrm>
-            <a:off x="10424160" y="2157984"/>
-            <a:ext cx="950976" cy="365760"/>
+            <a:off x="10405872" y="2130551"/>
+            <a:ext cx="987551" cy="402336"/>
           </a:xfrm>
           <a:prstGeom prst="rect">
             <a:avLst/>
@@ -11523,7 +11801,7 @@
               </a:spcAft>
             </a:pPr>
             <a:r>
-              <a:rPr sz="800" b="1">
+              <a:rPr sz="750" b="1">
                 <a:solidFill>
                   <a:srgbClr val="FFFFFF"/>
                 </a:solidFill>

</xml_diff>